<commit_message>
Fix diagram rendering in PowerPoint; ship deck fonts
Slide 11's UML hand-off arrows and verify loop were built with pptxgenjs
`line` shapes. A horizontal or vertical line serialises to a zero-height or
zero-width extent, which LibreOffice tolerates but PowerPoint frequently
drops or misdraws — six such shapes were in the file.

Replace them with K.connector(), which builds shafts from rectangles and
heads from triangles, and hand-builds dashes rather than stroking a thin
rect (which would outline all four sides). No degenerate extents remain in
the deck and no `line` geometry is emitted at all.

Swap Consolas for Courier New in the UML operation compartments; Consolas is
not present on macOS.

PowerPoint does not carry fonts with the file, so a machine without
Montserrat loses the whole weight hierarchy — headings fall back to a
default sans and the deck reads flat. Ship the five weights in assets/fonts/
with install instructions.
</commit_message>
<xml_diff>
--- a/out/Internship_Exit_Presentation_Stewart.pptx
+++ b/out/Internship_Exit_Presentation_Stewart.pptx
@@ -3846,9 +3846,9 @@
                 <a:solidFill>
                   <a:srgbClr val="43464A"/>
                 </a:solidFill>
-                <a:latin typeface="Consolas" pitchFamily="34" charset="0"/>
-                <a:ea typeface="Consolas" pitchFamily="34" charset="-122"/>
-                <a:cs typeface="Consolas" pitchFamily="34" charset="-120"/>
+                <a:latin typeface="Courier New" pitchFamily="34" charset="0"/>
+                <a:ea typeface="Courier New" pitchFamily="34" charset="-122"/>
+                <a:cs typeface="Courier New" pitchFamily="34" charset="-120"/>
               </a:rPr>
               <a:t>findVulnerable()</a:t>
             </a:r>
@@ -3885,9 +3885,9 @@
                 <a:solidFill>
                   <a:srgbClr val="43464A"/>
                 </a:solidFill>
-                <a:latin typeface="Consolas" pitchFamily="34" charset="0"/>
-                <a:ea typeface="Consolas" pitchFamily="34" charset="-122"/>
-                <a:cs typeface="Consolas" pitchFamily="34" charset="-120"/>
+                <a:latin typeface="Courier New" pitchFamily="34" charset="0"/>
+                <a:ea typeface="Courier New" pitchFamily="34" charset="-122"/>
+                <a:cs typeface="Courier New" pitchFamily="34" charset="-120"/>
               </a:rPr>
               <a:t>checkReachable()</a:t>
             </a:r>
@@ -3924,9 +3924,9 @@
                 <a:solidFill>
                   <a:srgbClr val="43464A"/>
                 </a:solidFill>
-                <a:latin typeface="Consolas" pitchFamily="34" charset="0"/>
-                <a:ea typeface="Consolas" pitchFamily="34" charset="-122"/>
-                <a:cs typeface="Consolas" pitchFamily="34" charset="-120"/>
+                <a:latin typeface="Courier New" pitchFamily="34" charset="0"/>
+                <a:ea typeface="Courier New" pitchFamily="34" charset="-122"/>
+                <a:cs typeface="Courier New" pitchFamily="34" charset="-120"/>
               </a:rPr>
               <a:t>markResolved()</a:t>
             </a:r>
@@ -4098,9 +4098,9 @@
                 <a:solidFill>
                   <a:srgbClr val="43464A"/>
                 </a:solidFill>
-                <a:latin typeface="Consolas" pitchFamily="34" charset="0"/>
-                <a:ea typeface="Consolas" pitchFamily="34" charset="-122"/>
-                <a:cs typeface="Consolas" pitchFamily="34" charset="-120"/>
+                <a:latin typeface="Courier New" pitchFamily="34" charset="0"/>
+                <a:ea typeface="Courier New" pitchFamily="34" charset="-122"/>
+                <a:cs typeface="Courier New" pitchFamily="34" charset="-120"/>
               </a:rPr>
               <a:t>proposeFix()</a:t>
             </a:r>
@@ -4137,9 +4137,9 @@
                 <a:solidFill>
                   <a:srgbClr val="43464A"/>
                 </a:solidFill>
-                <a:latin typeface="Consolas" pitchFamily="34" charset="0"/>
-                <a:ea typeface="Consolas" pitchFamily="34" charset="-122"/>
-                <a:cs typeface="Consolas" pitchFamily="34" charset="-120"/>
+                <a:latin typeface="Courier New" pitchFamily="34" charset="0"/>
+                <a:ea typeface="Courier New" pitchFamily="34" charset="-122"/>
+                <a:cs typeface="Courier New" pitchFamily="34" charset="-120"/>
               </a:rPr>
               <a:t>openBranch()</a:t>
             </a:r>
@@ -4176,9 +4176,9 @@
                 <a:solidFill>
                   <a:srgbClr val="43464A"/>
                 </a:solidFill>
-                <a:latin typeface="Consolas" pitchFamily="34" charset="0"/>
-                <a:ea typeface="Consolas" pitchFamily="34" charset="-122"/>
-                <a:cs typeface="Consolas" pitchFamily="34" charset="-120"/>
+                <a:latin typeface="Courier New" pitchFamily="34" charset="0"/>
+                <a:ea typeface="Courier New" pitchFamily="34" charset="-122"/>
+                <a:cs typeface="Courier New" pitchFamily="34" charset="-120"/>
               </a:rPr>
               <a:t>runTests()</a:t>
             </a:r>
@@ -4350,9 +4350,9 @@
                 <a:solidFill>
                   <a:srgbClr val="43464A"/>
                 </a:solidFill>
-                <a:latin typeface="Consolas" pitchFamily="34" charset="0"/>
-                <a:ea typeface="Consolas" pitchFamily="34" charset="-122"/>
-                <a:cs typeface="Consolas" pitchFamily="34" charset="-120"/>
+                <a:latin typeface="Courier New" pitchFamily="34" charset="0"/>
+                <a:ea typeface="Courier New" pitchFamily="34" charset="-122"/>
+                <a:cs typeface="Courier New" pitchFamily="34" charset="-120"/>
               </a:rPr>
               <a:t>recordFinding()</a:t>
             </a:r>
@@ -4389,9 +4389,9 @@
                 <a:solidFill>
                   <a:srgbClr val="43464A"/>
                 </a:solidFill>
-                <a:latin typeface="Consolas" pitchFamily="34" charset="0"/>
-                <a:ea typeface="Consolas" pitchFamily="34" charset="-122"/>
-                <a:cs typeface="Consolas" pitchFamily="34" charset="-120"/>
+                <a:latin typeface="Courier New" pitchFamily="34" charset="0"/>
+                <a:ea typeface="Courier New" pitchFamily="34" charset="-122"/>
+                <a:cs typeface="Courier New" pitchFamily="34" charset="-120"/>
               </a:rPr>
               <a:t>trackState()</a:t>
             </a:r>
@@ -4428,9 +4428,9 @@
                 <a:solidFill>
                   <a:srgbClr val="43464A"/>
                 </a:solidFill>
-                <a:latin typeface="Consolas" pitchFamily="34" charset="0"/>
-                <a:ea typeface="Consolas" pitchFamily="34" charset="-122"/>
-                <a:cs typeface="Consolas" pitchFamily="34" charset="-120"/>
+                <a:latin typeface="Courier New" pitchFamily="34" charset="0"/>
+                <a:ea typeface="Courier New" pitchFamily="34" charset="-122"/>
+                <a:cs typeface="Courier New" pitchFamily="34" charset="-120"/>
               </a:rPr>
               <a:t>auditTrail()</a:t>
             </a:r>
@@ -4602,9 +4602,9 @@
                 <a:solidFill>
                   <a:srgbClr val="43464A"/>
                 </a:solidFill>
-                <a:latin typeface="Consolas" pitchFamily="34" charset="0"/>
-                <a:ea typeface="Consolas" pitchFamily="34" charset="-122"/>
-                <a:cs typeface="Consolas" pitchFamily="34" charset="-120"/>
+                <a:latin typeface="Courier New" pitchFamily="34" charset="0"/>
+                <a:ea typeface="Courier New" pitchFamily="34" charset="-122"/>
+                <a:cs typeface="Courier New" pitchFamily="34" charset="-120"/>
               </a:rPr>
               <a:t>watchFeeds()</a:t>
             </a:r>
@@ -4641,9 +4641,9 @@
                 <a:solidFill>
                   <a:srgbClr val="43464A"/>
                 </a:solidFill>
-                <a:latin typeface="Consolas" pitchFamily="34" charset="0"/>
-                <a:ea typeface="Consolas" pitchFamily="34" charset="-122"/>
-                <a:cs typeface="Consolas" pitchFamily="34" charset="-120"/>
+                <a:latin typeface="Courier New" pitchFamily="34" charset="0"/>
+                <a:ea typeface="Courier New" pitchFamily="34" charset="-122"/>
+                <a:cs typeface="Courier New" pitchFamily="34" charset="-120"/>
               </a:rPr>
               <a:t>raiseAlert()</a:t>
             </a:r>
@@ -4680,9 +4680,9 @@
                 <a:solidFill>
                   <a:srgbClr val="43464A"/>
                 </a:solidFill>
-                <a:latin typeface="Consolas" pitchFamily="34" charset="0"/>
-                <a:ea typeface="Consolas" pitchFamily="34" charset="-122"/>
-                <a:cs typeface="Consolas" pitchFamily="34" charset="-120"/>
+                <a:latin typeface="Courier New" pitchFamily="34" charset="0"/>
+                <a:ea typeface="Courier New" pitchFamily="34" charset="-122"/>
+                <a:cs typeface="Courier New" pitchFamily="34" charset="-120"/>
               </a:rPr>
               <a:t>reportDrift()</a:t>
             </a:r>
@@ -4698,25 +4698,41 @@
         </p:nvSpPr>
         <p:spPr>
           <a:xfrm>
-            <a:off x="3044952" y="3639312"/>
-            <a:ext cx="485546" cy="0"/>
-          </a:xfrm>
-          <a:prstGeom prst="line">
-            <a:avLst/>
-          </a:prstGeom>
-          <a:noFill/>
-          <a:ln w="19050">
-            <a:solidFill>
-              <a:srgbClr val="43464A"/>
-            </a:solidFill>
-            <a:prstDash val="solid"/>
-            <a:tailEnd type="triangle"/>
-          </a:ln>
-        </p:spPr>
-      </p:sp>
-      <p:sp>
-        <p:nvSpPr>
-          <p:cNvPr id="39" name="Text 36"/>
+            <a:off x="3044952" y="3629254"/>
+            <a:ext cx="394106" cy="20117"/>
+          </a:xfrm>
+          <a:prstGeom prst="rect">
+            <a:avLst/>
+          </a:prstGeom>
+          <a:solidFill>
+            <a:srgbClr val="43464A"/>
+          </a:solidFill>
+          <a:ln/>
+        </p:spPr>
+      </p:sp>
+      <p:sp>
+        <p:nvSpPr>
+          <p:cNvPr id="39" name="Shape 36"/>
+          <p:cNvSpPr/>
+          <p:nvPr/>
+        </p:nvSpPr>
+        <p:spPr>
+          <a:xfrm rot="5400000">
+            <a:off x="3439058" y="3579876"/>
+            <a:ext cx="91440" cy="118872"/>
+          </a:xfrm>
+          <a:prstGeom prst="triangle">
+            <a:avLst/>
+          </a:prstGeom>
+          <a:solidFill>
+            <a:srgbClr val="43464A"/>
+          </a:solidFill>
+          <a:ln/>
+        </p:spPr>
+      </p:sp>
+      <p:sp>
+        <p:nvSpPr>
+          <p:cNvPr id="40" name="Text 37"/>
           <p:cNvSpPr txBox="1"/>
           <p:nvPr/>
         </p:nvSpPr>
@@ -4758,31 +4774,47 @@
       </p:sp>
       <p:sp>
         <p:nvSpPr>
-          <p:cNvPr id="40" name="Shape 37"/>
-          <p:cNvSpPr/>
-          <p:nvPr/>
-        </p:nvSpPr>
-        <p:spPr>
-          <a:xfrm>
-            <a:off x="5853074" y="3639312"/>
-            <a:ext cx="485546" cy="0"/>
-          </a:xfrm>
-          <a:prstGeom prst="line">
-            <a:avLst/>
-          </a:prstGeom>
-          <a:noFill/>
-          <a:ln w="19050">
-            <a:solidFill>
-              <a:srgbClr val="43464A"/>
-            </a:solidFill>
-            <a:prstDash val="solid"/>
-            <a:tailEnd type="triangle"/>
-          </a:ln>
-        </p:spPr>
-      </p:sp>
-      <p:sp>
-        <p:nvSpPr>
-          <p:cNvPr id="41" name="Text 38"/>
+          <p:cNvPr id="41" name="Shape 38"/>
+          <p:cNvSpPr/>
+          <p:nvPr/>
+        </p:nvSpPr>
+        <p:spPr>
+          <a:xfrm>
+            <a:off x="5853074" y="3629254"/>
+            <a:ext cx="394106" cy="20117"/>
+          </a:xfrm>
+          <a:prstGeom prst="rect">
+            <a:avLst/>
+          </a:prstGeom>
+          <a:solidFill>
+            <a:srgbClr val="43464A"/>
+          </a:solidFill>
+          <a:ln/>
+        </p:spPr>
+      </p:sp>
+      <p:sp>
+        <p:nvSpPr>
+          <p:cNvPr id="42" name="Shape 39"/>
+          <p:cNvSpPr/>
+          <p:nvPr/>
+        </p:nvSpPr>
+        <p:spPr>
+          <a:xfrm rot="5400000">
+            <a:off x="6247181" y="3579876"/>
+            <a:ext cx="91440" cy="118872"/>
+          </a:xfrm>
+          <a:prstGeom prst="triangle">
+            <a:avLst/>
+          </a:prstGeom>
+          <a:solidFill>
+            <a:srgbClr val="43464A"/>
+          </a:solidFill>
+          <a:ln/>
+        </p:spPr>
+      </p:sp>
+      <p:sp>
+        <p:nvSpPr>
+          <p:cNvPr id="43" name="Text 40"/>
           <p:cNvSpPr txBox="1"/>
           <p:nvPr/>
         </p:nvSpPr>
@@ -4844,31 +4876,47 @@
       </p:sp>
       <p:sp>
         <p:nvSpPr>
-          <p:cNvPr id="42" name="Shape 39"/>
-          <p:cNvSpPr/>
-          <p:nvPr/>
-        </p:nvSpPr>
-        <p:spPr>
-          <a:xfrm>
-            <a:off x="8661197" y="3639312"/>
-            <a:ext cx="485546" cy="0"/>
-          </a:xfrm>
-          <a:prstGeom prst="line">
-            <a:avLst/>
-          </a:prstGeom>
-          <a:noFill/>
-          <a:ln w="19050">
-            <a:solidFill>
-              <a:srgbClr val="43464A"/>
-            </a:solidFill>
-            <a:prstDash val="solid"/>
-            <a:tailEnd type="triangle"/>
-          </a:ln>
-        </p:spPr>
-      </p:sp>
-      <p:sp>
-        <p:nvSpPr>
-          <p:cNvPr id="43" name="Text 40"/>
+          <p:cNvPr id="44" name="Shape 41"/>
+          <p:cNvSpPr/>
+          <p:nvPr/>
+        </p:nvSpPr>
+        <p:spPr>
+          <a:xfrm>
+            <a:off x="8661197" y="3629254"/>
+            <a:ext cx="394106" cy="20117"/>
+          </a:xfrm>
+          <a:prstGeom prst="rect">
+            <a:avLst/>
+          </a:prstGeom>
+          <a:solidFill>
+            <a:srgbClr val="43464A"/>
+          </a:solidFill>
+          <a:ln/>
+        </p:spPr>
+      </p:sp>
+      <p:sp>
+        <p:nvSpPr>
+          <p:cNvPr id="45" name="Shape 42"/>
+          <p:cNvSpPr/>
+          <p:nvPr/>
+        </p:nvSpPr>
+        <p:spPr>
+          <a:xfrm rot="5400000">
+            <a:off x="9055303" y="3579876"/>
+            <a:ext cx="91440" cy="118872"/>
+          </a:xfrm>
+          <a:prstGeom prst="triangle">
+            <a:avLst/>
+          </a:prstGeom>
+          <a:solidFill>
+            <a:srgbClr val="43464A"/>
+          </a:solidFill>
+          <a:ln/>
+        </p:spPr>
+      </p:sp>
+      <p:sp>
+        <p:nvSpPr>
+          <p:cNvPr id="46" name="Text 43"/>
           <p:cNvSpPr txBox="1"/>
           <p:nvPr/>
         </p:nvSpPr>
@@ -4930,78 +4978,1547 @@
       </p:sp>
       <p:sp>
         <p:nvSpPr>
-          <p:cNvPr id="44" name="Shape 41"/>
-          <p:cNvSpPr/>
-          <p:nvPr/>
-        </p:nvSpPr>
-        <p:spPr>
-          <a:xfrm>
-            <a:off x="10308031" y="4407408"/>
-            <a:ext cx="0" cy="420624"/>
-          </a:xfrm>
-          <a:prstGeom prst="line">
-            <a:avLst/>
-          </a:prstGeom>
-          <a:noFill/>
-          <a:ln w="19050">
-            <a:solidFill>
-              <a:srgbClr val="942838"/>
-            </a:solidFill>
-            <a:prstDash val="dash"/>
-          </a:ln>
-        </p:spPr>
-      </p:sp>
-      <p:sp>
-        <p:nvSpPr>
-          <p:cNvPr id="45" name="Shape 42"/>
-          <p:cNvSpPr/>
-          <p:nvPr/>
-        </p:nvSpPr>
-        <p:spPr>
-          <a:xfrm>
-            <a:off x="1883664" y="4828032"/>
-            <a:ext cx="8424367" cy="0"/>
-          </a:xfrm>
-          <a:prstGeom prst="line">
-            <a:avLst/>
-          </a:prstGeom>
-          <a:noFill/>
-          <a:ln w="19050">
-            <a:solidFill>
-              <a:srgbClr val="942838"/>
-            </a:solidFill>
-            <a:prstDash val="dash"/>
-          </a:ln>
-        </p:spPr>
-      </p:sp>
-      <p:sp>
-        <p:nvSpPr>
-          <p:cNvPr id="46" name="Shape 43"/>
-          <p:cNvSpPr/>
-          <p:nvPr/>
-        </p:nvSpPr>
-        <p:spPr>
-          <a:xfrm>
-            <a:off x="1883664" y="4407408"/>
-            <a:ext cx="0" cy="420624"/>
-          </a:xfrm>
-          <a:prstGeom prst="line">
-            <a:avLst/>
-          </a:prstGeom>
-          <a:noFill/>
-          <a:ln w="19050">
-            <a:solidFill>
-              <a:srgbClr val="942838"/>
-            </a:solidFill>
-            <a:prstDash val="dash"/>
-            <a:headEnd type="triangle"/>
-            <a:tailEnd type="triangle"/>
-          </a:ln>
-        </p:spPr>
-      </p:sp>
-      <p:sp>
-        <p:nvSpPr>
-          <p:cNvPr id="47" name="Text 44"/>
+          <p:cNvPr id="47" name="Shape 44"/>
+          <p:cNvSpPr/>
+          <p:nvPr/>
+        </p:nvSpPr>
+        <p:spPr>
+          <a:xfrm>
+            <a:off x="10297973" y="4407408"/>
+            <a:ext cx="20117" cy="68580"/>
+          </a:xfrm>
+          <a:prstGeom prst="rect">
+            <a:avLst/>
+          </a:prstGeom>
+          <a:solidFill>
+            <a:srgbClr val="942838"/>
+          </a:solidFill>
+          <a:ln/>
+        </p:spPr>
+      </p:sp>
+      <p:sp>
+        <p:nvSpPr>
+          <p:cNvPr id="48" name="Shape 45"/>
+          <p:cNvSpPr/>
+          <p:nvPr/>
+        </p:nvSpPr>
+        <p:spPr>
+          <a:xfrm>
+            <a:off x="10297973" y="4526280"/>
+            <a:ext cx="20117" cy="68580"/>
+          </a:xfrm>
+          <a:prstGeom prst="rect">
+            <a:avLst/>
+          </a:prstGeom>
+          <a:solidFill>
+            <a:srgbClr val="942838"/>
+          </a:solidFill>
+          <a:ln/>
+        </p:spPr>
+      </p:sp>
+      <p:sp>
+        <p:nvSpPr>
+          <p:cNvPr id="49" name="Shape 46"/>
+          <p:cNvSpPr/>
+          <p:nvPr/>
+        </p:nvSpPr>
+        <p:spPr>
+          <a:xfrm>
+            <a:off x="10297973" y="4645152"/>
+            <a:ext cx="20117" cy="68580"/>
+          </a:xfrm>
+          <a:prstGeom prst="rect">
+            <a:avLst/>
+          </a:prstGeom>
+          <a:solidFill>
+            <a:srgbClr val="942838"/>
+          </a:solidFill>
+          <a:ln/>
+        </p:spPr>
+      </p:sp>
+      <p:sp>
+        <p:nvSpPr>
+          <p:cNvPr id="50" name="Shape 47"/>
+          <p:cNvSpPr/>
+          <p:nvPr/>
+        </p:nvSpPr>
+        <p:spPr>
+          <a:xfrm>
+            <a:off x="10297973" y="4764024"/>
+            <a:ext cx="20117" cy="64008"/>
+          </a:xfrm>
+          <a:prstGeom prst="rect">
+            <a:avLst/>
+          </a:prstGeom>
+          <a:solidFill>
+            <a:srgbClr val="942838"/>
+          </a:solidFill>
+          <a:ln/>
+        </p:spPr>
+      </p:sp>
+      <p:sp>
+        <p:nvSpPr>
+          <p:cNvPr id="51" name="Shape 48"/>
+          <p:cNvSpPr/>
+          <p:nvPr/>
+        </p:nvSpPr>
+        <p:spPr>
+          <a:xfrm>
+            <a:off x="1883664" y="4817974"/>
+            <a:ext cx="68580" cy="20117"/>
+          </a:xfrm>
+          <a:prstGeom prst="rect">
+            <a:avLst/>
+          </a:prstGeom>
+          <a:solidFill>
+            <a:srgbClr val="942838"/>
+          </a:solidFill>
+          <a:ln/>
+        </p:spPr>
+      </p:sp>
+      <p:sp>
+        <p:nvSpPr>
+          <p:cNvPr id="52" name="Shape 49"/>
+          <p:cNvSpPr/>
+          <p:nvPr/>
+        </p:nvSpPr>
+        <p:spPr>
+          <a:xfrm>
+            <a:off x="2002536" y="4817974"/>
+            <a:ext cx="68580" cy="20117"/>
+          </a:xfrm>
+          <a:prstGeom prst="rect">
+            <a:avLst/>
+          </a:prstGeom>
+          <a:solidFill>
+            <a:srgbClr val="942838"/>
+          </a:solidFill>
+          <a:ln/>
+        </p:spPr>
+      </p:sp>
+      <p:sp>
+        <p:nvSpPr>
+          <p:cNvPr id="53" name="Shape 50"/>
+          <p:cNvSpPr/>
+          <p:nvPr/>
+        </p:nvSpPr>
+        <p:spPr>
+          <a:xfrm>
+            <a:off x="2121408" y="4817974"/>
+            <a:ext cx="68580" cy="20117"/>
+          </a:xfrm>
+          <a:prstGeom prst="rect">
+            <a:avLst/>
+          </a:prstGeom>
+          <a:solidFill>
+            <a:srgbClr val="942838"/>
+          </a:solidFill>
+          <a:ln/>
+        </p:spPr>
+      </p:sp>
+      <p:sp>
+        <p:nvSpPr>
+          <p:cNvPr id="54" name="Shape 51"/>
+          <p:cNvSpPr/>
+          <p:nvPr/>
+        </p:nvSpPr>
+        <p:spPr>
+          <a:xfrm>
+            <a:off x="2240280" y="4817974"/>
+            <a:ext cx="68580" cy="20117"/>
+          </a:xfrm>
+          <a:prstGeom prst="rect">
+            <a:avLst/>
+          </a:prstGeom>
+          <a:solidFill>
+            <a:srgbClr val="942838"/>
+          </a:solidFill>
+          <a:ln/>
+        </p:spPr>
+      </p:sp>
+      <p:sp>
+        <p:nvSpPr>
+          <p:cNvPr id="55" name="Shape 52"/>
+          <p:cNvSpPr/>
+          <p:nvPr/>
+        </p:nvSpPr>
+        <p:spPr>
+          <a:xfrm>
+            <a:off x="2359152" y="4817974"/>
+            <a:ext cx="68580" cy="20117"/>
+          </a:xfrm>
+          <a:prstGeom prst="rect">
+            <a:avLst/>
+          </a:prstGeom>
+          <a:solidFill>
+            <a:srgbClr val="942838"/>
+          </a:solidFill>
+          <a:ln/>
+        </p:spPr>
+      </p:sp>
+      <p:sp>
+        <p:nvSpPr>
+          <p:cNvPr id="56" name="Shape 53"/>
+          <p:cNvSpPr/>
+          <p:nvPr/>
+        </p:nvSpPr>
+        <p:spPr>
+          <a:xfrm>
+            <a:off x="2478024" y="4817974"/>
+            <a:ext cx="68580" cy="20117"/>
+          </a:xfrm>
+          <a:prstGeom prst="rect">
+            <a:avLst/>
+          </a:prstGeom>
+          <a:solidFill>
+            <a:srgbClr val="942838"/>
+          </a:solidFill>
+          <a:ln/>
+        </p:spPr>
+      </p:sp>
+      <p:sp>
+        <p:nvSpPr>
+          <p:cNvPr id="57" name="Shape 54"/>
+          <p:cNvSpPr/>
+          <p:nvPr/>
+        </p:nvSpPr>
+        <p:spPr>
+          <a:xfrm>
+            <a:off x="2596896" y="4817974"/>
+            <a:ext cx="68580" cy="20117"/>
+          </a:xfrm>
+          <a:prstGeom prst="rect">
+            <a:avLst/>
+          </a:prstGeom>
+          <a:solidFill>
+            <a:srgbClr val="942838"/>
+          </a:solidFill>
+          <a:ln/>
+        </p:spPr>
+      </p:sp>
+      <p:sp>
+        <p:nvSpPr>
+          <p:cNvPr id="58" name="Shape 55"/>
+          <p:cNvSpPr/>
+          <p:nvPr/>
+        </p:nvSpPr>
+        <p:spPr>
+          <a:xfrm>
+            <a:off x="2715768" y="4817974"/>
+            <a:ext cx="68580" cy="20117"/>
+          </a:xfrm>
+          <a:prstGeom prst="rect">
+            <a:avLst/>
+          </a:prstGeom>
+          <a:solidFill>
+            <a:srgbClr val="942838"/>
+          </a:solidFill>
+          <a:ln/>
+        </p:spPr>
+      </p:sp>
+      <p:sp>
+        <p:nvSpPr>
+          <p:cNvPr id="59" name="Shape 56"/>
+          <p:cNvSpPr/>
+          <p:nvPr/>
+        </p:nvSpPr>
+        <p:spPr>
+          <a:xfrm>
+            <a:off x="2834640" y="4817974"/>
+            <a:ext cx="68580" cy="20117"/>
+          </a:xfrm>
+          <a:prstGeom prst="rect">
+            <a:avLst/>
+          </a:prstGeom>
+          <a:solidFill>
+            <a:srgbClr val="942838"/>
+          </a:solidFill>
+          <a:ln/>
+        </p:spPr>
+      </p:sp>
+      <p:sp>
+        <p:nvSpPr>
+          <p:cNvPr id="60" name="Shape 57"/>
+          <p:cNvSpPr/>
+          <p:nvPr/>
+        </p:nvSpPr>
+        <p:spPr>
+          <a:xfrm>
+            <a:off x="2953512" y="4817974"/>
+            <a:ext cx="68580" cy="20117"/>
+          </a:xfrm>
+          <a:prstGeom prst="rect">
+            <a:avLst/>
+          </a:prstGeom>
+          <a:solidFill>
+            <a:srgbClr val="942838"/>
+          </a:solidFill>
+          <a:ln/>
+        </p:spPr>
+      </p:sp>
+      <p:sp>
+        <p:nvSpPr>
+          <p:cNvPr id="61" name="Shape 58"/>
+          <p:cNvSpPr/>
+          <p:nvPr/>
+        </p:nvSpPr>
+        <p:spPr>
+          <a:xfrm>
+            <a:off x="3072384" y="4817974"/>
+            <a:ext cx="68580" cy="20117"/>
+          </a:xfrm>
+          <a:prstGeom prst="rect">
+            <a:avLst/>
+          </a:prstGeom>
+          <a:solidFill>
+            <a:srgbClr val="942838"/>
+          </a:solidFill>
+          <a:ln/>
+        </p:spPr>
+      </p:sp>
+      <p:sp>
+        <p:nvSpPr>
+          <p:cNvPr id="62" name="Shape 59"/>
+          <p:cNvSpPr/>
+          <p:nvPr/>
+        </p:nvSpPr>
+        <p:spPr>
+          <a:xfrm>
+            <a:off x="3191256" y="4817974"/>
+            <a:ext cx="68580" cy="20117"/>
+          </a:xfrm>
+          <a:prstGeom prst="rect">
+            <a:avLst/>
+          </a:prstGeom>
+          <a:solidFill>
+            <a:srgbClr val="942838"/>
+          </a:solidFill>
+          <a:ln/>
+        </p:spPr>
+      </p:sp>
+      <p:sp>
+        <p:nvSpPr>
+          <p:cNvPr id="63" name="Shape 60"/>
+          <p:cNvSpPr/>
+          <p:nvPr/>
+        </p:nvSpPr>
+        <p:spPr>
+          <a:xfrm>
+            <a:off x="3310128" y="4817974"/>
+            <a:ext cx="68580" cy="20117"/>
+          </a:xfrm>
+          <a:prstGeom prst="rect">
+            <a:avLst/>
+          </a:prstGeom>
+          <a:solidFill>
+            <a:srgbClr val="942838"/>
+          </a:solidFill>
+          <a:ln/>
+        </p:spPr>
+      </p:sp>
+      <p:sp>
+        <p:nvSpPr>
+          <p:cNvPr id="64" name="Shape 61"/>
+          <p:cNvSpPr/>
+          <p:nvPr/>
+        </p:nvSpPr>
+        <p:spPr>
+          <a:xfrm>
+            <a:off x="3429000" y="4817974"/>
+            <a:ext cx="68580" cy="20117"/>
+          </a:xfrm>
+          <a:prstGeom prst="rect">
+            <a:avLst/>
+          </a:prstGeom>
+          <a:solidFill>
+            <a:srgbClr val="942838"/>
+          </a:solidFill>
+          <a:ln/>
+        </p:spPr>
+      </p:sp>
+      <p:sp>
+        <p:nvSpPr>
+          <p:cNvPr id="65" name="Shape 62"/>
+          <p:cNvSpPr/>
+          <p:nvPr/>
+        </p:nvSpPr>
+        <p:spPr>
+          <a:xfrm>
+            <a:off x="3547872" y="4817974"/>
+            <a:ext cx="68580" cy="20117"/>
+          </a:xfrm>
+          <a:prstGeom prst="rect">
+            <a:avLst/>
+          </a:prstGeom>
+          <a:solidFill>
+            <a:srgbClr val="942838"/>
+          </a:solidFill>
+          <a:ln/>
+        </p:spPr>
+      </p:sp>
+      <p:sp>
+        <p:nvSpPr>
+          <p:cNvPr id="66" name="Shape 63"/>
+          <p:cNvSpPr/>
+          <p:nvPr/>
+        </p:nvSpPr>
+        <p:spPr>
+          <a:xfrm>
+            <a:off x="3666744" y="4817974"/>
+            <a:ext cx="68580" cy="20117"/>
+          </a:xfrm>
+          <a:prstGeom prst="rect">
+            <a:avLst/>
+          </a:prstGeom>
+          <a:solidFill>
+            <a:srgbClr val="942838"/>
+          </a:solidFill>
+          <a:ln/>
+        </p:spPr>
+      </p:sp>
+      <p:sp>
+        <p:nvSpPr>
+          <p:cNvPr id="67" name="Shape 64"/>
+          <p:cNvSpPr/>
+          <p:nvPr/>
+        </p:nvSpPr>
+        <p:spPr>
+          <a:xfrm>
+            <a:off x="3785616" y="4817974"/>
+            <a:ext cx="68580" cy="20117"/>
+          </a:xfrm>
+          <a:prstGeom prst="rect">
+            <a:avLst/>
+          </a:prstGeom>
+          <a:solidFill>
+            <a:srgbClr val="942838"/>
+          </a:solidFill>
+          <a:ln/>
+        </p:spPr>
+      </p:sp>
+      <p:sp>
+        <p:nvSpPr>
+          <p:cNvPr id="68" name="Shape 65"/>
+          <p:cNvSpPr/>
+          <p:nvPr/>
+        </p:nvSpPr>
+        <p:spPr>
+          <a:xfrm>
+            <a:off x="3904488" y="4817974"/>
+            <a:ext cx="68580" cy="20117"/>
+          </a:xfrm>
+          <a:prstGeom prst="rect">
+            <a:avLst/>
+          </a:prstGeom>
+          <a:solidFill>
+            <a:srgbClr val="942838"/>
+          </a:solidFill>
+          <a:ln/>
+        </p:spPr>
+      </p:sp>
+      <p:sp>
+        <p:nvSpPr>
+          <p:cNvPr id="69" name="Shape 66"/>
+          <p:cNvSpPr/>
+          <p:nvPr/>
+        </p:nvSpPr>
+        <p:spPr>
+          <a:xfrm>
+            <a:off x="4023360" y="4817974"/>
+            <a:ext cx="68580" cy="20117"/>
+          </a:xfrm>
+          <a:prstGeom prst="rect">
+            <a:avLst/>
+          </a:prstGeom>
+          <a:solidFill>
+            <a:srgbClr val="942838"/>
+          </a:solidFill>
+          <a:ln/>
+        </p:spPr>
+      </p:sp>
+      <p:sp>
+        <p:nvSpPr>
+          <p:cNvPr id="70" name="Shape 67"/>
+          <p:cNvSpPr/>
+          <p:nvPr/>
+        </p:nvSpPr>
+        <p:spPr>
+          <a:xfrm>
+            <a:off x="4142232" y="4817974"/>
+            <a:ext cx="68580" cy="20117"/>
+          </a:xfrm>
+          <a:prstGeom prst="rect">
+            <a:avLst/>
+          </a:prstGeom>
+          <a:solidFill>
+            <a:srgbClr val="942838"/>
+          </a:solidFill>
+          <a:ln/>
+        </p:spPr>
+      </p:sp>
+      <p:sp>
+        <p:nvSpPr>
+          <p:cNvPr id="71" name="Shape 68"/>
+          <p:cNvSpPr/>
+          <p:nvPr/>
+        </p:nvSpPr>
+        <p:spPr>
+          <a:xfrm>
+            <a:off x="4261104" y="4817974"/>
+            <a:ext cx="68580" cy="20117"/>
+          </a:xfrm>
+          <a:prstGeom prst="rect">
+            <a:avLst/>
+          </a:prstGeom>
+          <a:solidFill>
+            <a:srgbClr val="942838"/>
+          </a:solidFill>
+          <a:ln/>
+        </p:spPr>
+      </p:sp>
+      <p:sp>
+        <p:nvSpPr>
+          <p:cNvPr id="72" name="Shape 69"/>
+          <p:cNvSpPr/>
+          <p:nvPr/>
+        </p:nvSpPr>
+        <p:spPr>
+          <a:xfrm>
+            <a:off x="4379976" y="4817974"/>
+            <a:ext cx="68580" cy="20117"/>
+          </a:xfrm>
+          <a:prstGeom prst="rect">
+            <a:avLst/>
+          </a:prstGeom>
+          <a:solidFill>
+            <a:srgbClr val="942838"/>
+          </a:solidFill>
+          <a:ln/>
+        </p:spPr>
+      </p:sp>
+      <p:sp>
+        <p:nvSpPr>
+          <p:cNvPr id="73" name="Shape 70"/>
+          <p:cNvSpPr/>
+          <p:nvPr/>
+        </p:nvSpPr>
+        <p:spPr>
+          <a:xfrm>
+            <a:off x="4498848" y="4817974"/>
+            <a:ext cx="68580" cy="20117"/>
+          </a:xfrm>
+          <a:prstGeom prst="rect">
+            <a:avLst/>
+          </a:prstGeom>
+          <a:solidFill>
+            <a:srgbClr val="942838"/>
+          </a:solidFill>
+          <a:ln/>
+        </p:spPr>
+      </p:sp>
+      <p:sp>
+        <p:nvSpPr>
+          <p:cNvPr id="74" name="Shape 71"/>
+          <p:cNvSpPr/>
+          <p:nvPr/>
+        </p:nvSpPr>
+        <p:spPr>
+          <a:xfrm>
+            <a:off x="4617720" y="4817974"/>
+            <a:ext cx="68580" cy="20117"/>
+          </a:xfrm>
+          <a:prstGeom prst="rect">
+            <a:avLst/>
+          </a:prstGeom>
+          <a:solidFill>
+            <a:srgbClr val="942838"/>
+          </a:solidFill>
+          <a:ln/>
+        </p:spPr>
+      </p:sp>
+      <p:sp>
+        <p:nvSpPr>
+          <p:cNvPr id="75" name="Shape 72"/>
+          <p:cNvSpPr/>
+          <p:nvPr/>
+        </p:nvSpPr>
+        <p:spPr>
+          <a:xfrm>
+            <a:off x="4736592" y="4817974"/>
+            <a:ext cx="68580" cy="20117"/>
+          </a:xfrm>
+          <a:prstGeom prst="rect">
+            <a:avLst/>
+          </a:prstGeom>
+          <a:solidFill>
+            <a:srgbClr val="942838"/>
+          </a:solidFill>
+          <a:ln/>
+        </p:spPr>
+      </p:sp>
+      <p:sp>
+        <p:nvSpPr>
+          <p:cNvPr id="76" name="Shape 73"/>
+          <p:cNvSpPr/>
+          <p:nvPr/>
+        </p:nvSpPr>
+        <p:spPr>
+          <a:xfrm>
+            <a:off x="4855464" y="4817974"/>
+            <a:ext cx="68580" cy="20117"/>
+          </a:xfrm>
+          <a:prstGeom prst="rect">
+            <a:avLst/>
+          </a:prstGeom>
+          <a:solidFill>
+            <a:srgbClr val="942838"/>
+          </a:solidFill>
+          <a:ln/>
+        </p:spPr>
+      </p:sp>
+      <p:sp>
+        <p:nvSpPr>
+          <p:cNvPr id="77" name="Shape 74"/>
+          <p:cNvSpPr/>
+          <p:nvPr/>
+        </p:nvSpPr>
+        <p:spPr>
+          <a:xfrm>
+            <a:off x="4974336" y="4817974"/>
+            <a:ext cx="68580" cy="20117"/>
+          </a:xfrm>
+          <a:prstGeom prst="rect">
+            <a:avLst/>
+          </a:prstGeom>
+          <a:solidFill>
+            <a:srgbClr val="942838"/>
+          </a:solidFill>
+          <a:ln/>
+        </p:spPr>
+      </p:sp>
+      <p:sp>
+        <p:nvSpPr>
+          <p:cNvPr id="78" name="Shape 75"/>
+          <p:cNvSpPr/>
+          <p:nvPr/>
+        </p:nvSpPr>
+        <p:spPr>
+          <a:xfrm>
+            <a:off x="5093208" y="4817974"/>
+            <a:ext cx="68580" cy="20117"/>
+          </a:xfrm>
+          <a:prstGeom prst="rect">
+            <a:avLst/>
+          </a:prstGeom>
+          <a:solidFill>
+            <a:srgbClr val="942838"/>
+          </a:solidFill>
+          <a:ln/>
+        </p:spPr>
+      </p:sp>
+      <p:sp>
+        <p:nvSpPr>
+          <p:cNvPr id="79" name="Shape 76"/>
+          <p:cNvSpPr/>
+          <p:nvPr/>
+        </p:nvSpPr>
+        <p:spPr>
+          <a:xfrm>
+            <a:off x="5212080" y="4817974"/>
+            <a:ext cx="68580" cy="20117"/>
+          </a:xfrm>
+          <a:prstGeom prst="rect">
+            <a:avLst/>
+          </a:prstGeom>
+          <a:solidFill>
+            <a:srgbClr val="942838"/>
+          </a:solidFill>
+          <a:ln/>
+        </p:spPr>
+      </p:sp>
+      <p:sp>
+        <p:nvSpPr>
+          <p:cNvPr id="80" name="Shape 77"/>
+          <p:cNvSpPr/>
+          <p:nvPr/>
+        </p:nvSpPr>
+        <p:spPr>
+          <a:xfrm>
+            <a:off x="5330952" y="4817974"/>
+            <a:ext cx="68580" cy="20117"/>
+          </a:xfrm>
+          <a:prstGeom prst="rect">
+            <a:avLst/>
+          </a:prstGeom>
+          <a:solidFill>
+            <a:srgbClr val="942838"/>
+          </a:solidFill>
+          <a:ln/>
+        </p:spPr>
+      </p:sp>
+      <p:sp>
+        <p:nvSpPr>
+          <p:cNvPr id="81" name="Shape 78"/>
+          <p:cNvSpPr/>
+          <p:nvPr/>
+        </p:nvSpPr>
+        <p:spPr>
+          <a:xfrm>
+            <a:off x="5449824" y="4817974"/>
+            <a:ext cx="68580" cy="20117"/>
+          </a:xfrm>
+          <a:prstGeom prst="rect">
+            <a:avLst/>
+          </a:prstGeom>
+          <a:solidFill>
+            <a:srgbClr val="942838"/>
+          </a:solidFill>
+          <a:ln/>
+        </p:spPr>
+      </p:sp>
+      <p:sp>
+        <p:nvSpPr>
+          <p:cNvPr id="82" name="Shape 79"/>
+          <p:cNvSpPr/>
+          <p:nvPr/>
+        </p:nvSpPr>
+        <p:spPr>
+          <a:xfrm>
+            <a:off x="5568696" y="4817974"/>
+            <a:ext cx="68580" cy="20117"/>
+          </a:xfrm>
+          <a:prstGeom prst="rect">
+            <a:avLst/>
+          </a:prstGeom>
+          <a:solidFill>
+            <a:srgbClr val="942838"/>
+          </a:solidFill>
+          <a:ln/>
+        </p:spPr>
+      </p:sp>
+      <p:sp>
+        <p:nvSpPr>
+          <p:cNvPr id="83" name="Shape 80"/>
+          <p:cNvSpPr/>
+          <p:nvPr/>
+        </p:nvSpPr>
+        <p:spPr>
+          <a:xfrm>
+            <a:off x="5687568" y="4817974"/>
+            <a:ext cx="68580" cy="20117"/>
+          </a:xfrm>
+          <a:prstGeom prst="rect">
+            <a:avLst/>
+          </a:prstGeom>
+          <a:solidFill>
+            <a:srgbClr val="942838"/>
+          </a:solidFill>
+          <a:ln/>
+        </p:spPr>
+      </p:sp>
+      <p:sp>
+        <p:nvSpPr>
+          <p:cNvPr id="84" name="Shape 81"/>
+          <p:cNvSpPr/>
+          <p:nvPr/>
+        </p:nvSpPr>
+        <p:spPr>
+          <a:xfrm>
+            <a:off x="5806440" y="4817974"/>
+            <a:ext cx="68580" cy="20117"/>
+          </a:xfrm>
+          <a:prstGeom prst="rect">
+            <a:avLst/>
+          </a:prstGeom>
+          <a:solidFill>
+            <a:srgbClr val="942838"/>
+          </a:solidFill>
+          <a:ln/>
+        </p:spPr>
+      </p:sp>
+      <p:sp>
+        <p:nvSpPr>
+          <p:cNvPr id="85" name="Shape 82"/>
+          <p:cNvSpPr/>
+          <p:nvPr/>
+        </p:nvSpPr>
+        <p:spPr>
+          <a:xfrm>
+            <a:off x="5925312" y="4817974"/>
+            <a:ext cx="68580" cy="20117"/>
+          </a:xfrm>
+          <a:prstGeom prst="rect">
+            <a:avLst/>
+          </a:prstGeom>
+          <a:solidFill>
+            <a:srgbClr val="942838"/>
+          </a:solidFill>
+          <a:ln/>
+        </p:spPr>
+      </p:sp>
+      <p:sp>
+        <p:nvSpPr>
+          <p:cNvPr id="86" name="Shape 83"/>
+          <p:cNvSpPr/>
+          <p:nvPr/>
+        </p:nvSpPr>
+        <p:spPr>
+          <a:xfrm>
+            <a:off x="6044184" y="4817974"/>
+            <a:ext cx="68580" cy="20117"/>
+          </a:xfrm>
+          <a:prstGeom prst="rect">
+            <a:avLst/>
+          </a:prstGeom>
+          <a:solidFill>
+            <a:srgbClr val="942838"/>
+          </a:solidFill>
+          <a:ln/>
+        </p:spPr>
+      </p:sp>
+      <p:sp>
+        <p:nvSpPr>
+          <p:cNvPr id="87" name="Shape 84"/>
+          <p:cNvSpPr/>
+          <p:nvPr/>
+        </p:nvSpPr>
+        <p:spPr>
+          <a:xfrm>
+            <a:off x="6163056" y="4817974"/>
+            <a:ext cx="68580" cy="20117"/>
+          </a:xfrm>
+          <a:prstGeom prst="rect">
+            <a:avLst/>
+          </a:prstGeom>
+          <a:solidFill>
+            <a:srgbClr val="942838"/>
+          </a:solidFill>
+          <a:ln/>
+        </p:spPr>
+      </p:sp>
+      <p:sp>
+        <p:nvSpPr>
+          <p:cNvPr id="88" name="Shape 85"/>
+          <p:cNvSpPr/>
+          <p:nvPr/>
+        </p:nvSpPr>
+        <p:spPr>
+          <a:xfrm>
+            <a:off x="6281928" y="4817974"/>
+            <a:ext cx="68580" cy="20117"/>
+          </a:xfrm>
+          <a:prstGeom prst="rect">
+            <a:avLst/>
+          </a:prstGeom>
+          <a:solidFill>
+            <a:srgbClr val="942838"/>
+          </a:solidFill>
+          <a:ln/>
+        </p:spPr>
+      </p:sp>
+      <p:sp>
+        <p:nvSpPr>
+          <p:cNvPr id="89" name="Shape 86"/>
+          <p:cNvSpPr/>
+          <p:nvPr/>
+        </p:nvSpPr>
+        <p:spPr>
+          <a:xfrm>
+            <a:off x="6400800" y="4817974"/>
+            <a:ext cx="68580" cy="20117"/>
+          </a:xfrm>
+          <a:prstGeom prst="rect">
+            <a:avLst/>
+          </a:prstGeom>
+          <a:solidFill>
+            <a:srgbClr val="942838"/>
+          </a:solidFill>
+          <a:ln/>
+        </p:spPr>
+      </p:sp>
+      <p:sp>
+        <p:nvSpPr>
+          <p:cNvPr id="90" name="Shape 87"/>
+          <p:cNvSpPr/>
+          <p:nvPr/>
+        </p:nvSpPr>
+        <p:spPr>
+          <a:xfrm>
+            <a:off x="6519672" y="4817974"/>
+            <a:ext cx="68580" cy="20117"/>
+          </a:xfrm>
+          <a:prstGeom prst="rect">
+            <a:avLst/>
+          </a:prstGeom>
+          <a:solidFill>
+            <a:srgbClr val="942838"/>
+          </a:solidFill>
+          <a:ln/>
+        </p:spPr>
+      </p:sp>
+      <p:sp>
+        <p:nvSpPr>
+          <p:cNvPr id="91" name="Shape 88"/>
+          <p:cNvSpPr/>
+          <p:nvPr/>
+        </p:nvSpPr>
+        <p:spPr>
+          <a:xfrm>
+            <a:off x="6638544" y="4817974"/>
+            <a:ext cx="68580" cy="20117"/>
+          </a:xfrm>
+          <a:prstGeom prst="rect">
+            <a:avLst/>
+          </a:prstGeom>
+          <a:solidFill>
+            <a:srgbClr val="942838"/>
+          </a:solidFill>
+          <a:ln/>
+        </p:spPr>
+      </p:sp>
+      <p:sp>
+        <p:nvSpPr>
+          <p:cNvPr id="92" name="Shape 89"/>
+          <p:cNvSpPr/>
+          <p:nvPr/>
+        </p:nvSpPr>
+        <p:spPr>
+          <a:xfrm>
+            <a:off x="6757416" y="4817974"/>
+            <a:ext cx="68580" cy="20117"/>
+          </a:xfrm>
+          <a:prstGeom prst="rect">
+            <a:avLst/>
+          </a:prstGeom>
+          <a:solidFill>
+            <a:srgbClr val="942838"/>
+          </a:solidFill>
+          <a:ln/>
+        </p:spPr>
+      </p:sp>
+      <p:sp>
+        <p:nvSpPr>
+          <p:cNvPr id="93" name="Shape 90"/>
+          <p:cNvSpPr/>
+          <p:nvPr/>
+        </p:nvSpPr>
+        <p:spPr>
+          <a:xfrm>
+            <a:off x="6876288" y="4817974"/>
+            <a:ext cx="68580" cy="20117"/>
+          </a:xfrm>
+          <a:prstGeom prst="rect">
+            <a:avLst/>
+          </a:prstGeom>
+          <a:solidFill>
+            <a:srgbClr val="942838"/>
+          </a:solidFill>
+          <a:ln/>
+        </p:spPr>
+      </p:sp>
+      <p:sp>
+        <p:nvSpPr>
+          <p:cNvPr id="94" name="Shape 91"/>
+          <p:cNvSpPr/>
+          <p:nvPr/>
+        </p:nvSpPr>
+        <p:spPr>
+          <a:xfrm>
+            <a:off x="6995160" y="4817974"/>
+            <a:ext cx="68580" cy="20117"/>
+          </a:xfrm>
+          <a:prstGeom prst="rect">
+            <a:avLst/>
+          </a:prstGeom>
+          <a:solidFill>
+            <a:srgbClr val="942838"/>
+          </a:solidFill>
+          <a:ln/>
+        </p:spPr>
+      </p:sp>
+      <p:sp>
+        <p:nvSpPr>
+          <p:cNvPr id="95" name="Shape 92"/>
+          <p:cNvSpPr/>
+          <p:nvPr/>
+        </p:nvSpPr>
+        <p:spPr>
+          <a:xfrm>
+            <a:off x="7114032" y="4817974"/>
+            <a:ext cx="68580" cy="20117"/>
+          </a:xfrm>
+          <a:prstGeom prst="rect">
+            <a:avLst/>
+          </a:prstGeom>
+          <a:solidFill>
+            <a:srgbClr val="942838"/>
+          </a:solidFill>
+          <a:ln/>
+        </p:spPr>
+      </p:sp>
+      <p:sp>
+        <p:nvSpPr>
+          <p:cNvPr id="96" name="Shape 93"/>
+          <p:cNvSpPr/>
+          <p:nvPr/>
+        </p:nvSpPr>
+        <p:spPr>
+          <a:xfrm>
+            <a:off x="7232904" y="4817974"/>
+            <a:ext cx="68580" cy="20117"/>
+          </a:xfrm>
+          <a:prstGeom prst="rect">
+            <a:avLst/>
+          </a:prstGeom>
+          <a:solidFill>
+            <a:srgbClr val="942838"/>
+          </a:solidFill>
+          <a:ln/>
+        </p:spPr>
+      </p:sp>
+      <p:sp>
+        <p:nvSpPr>
+          <p:cNvPr id="97" name="Shape 94"/>
+          <p:cNvSpPr/>
+          <p:nvPr/>
+        </p:nvSpPr>
+        <p:spPr>
+          <a:xfrm>
+            <a:off x="7351776" y="4817974"/>
+            <a:ext cx="68580" cy="20117"/>
+          </a:xfrm>
+          <a:prstGeom prst="rect">
+            <a:avLst/>
+          </a:prstGeom>
+          <a:solidFill>
+            <a:srgbClr val="942838"/>
+          </a:solidFill>
+          <a:ln/>
+        </p:spPr>
+      </p:sp>
+      <p:sp>
+        <p:nvSpPr>
+          <p:cNvPr id="98" name="Shape 95"/>
+          <p:cNvSpPr/>
+          <p:nvPr/>
+        </p:nvSpPr>
+        <p:spPr>
+          <a:xfrm>
+            <a:off x="7470648" y="4817974"/>
+            <a:ext cx="68580" cy="20117"/>
+          </a:xfrm>
+          <a:prstGeom prst="rect">
+            <a:avLst/>
+          </a:prstGeom>
+          <a:solidFill>
+            <a:srgbClr val="942838"/>
+          </a:solidFill>
+          <a:ln/>
+        </p:spPr>
+      </p:sp>
+      <p:sp>
+        <p:nvSpPr>
+          <p:cNvPr id="99" name="Shape 96"/>
+          <p:cNvSpPr/>
+          <p:nvPr/>
+        </p:nvSpPr>
+        <p:spPr>
+          <a:xfrm>
+            <a:off x="7589520" y="4817974"/>
+            <a:ext cx="68580" cy="20117"/>
+          </a:xfrm>
+          <a:prstGeom prst="rect">
+            <a:avLst/>
+          </a:prstGeom>
+          <a:solidFill>
+            <a:srgbClr val="942838"/>
+          </a:solidFill>
+          <a:ln/>
+        </p:spPr>
+      </p:sp>
+      <p:sp>
+        <p:nvSpPr>
+          <p:cNvPr id="100" name="Shape 97"/>
+          <p:cNvSpPr/>
+          <p:nvPr/>
+        </p:nvSpPr>
+        <p:spPr>
+          <a:xfrm>
+            <a:off x="7708392" y="4817974"/>
+            <a:ext cx="68580" cy="20117"/>
+          </a:xfrm>
+          <a:prstGeom prst="rect">
+            <a:avLst/>
+          </a:prstGeom>
+          <a:solidFill>
+            <a:srgbClr val="942838"/>
+          </a:solidFill>
+          <a:ln/>
+        </p:spPr>
+      </p:sp>
+      <p:sp>
+        <p:nvSpPr>
+          <p:cNvPr id="101" name="Shape 98"/>
+          <p:cNvSpPr/>
+          <p:nvPr/>
+        </p:nvSpPr>
+        <p:spPr>
+          <a:xfrm>
+            <a:off x="7827264" y="4817974"/>
+            <a:ext cx="68580" cy="20117"/>
+          </a:xfrm>
+          <a:prstGeom prst="rect">
+            <a:avLst/>
+          </a:prstGeom>
+          <a:solidFill>
+            <a:srgbClr val="942838"/>
+          </a:solidFill>
+          <a:ln/>
+        </p:spPr>
+      </p:sp>
+      <p:sp>
+        <p:nvSpPr>
+          <p:cNvPr id="102" name="Shape 99"/>
+          <p:cNvSpPr/>
+          <p:nvPr/>
+        </p:nvSpPr>
+        <p:spPr>
+          <a:xfrm>
+            <a:off x="7946136" y="4817974"/>
+            <a:ext cx="68580" cy="20117"/>
+          </a:xfrm>
+          <a:prstGeom prst="rect">
+            <a:avLst/>
+          </a:prstGeom>
+          <a:solidFill>
+            <a:srgbClr val="942838"/>
+          </a:solidFill>
+          <a:ln/>
+        </p:spPr>
+      </p:sp>
+      <p:sp>
+        <p:nvSpPr>
+          <p:cNvPr id="103" name="Shape 100"/>
+          <p:cNvSpPr/>
+          <p:nvPr/>
+        </p:nvSpPr>
+        <p:spPr>
+          <a:xfrm>
+            <a:off x="8065008" y="4817974"/>
+            <a:ext cx="68580" cy="20117"/>
+          </a:xfrm>
+          <a:prstGeom prst="rect">
+            <a:avLst/>
+          </a:prstGeom>
+          <a:solidFill>
+            <a:srgbClr val="942838"/>
+          </a:solidFill>
+          <a:ln/>
+        </p:spPr>
+      </p:sp>
+      <p:sp>
+        <p:nvSpPr>
+          <p:cNvPr id="104" name="Shape 101"/>
+          <p:cNvSpPr/>
+          <p:nvPr/>
+        </p:nvSpPr>
+        <p:spPr>
+          <a:xfrm>
+            <a:off x="8183880" y="4817974"/>
+            <a:ext cx="68580" cy="20117"/>
+          </a:xfrm>
+          <a:prstGeom prst="rect">
+            <a:avLst/>
+          </a:prstGeom>
+          <a:solidFill>
+            <a:srgbClr val="942838"/>
+          </a:solidFill>
+          <a:ln/>
+        </p:spPr>
+      </p:sp>
+      <p:sp>
+        <p:nvSpPr>
+          <p:cNvPr id="105" name="Shape 102"/>
+          <p:cNvSpPr/>
+          <p:nvPr/>
+        </p:nvSpPr>
+        <p:spPr>
+          <a:xfrm>
+            <a:off x="8302752" y="4817974"/>
+            <a:ext cx="68580" cy="20117"/>
+          </a:xfrm>
+          <a:prstGeom prst="rect">
+            <a:avLst/>
+          </a:prstGeom>
+          <a:solidFill>
+            <a:srgbClr val="942838"/>
+          </a:solidFill>
+          <a:ln/>
+        </p:spPr>
+      </p:sp>
+      <p:sp>
+        <p:nvSpPr>
+          <p:cNvPr id="106" name="Shape 103"/>
+          <p:cNvSpPr/>
+          <p:nvPr/>
+        </p:nvSpPr>
+        <p:spPr>
+          <a:xfrm>
+            <a:off x="8421624" y="4817974"/>
+            <a:ext cx="68580" cy="20117"/>
+          </a:xfrm>
+          <a:prstGeom prst="rect">
+            <a:avLst/>
+          </a:prstGeom>
+          <a:solidFill>
+            <a:srgbClr val="942838"/>
+          </a:solidFill>
+          <a:ln/>
+        </p:spPr>
+      </p:sp>
+      <p:sp>
+        <p:nvSpPr>
+          <p:cNvPr id="107" name="Shape 104"/>
+          <p:cNvSpPr/>
+          <p:nvPr/>
+        </p:nvSpPr>
+        <p:spPr>
+          <a:xfrm>
+            <a:off x="8540496" y="4817974"/>
+            <a:ext cx="68580" cy="20117"/>
+          </a:xfrm>
+          <a:prstGeom prst="rect">
+            <a:avLst/>
+          </a:prstGeom>
+          <a:solidFill>
+            <a:srgbClr val="942838"/>
+          </a:solidFill>
+          <a:ln/>
+        </p:spPr>
+      </p:sp>
+      <p:sp>
+        <p:nvSpPr>
+          <p:cNvPr id="108" name="Shape 105"/>
+          <p:cNvSpPr/>
+          <p:nvPr/>
+        </p:nvSpPr>
+        <p:spPr>
+          <a:xfrm>
+            <a:off x="8659368" y="4817974"/>
+            <a:ext cx="68580" cy="20117"/>
+          </a:xfrm>
+          <a:prstGeom prst="rect">
+            <a:avLst/>
+          </a:prstGeom>
+          <a:solidFill>
+            <a:srgbClr val="942838"/>
+          </a:solidFill>
+          <a:ln/>
+        </p:spPr>
+      </p:sp>
+      <p:sp>
+        <p:nvSpPr>
+          <p:cNvPr id="109" name="Shape 106"/>
+          <p:cNvSpPr/>
+          <p:nvPr/>
+        </p:nvSpPr>
+        <p:spPr>
+          <a:xfrm>
+            <a:off x="8778240" y="4817974"/>
+            <a:ext cx="68580" cy="20117"/>
+          </a:xfrm>
+          <a:prstGeom prst="rect">
+            <a:avLst/>
+          </a:prstGeom>
+          <a:solidFill>
+            <a:srgbClr val="942838"/>
+          </a:solidFill>
+          <a:ln/>
+        </p:spPr>
+      </p:sp>
+      <p:sp>
+        <p:nvSpPr>
+          <p:cNvPr id="110" name="Shape 107"/>
+          <p:cNvSpPr/>
+          <p:nvPr/>
+        </p:nvSpPr>
+        <p:spPr>
+          <a:xfrm>
+            <a:off x="8897112" y="4817974"/>
+            <a:ext cx="68580" cy="20117"/>
+          </a:xfrm>
+          <a:prstGeom prst="rect">
+            <a:avLst/>
+          </a:prstGeom>
+          <a:solidFill>
+            <a:srgbClr val="942838"/>
+          </a:solidFill>
+          <a:ln/>
+        </p:spPr>
+      </p:sp>
+      <p:sp>
+        <p:nvSpPr>
+          <p:cNvPr id="111" name="Shape 108"/>
+          <p:cNvSpPr/>
+          <p:nvPr/>
+        </p:nvSpPr>
+        <p:spPr>
+          <a:xfrm>
+            <a:off x="9015984" y="4817974"/>
+            <a:ext cx="68580" cy="20117"/>
+          </a:xfrm>
+          <a:prstGeom prst="rect">
+            <a:avLst/>
+          </a:prstGeom>
+          <a:solidFill>
+            <a:srgbClr val="942838"/>
+          </a:solidFill>
+          <a:ln/>
+        </p:spPr>
+      </p:sp>
+      <p:sp>
+        <p:nvSpPr>
+          <p:cNvPr id="112" name="Shape 109"/>
+          <p:cNvSpPr/>
+          <p:nvPr/>
+        </p:nvSpPr>
+        <p:spPr>
+          <a:xfrm>
+            <a:off x="9134856" y="4817974"/>
+            <a:ext cx="68580" cy="20117"/>
+          </a:xfrm>
+          <a:prstGeom prst="rect">
+            <a:avLst/>
+          </a:prstGeom>
+          <a:solidFill>
+            <a:srgbClr val="942838"/>
+          </a:solidFill>
+          <a:ln/>
+        </p:spPr>
+      </p:sp>
+      <p:sp>
+        <p:nvSpPr>
+          <p:cNvPr id="113" name="Shape 110"/>
+          <p:cNvSpPr/>
+          <p:nvPr/>
+        </p:nvSpPr>
+        <p:spPr>
+          <a:xfrm>
+            <a:off x="9253728" y="4817974"/>
+            <a:ext cx="68580" cy="20117"/>
+          </a:xfrm>
+          <a:prstGeom prst="rect">
+            <a:avLst/>
+          </a:prstGeom>
+          <a:solidFill>
+            <a:srgbClr val="942838"/>
+          </a:solidFill>
+          <a:ln/>
+        </p:spPr>
+      </p:sp>
+      <p:sp>
+        <p:nvSpPr>
+          <p:cNvPr id="114" name="Shape 111"/>
+          <p:cNvSpPr/>
+          <p:nvPr/>
+        </p:nvSpPr>
+        <p:spPr>
+          <a:xfrm>
+            <a:off x="9372600" y="4817974"/>
+            <a:ext cx="68580" cy="20117"/>
+          </a:xfrm>
+          <a:prstGeom prst="rect">
+            <a:avLst/>
+          </a:prstGeom>
+          <a:solidFill>
+            <a:srgbClr val="942838"/>
+          </a:solidFill>
+          <a:ln/>
+        </p:spPr>
+      </p:sp>
+      <p:sp>
+        <p:nvSpPr>
+          <p:cNvPr id="115" name="Shape 112"/>
+          <p:cNvSpPr/>
+          <p:nvPr/>
+        </p:nvSpPr>
+        <p:spPr>
+          <a:xfrm>
+            <a:off x="9491472" y="4817974"/>
+            <a:ext cx="68580" cy="20117"/>
+          </a:xfrm>
+          <a:prstGeom prst="rect">
+            <a:avLst/>
+          </a:prstGeom>
+          <a:solidFill>
+            <a:srgbClr val="942838"/>
+          </a:solidFill>
+          <a:ln/>
+        </p:spPr>
+      </p:sp>
+      <p:sp>
+        <p:nvSpPr>
+          <p:cNvPr id="116" name="Shape 113"/>
+          <p:cNvSpPr/>
+          <p:nvPr/>
+        </p:nvSpPr>
+        <p:spPr>
+          <a:xfrm>
+            <a:off x="9610344" y="4817974"/>
+            <a:ext cx="68580" cy="20117"/>
+          </a:xfrm>
+          <a:prstGeom prst="rect">
+            <a:avLst/>
+          </a:prstGeom>
+          <a:solidFill>
+            <a:srgbClr val="942838"/>
+          </a:solidFill>
+          <a:ln/>
+        </p:spPr>
+      </p:sp>
+      <p:sp>
+        <p:nvSpPr>
+          <p:cNvPr id="117" name="Shape 114"/>
+          <p:cNvSpPr/>
+          <p:nvPr/>
+        </p:nvSpPr>
+        <p:spPr>
+          <a:xfrm>
+            <a:off x="9729216" y="4817974"/>
+            <a:ext cx="68580" cy="20117"/>
+          </a:xfrm>
+          <a:prstGeom prst="rect">
+            <a:avLst/>
+          </a:prstGeom>
+          <a:solidFill>
+            <a:srgbClr val="942838"/>
+          </a:solidFill>
+          <a:ln/>
+        </p:spPr>
+      </p:sp>
+      <p:sp>
+        <p:nvSpPr>
+          <p:cNvPr id="118" name="Shape 115"/>
+          <p:cNvSpPr/>
+          <p:nvPr/>
+        </p:nvSpPr>
+        <p:spPr>
+          <a:xfrm>
+            <a:off x="9848088" y="4817974"/>
+            <a:ext cx="68580" cy="20117"/>
+          </a:xfrm>
+          <a:prstGeom prst="rect">
+            <a:avLst/>
+          </a:prstGeom>
+          <a:solidFill>
+            <a:srgbClr val="942838"/>
+          </a:solidFill>
+          <a:ln/>
+        </p:spPr>
+      </p:sp>
+      <p:sp>
+        <p:nvSpPr>
+          <p:cNvPr id="119" name="Shape 116"/>
+          <p:cNvSpPr/>
+          <p:nvPr/>
+        </p:nvSpPr>
+        <p:spPr>
+          <a:xfrm>
+            <a:off x="9966960" y="4817974"/>
+            <a:ext cx="68580" cy="20117"/>
+          </a:xfrm>
+          <a:prstGeom prst="rect">
+            <a:avLst/>
+          </a:prstGeom>
+          <a:solidFill>
+            <a:srgbClr val="942838"/>
+          </a:solidFill>
+          <a:ln/>
+        </p:spPr>
+      </p:sp>
+      <p:sp>
+        <p:nvSpPr>
+          <p:cNvPr id="120" name="Shape 117"/>
+          <p:cNvSpPr/>
+          <p:nvPr/>
+        </p:nvSpPr>
+        <p:spPr>
+          <a:xfrm>
+            <a:off x="10085832" y="4817974"/>
+            <a:ext cx="68580" cy="20117"/>
+          </a:xfrm>
+          <a:prstGeom prst="rect">
+            <a:avLst/>
+          </a:prstGeom>
+          <a:solidFill>
+            <a:srgbClr val="942838"/>
+          </a:solidFill>
+          <a:ln/>
+        </p:spPr>
+      </p:sp>
+      <p:sp>
+        <p:nvSpPr>
+          <p:cNvPr id="121" name="Shape 118"/>
+          <p:cNvSpPr/>
+          <p:nvPr/>
+        </p:nvSpPr>
+        <p:spPr>
+          <a:xfrm>
+            <a:off x="10204704" y="4817974"/>
+            <a:ext cx="68580" cy="20117"/>
+          </a:xfrm>
+          <a:prstGeom prst="rect">
+            <a:avLst/>
+          </a:prstGeom>
+          <a:solidFill>
+            <a:srgbClr val="942838"/>
+          </a:solidFill>
+          <a:ln/>
+        </p:spPr>
+      </p:sp>
+      <p:sp>
+        <p:nvSpPr>
+          <p:cNvPr id="122" name="Shape 119"/>
+          <p:cNvSpPr/>
+          <p:nvPr/>
+        </p:nvSpPr>
+        <p:spPr>
+          <a:xfrm>
+            <a:off x="1873606" y="4526280"/>
+            <a:ext cx="20117" cy="301752"/>
+          </a:xfrm>
+          <a:prstGeom prst="rect">
+            <a:avLst/>
+          </a:prstGeom>
+          <a:solidFill>
+            <a:srgbClr val="942838"/>
+          </a:solidFill>
+          <a:ln/>
+        </p:spPr>
+      </p:sp>
+      <p:sp>
+        <p:nvSpPr>
+          <p:cNvPr id="123" name="Shape 120"/>
+          <p:cNvSpPr/>
+          <p:nvPr/>
+        </p:nvSpPr>
+        <p:spPr>
+          <a:xfrm>
+            <a:off x="1837944" y="4407408"/>
+            <a:ext cx="91440" cy="118872"/>
+          </a:xfrm>
+          <a:prstGeom prst="triangle">
+            <a:avLst/>
+          </a:prstGeom>
+          <a:solidFill>
+            <a:srgbClr val="942838"/>
+          </a:solidFill>
+          <a:ln/>
+        </p:spPr>
+      </p:sp>
+      <p:sp>
+        <p:nvSpPr>
+          <p:cNvPr id="124" name="Text 121"/>
           <p:cNvSpPr txBox="1"/>
           <p:nvPr/>
         </p:nvSpPr>
@@ -5040,7 +6557,7 @@
       </p:sp>
       <p:sp>
         <p:nvSpPr>
-          <p:cNvPr id="48" name="Shape 45"/>
+          <p:cNvPr id="125" name="Shape 122"/>
           <p:cNvSpPr/>
           <p:nvPr/>
         </p:nvSpPr>
@@ -5065,7 +6582,7 @@
       </p:sp>
       <p:sp>
         <p:nvSpPr>
-          <p:cNvPr id="49" name="Text 46"/>
+          <p:cNvPr id="126" name="Text 123"/>
           <p:cNvSpPr txBox="1"/>
           <p:nvPr/>
         </p:nvSpPr>
@@ -5104,7 +6621,7 @@
       </p:sp>
       <p:sp>
         <p:nvSpPr>
-          <p:cNvPr id="50" name="Text 47"/>
+          <p:cNvPr id="127" name="Text 124"/>
           <p:cNvSpPr txBox="1"/>
           <p:nvPr/>
         </p:nvSpPr>
@@ -5146,7 +6663,7 @@
       </p:sp>
       <p:sp>
         <p:nvSpPr>
-          <p:cNvPr id="51" name="Shape 48"/>
+          <p:cNvPr id="128" name="Shape 125"/>
           <p:cNvSpPr/>
           <p:nvPr/>
         </p:nvSpPr>
@@ -5171,7 +6688,7 @@
       </p:sp>
       <p:sp>
         <p:nvSpPr>
-          <p:cNvPr id="52" name="Text 49"/>
+          <p:cNvPr id="129" name="Text 126"/>
           <p:cNvSpPr txBox="1"/>
           <p:nvPr/>
         </p:nvSpPr>
@@ -5210,7 +6727,7 @@
       </p:sp>
       <p:sp>
         <p:nvSpPr>
-          <p:cNvPr id="53" name="Text 50"/>
+          <p:cNvPr id="130" name="Text 127"/>
           <p:cNvSpPr txBox="1"/>
           <p:nvPr/>
         </p:nvSpPr>

</xml_diff>

<commit_message>
Update logo wordmark to 'Stewart Title'
Capitalise the wordmark and add 'Title' so the mark reads as the full company
name. The longer wordmark takes the lockup from a 6.7:1 aspect to 9.9:1, so
placement widths grow to match: 1.22in to 1.8in for the standard top-right
mark, and 1.62in to 2.4in on the title slide. Height still derives from the
asset's real dimensions, so the wordmark keeps its previous optical size
rather than shrinking to fit the old box.
</commit_message>
<xml_diff>
--- a/out/Internship_Exit_Presentation_Stewart.pptx
+++ b/out/Internship_Exit_Presentation_Stewart.pptx
@@ -2446,7 +2446,7 @@
         <p:spPr>
           <a:xfrm>
             <a:off x="777240" y="566928"/>
-            <a:ext cx="1481328" cy="221277"/>
+            <a:ext cx="2194560" cy="221404"/>
           </a:xfrm>
           <a:prstGeom prst="rect">
             <a:avLst/>
@@ -2700,8 +2700,8 @@
         </p:blipFill>
         <p:spPr>
           <a:xfrm>
-            <a:off x="10298887" y="457200"/>
-            <a:ext cx="1115568" cy="166641"/>
+            <a:off x="9768535" y="457200"/>
+            <a:ext cx="1645920" cy="166053"/>
           </a:xfrm>
           <a:prstGeom prst="rect">
             <a:avLst/>
@@ -3436,8 +3436,8 @@
         </p:blipFill>
         <p:spPr>
           <a:xfrm>
-            <a:off x="10298887" y="457200"/>
-            <a:ext cx="1115568" cy="166641"/>
+            <a:off x="9768535" y="457200"/>
+            <a:ext cx="1645920" cy="166053"/>
           </a:xfrm>
           <a:prstGeom prst="rect">
             <a:avLst/>
@@ -7040,8 +7040,8 @@
         </p:blipFill>
         <p:spPr>
           <a:xfrm>
-            <a:off x="10298887" y="457200"/>
-            <a:ext cx="1115568" cy="166641"/>
+            <a:off x="9768535" y="457200"/>
+            <a:ext cx="1645920" cy="166053"/>
           </a:xfrm>
           <a:prstGeom prst="rect">
             <a:avLst/>
@@ -7174,8 +7174,8 @@
         </p:blipFill>
         <p:spPr>
           <a:xfrm>
-            <a:off x="10298887" y="457200"/>
-            <a:ext cx="1115568" cy="166641"/>
+            <a:off x="9768535" y="457200"/>
+            <a:ext cx="1645920" cy="166053"/>
           </a:xfrm>
           <a:prstGeom prst="rect">
             <a:avLst/>
@@ -7954,8 +7954,8 @@
         </p:blipFill>
         <p:spPr>
           <a:xfrm>
-            <a:off x="10298887" y="457200"/>
-            <a:ext cx="1115568" cy="166641"/>
+            <a:off x="9768535" y="457200"/>
+            <a:ext cx="1645920" cy="166053"/>
           </a:xfrm>
           <a:prstGeom prst="rect">
             <a:avLst/>
@@ -8656,8 +8656,8 @@
         </p:blipFill>
         <p:spPr>
           <a:xfrm>
-            <a:off x="10298887" y="457200"/>
-            <a:ext cx="1115568" cy="166641"/>
+            <a:off x="9768535" y="457200"/>
+            <a:ext cx="1645920" cy="166053"/>
           </a:xfrm>
           <a:prstGeom prst="rect">
             <a:avLst/>
@@ -9865,8 +9865,8 @@
         </p:blipFill>
         <p:spPr>
           <a:xfrm>
-            <a:off x="10298887" y="457200"/>
-            <a:ext cx="1115568" cy="166641"/>
+            <a:off x="9768535" y="457200"/>
+            <a:ext cx="1645920" cy="166053"/>
           </a:xfrm>
           <a:prstGeom prst="rect">
             <a:avLst/>
@@ -10719,8 +10719,8 @@
         </p:blipFill>
         <p:spPr>
           <a:xfrm>
-            <a:off x="10298887" y="457200"/>
-            <a:ext cx="1115568" cy="166641"/>
+            <a:off x="9768535" y="457200"/>
+            <a:ext cx="1645920" cy="166053"/>
           </a:xfrm>
           <a:prstGeom prst="rect">
             <a:avLst/>
@@ -11714,8 +11714,8 @@
         </p:blipFill>
         <p:spPr>
           <a:xfrm>
-            <a:off x="10298887" y="457200"/>
-            <a:ext cx="1115568" cy="166641"/>
+            <a:off x="9768535" y="457200"/>
+            <a:ext cx="1645920" cy="166053"/>
           </a:xfrm>
           <a:prstGeom prst="rect">
             <a:avLst/>
@@ -12567,8 +12567,8 @@
         </p:blipFill>
         <p:spPr>
           <a:xfrm>
-            <a:off x="10298887" y="457200"/>
-            <a:ext cx="1115568" cy="166641"/>
+            <a:off x="9768535" y="457200"/>
+            <a:ext cx="1645920" cy="166053"/>
           </a:xfrm>
           <a:prstGeom prst="rect">
             <a:avLst/>
@@ -14339,8 +14339,8 @@
         </p:blipFill>
         <p:spPr>
           <a:xfrm>
-            <a:off x="10298887" y="457200"/>
-            <a:ext cx="1115568" cy="166641"/>
+            <a:off x="9768535" y="457200"/>
+            <a:ext cx="1645920" cy="166053"/>
           </a:xfrm>
           <a:prstGeom prst="rect">
             <a:avLst/>
@@ -14493,8 +14493,8 @@
         </p:blipFill>
         <p:spPr>
           <a:xfrm>
-            <a:off x="10298887" y="457200"/>
-            <a:ext cx="1115568" cy="166641"/>
+            <a:off x="9768535" y="457200"/>
+            <a:ext cx="1645920" cy="166053"/>
           </a:xfrm>
           <a:prstGeom prst="rect">
             <a:avLst/>
@@ -15638,8 +15638,8 @@
         </p:blipFill>
         <p:spPr>
           <a:xfrm>
-            <a:off x="10298887" y="457200"/>
-            <a:ext cx="1115568" cy="166641"/>
+            <a:off x="9768535" y="457200"/>
+            <a:ext cx="1645920" cy="166053"/>
           </a:xfrm>
           <a:prstGeom prst="rect">
             <a:avLst/>
@@ -15772,8 +15772,8 @@
         </p:blipFill>
         <p:spPr>
           <a:xfrm>
-            <a:off x="10298887" y="457200"/>
-            <a:ext cx="1115568" cy="166641"/>
+            <a:off x="9768535" y="457200"/>
+            <a:ext cx="1645920" cy="166053"/>
           </a:xfrm>
           <a:prstGeom prst="rect">
             <a:avLst/>
@@ -17186,8 +17186,8 @@
         </p:blipFill>
         <p:spPr>
           <a:xfrm>
-            <a:off x="10298887" y="457200"/>
-            <a:ext cx="1115568" cy="166641"/>
+            <a:off x="9768535" y="457200"/>
+            <a:ext cx="1645920" cy="166053"/>
           </a:xfrm>
           <a:prstGeom prst="rect">
             <a:avLst/>
@@ -18421,8 +18421,8 @@
         </p:blipFill>
         <p:spPr>
           <a:xfrm>
-            <a:off x="10298887" y="457200"/>
-            <a:ext cx="1115568" cy="166641"/>
+            <a:off x="9768535" y="457200"/>
+            <a:ext cx="1645920" cy="166053"/>
           </a:xfrm>
           <a:prstGeom prst="rect">
             <a:avLst/>
@@ -18555,8 +18555,8 @@
         </p:blipFill>
         <p:spPr>
           <a:xfrm>
-            <a:off x="10298887" y="457200"/>
-            <a:ext cx="1115568" cy="166641"/>
+            <a:off x="9768535" y="457200"/>
+            <a:ext cx="1645920" cy="166053"/>
           </a:xfrm>
           <a:prstGeom prst="rect">
             <a:avLst/>

</xml_diff>

<commit_message>
Add SLA and patching views to the dashboard; rebuild the close as a thank-you
Rebuild the concept dashboard so it shows the two views the team actually
wants rather than a generic bar chart: an SLA remediation panel plotting days
to fix against the deadline each severity sets, with breaches in red and the
deadline drawn as a dashed line, and a patching status panel showing how much
of the fleet is current per product. The KPI tiles keep the real numbers; the
panel figures are illustrative and the slide still says so.

Replace the closing slide entirely. It previously argued the intern's own
case — 'not just a good intern for my team, for the company' — which the
executive summary on slide 3 now covers. The last thing the room sees is
gratitude instead: thanks to the Information Security team, to the three
rotations, and to Cloud Operations and Development.
</commit_message>
<xml_diff>
--- a/out/Internship_Exit_Presentation_Stewart.pptx
+++ b/out/Internship_Exit_Presentation_Stewart.pptx
@@ -14665,7 +14665,7 @@
         <p:spPr>
           <a:xfrm>
             <a:off x="777240" y="2011680"/>
-            <a:ext cx="4160520" cy="731520"/>
+            <a:ext cx="4160520" cy="822960"/>
           </a:xfrm>
           <a:prstGeom prst="rect">
             <a:avLst/>
@@ -14692,7 +14692,7 @@
                 <a:ea typeface="Montserrat" pitchFamily="34" charset="-122"/>
                 <a:cs typeface="Montserrat" pitchFamily="34" charset="-120"/>
               </a:rPr>
-              <a:t>Today these four systems each hold one piece of the story, and someone stitches them together by hand. A single view would close that gap.</a:t>
+              <a:t>Two views would close the gap: an SLA remediation dashboard showing whether flaws are fixed inside their deadline, and a patching dashboard showing how much of the fleet is current.</a:t>
             </a:r>
             <a:endParaRPr lang="en-US" sz="1250" dirty="0"/>
           </a:p>
@@ -14706,7 +14706,7 @@
         </p:nvSpPr>
         <p:spPr>
           <a:xfrm>
-            <a:off x="795528" y="3118104"/>
+            <a:off x="795528" y="3044952"/>
             <a:ext cx="182880" cy="182880"/>
           </a:xfrm>
           <a:prstGeom prst="ellipse">
@@ -14731,7 +14731,7 @@
         </p:nvSpPr>
         <p:spPr>
           <a:xfrm>
-            <a:off x="850392" y="3172968"/>
+            <a:off x="850392" y="3099816"/>
             <a:ext cx="73152" cy="73152"/>
           </a:xfrm>
           <a:prstGeom prst="ellipse">
@@ -14751,7 +14751,7 @@
         </p:nvSpPr>
         <p:spPr>
           <a:xfrm>
-            <a:off x="882396" y="3319272"/>
+            <a:off x="882396" y="3246120"/>
             <a:ext cx="10973" cy="457200"/>
           </a:xfrm>
           <a:prstGeom prst="rect">
@@ -14771,7 +14771,7 @@
         </p:nvSpPr>
         <p:spPr>
           <a:xfrm>
-            <a:off x="1143000" y="3054096"/>
+            <a:off x="1143000" y="2980944"/>
             <a:ext cx="3794760" cy="256032"/>
           </a:xfrm>
           <a:prstGeom prst="rect">
@@ -14810,7 +14810,7 @@
         </p:nvSpPr>
         <p:spPr>
           <a:xfrm>
-            <a:off x="1143000" y="3310128"/>
+            <a:off x="1143000" y="3236976"/>
             <a:ext cx="3749040" cy="274320"/>
           </a:xfrm>
           <a:prstGeom prst="rect">
@@ -14849,7 +14849,7 @@
         </p:nvSpPr>
         <p:spPr>
           <a:xfrm>
-            <a:off x="795528" y="3776472"/>
+            <a:off x="795528" y="3630168"/>
             <a:ext cx="182880" cy="182880"/>
           </a:xfrm>
           <a:prstGeom prst="ellipse">
@@ -14874,7 +14874,7 @@
         </p:nvSpPr>
         <p:spPr>
           <a:xfrm>
-            <a:off x="850392" y="3831336"/>
+            <a:off x="850392" y="3685032"/>
             <a:ext cx="73152" cy="73152"/>
           </a:xfrm>
           <a:prstGeom prst="ellipse">
@@ -14894,7 +14894,7 @@
         </p:nvSpPr>
         <p:spPr>
           <a:xfrm>
-            <a:off x="882396" y="3977640"/>
+            <a:off x="882396" y="3831336"/>
             <a:ext cx="10973" cy="457200"/>
           </a:xfrm>
           <a:prstGeom prst="rect">
@@ -14914,7 +14914,7 @@
         </p:nvSpPr>
         <p:spPr>
           <a:xfrm>
-            <a:off x="1143000" y="3712464"/>
+            <a:off x="1143000" y="3566160"/>
             <a:ext cx="3794760" cy="256032"/>
           </a:xfrm>
           <a:prstGeom prst="rect">
@@ -14953,7 +14953,7 @@
         </p:nvSpPr>
         <p:spPr>
           <a:xfrm>
-            <a:off x="1143000" y="3968496"/>
+            <a:off x="1143000" y="3822192"/>
             <a:ext cx="3749040" cy="274320"/>
           </a:xfrm>
           <a:prstGeom prst="rect">
@@ -14992,7 +14992,7 @@
         </p:nvSpPr>
         <p:spPr>
           <a:xfrm>
-            <a:off x="795528" y="4434840"/>
+            <a:off x="795528" y="4215384"/>
             <a:ext cx="182880" cy="182880"/>
           </a:xfrm>
           <a:prstGeom prst="ellipse">
@@ -15017,7 +15017,7 @@
         </p:nvSpPr>
         <p:spPr>
           <a:xfrm>
-            <a:off x="850392" y="4489704"/>
+            <a:off x="850392" y="4270248"/>
             <a:ext cx="73152" cy="73152"/>
           </a:xfrm>
           <a:prstGeom prst="ellipse">
@@ -15037,7 +15037,7 @@
         </p:nvSpPr>
         <p:spPr>
           <a:xfrm>
-            <a:off x="882396" y="4636008"/>
+            <a:off x="882396" y="4416552"/>
             <a:ext cx="10973" cy="457200"/>
           </a:xfrm>
           <a:prstGeom prst="rect">
@@ -15057,7 +15057,7 @@
         </p:nvSpPr>
         <p:spPr>
           <a:xfrm>
-            <a:off x="1143000" y="4370832"/>
+            <a:off x="1143000" y="4151376"/>
             <a:ext cx="3794760" cy="256032"/>
           </a:xfrm>
           <a:prstGeom prst="rect">
@@ -15096,7 +15096,7 @@
         </p:nvSpPr>
         <p:spPr>
           <a:xfrm>
-            <a:off x="1143000" y="4626864"/>
+            <a:off x="1143000" y="4407408"/>
             <a:ext cx="3749040" cy="274320"/>
           </a:xfrm>
           <a:prstGeom prst="rect">
@@ -15135,7 +15135,7 @@
         </p:nvSpPr>
         <p:spPr>
           <a:xfrm>
-            <a:off x="795528" y="5093208"/>
+            <a:off x="795528" y="4800600"/>
             <a:ext cx="182880" cy="182880"/>
           </a:xfrm>
           <a:prstGeom prst="ellipse">
@@ -15160,7 +15160,7 @@
         </p:nvSpPr>
         <p:spPr>
           <a:xfrm>
-            <a:off x="850392" y="5148072"/>
+            <a:off x="850392" y="4855464"/>
             <a:ext cx="73152" cy="73152"/>
           </a:xfrm>
           <a:prstGeom prst="ellipse">
@@ -15180,7 +15180,7 @@
         </p:nvSpPr>
         <p:spPr>
           <a:xfrm>
-            <a:off x="1143000" y="5029200"/>
+            <a:off x="1143000" y="4736592"/>
             <a:ext cx="3794760" cy="256032"/>
           </a:xfrm>
           <a:prstGeom prst="rect">
@@ -15219,7 +15219,7 @@
         </p:nvSpPr>
         <p:spPr>
           <a:xfrm>
-            <a:off x="1143000" y="5285232"/>
+            <a:off x="1143000" y="4992624"/>
             <a:ext cx="3749040" cy="274320"/>
           </a:xfrm>
           <a:prstGeom prst="rect">
@@ -15258,8 +15258,8 @@
         </p:nvSpPr>
         <p:spPr>
           <a:xfrm>
-            <a:off x="777240" y="5541264"/>
-            <a:ext cx="4160520" cy="566928"/>
+            <a:off x="777240" y="5449824"/>
+            <a:ext cx="4160520" cy="548640"/>
           </a:xfrm>
           <a:prstGeom prst="rect">
             <a:avLst/>
@@ -15326,7 +15326,7 @@
         <p:spPr>
           <a:xfrm>
             <a:off x="5358384" y="2103120"/>
-            <a:ext cx="6056071" cy="3499063"/>
+            <a:ext cx="6056071" cy="3633643"/>
           </a:xfrm>
           <a:prstGeom prst="rect">
             <a:avLst/>
@@ -15341,7 +15341,7 @@
         </p:nvSpPr>
         <p:spPr>
           <a:xfrm>
-            <a:off x="5358384" y="5748487"/>
+            <a:off x="5358384" y="5883067"/>
             <a:ext cx="6056071" cy="237744"/>
           </a:xfrm>
           <a:prstGeom prst="rect">
@@ -15437,8 +15437,8 @@
         </p:blipFill>
         <p:spPr>
           <a:xfrm>
-            <a:off x="8595360" y="2926080"/>
-            <a:ext cx="4754880" cy="4754880"/>
+            <a:off x="8595360" y="2377440"/>
+            <a:ext cx="5120640" cy="5120640"/>
           </a:xfrm>
           <a:prstGeom prst="rect">
             <a:avLst/>
@@ -15477,7 +15477,7 @@
         </p:nvSpPr>
         <p:spPr>
           <a:xfrm>
-            <a:off x="777240" y="658368"/>
+            <a:off x="777240" y="713232"/>
             <a:ext cx="5486400" cy="237744"/>
           </a:xfrm>
           <a:prstGeom prst="rect">
@@ -15502,7 +15502,7 @@
                 <a:ea typeface="Montserrat SemiBold" pitchFamily="34" charset="-122"/>
                 <a:cs typeface="Montserrat SemiBold" pitchFamily="34" charset="-120"/>
               </a:rPr>
-              <a:t>SUMMARY</a:t>
+              <a:t>IN CLOSING</a:t>
             </a:r>
             <a:endParaRPr lang="en-US" sz="1000" dirty="0"/>
           </a:p>
@@ -15516,27 +15516,24 @@
         </p:nvSpPr>
         <p:spPr>
           <a:xfrm>
-            <a:off x="777240" y="987552"/>
-            <a:ext cx="9509760" cy="1133856"/>
-          </a:xfrm>
-          <a:prstGeom prst="rect">
-            <a:avLst/>
-          </a:prstGeom>
-          <a:noFill/>
-          <a:ln/>
-        </p:spPr>
-        <p:txBody>
-          <a:bodyPr wrap="square" lIns="0" tIns="0" rIns="0" bIns="0" rtlCol="0" anchor="t"/>
-          <a:lstStyle/>
-          <a:p>
-            <a:pPr indent="0" marL="0">
-              <a:lnSpc>
-                <a:spcPct val="102000"/>
-              </a:lnSpc>
-              <a:buNone/>
-            </a:pPr>
-            <a:r>
-              <a:rPr lang="en-US" sz="3200" spc="-80" kern="0" dirty="0">
+            <a:off x="777240" y="1042416"/>
+            <a:ext cx="7315200" cy="896112"/>
+          </a:xfrm>
+          <a:prstGeom prst="rect">
+            <a:avLst/>
+          </a:prstGeom>
+          <a:noFill/>
+          <a:ln/>
+        </p:spPr>
+        <p:txBody>
+          <a:bodyPr wrap="square" lIns="0" tIns="0" rIns="0" bIns="0" rtlCol="0" anchor="t"/>
+          <a:lstStyle/>
+          <a:p>
+            <a:pPr indent="0" marL="0">
+              <a:buNone/>
+            </a:pPr>
+            <a:r>
+              <a:rPr lang="en-US" sz="4600" spc="-120" kern="0" dirty="0">
                 <a:solidFill>
                   <a:srgbClr val="FFFFFF"/>
                 </a:solidFill>
@@ -15544,29 +15541,9 @@
                 <a:ea typeface="Montserrat ExtraBold" pitchFamily="34" charset="-122"/>
                 <a:cs typeface="Montserrat ExtraBold" pitchFamily="34" charset="-120"/>
               </a:rPr>
-              <a:t>Not just a good intern for my team —</a:t>
-            </a:r>
-            <a:endParaRPr lang="en-US" sz="3200" dirty="0"/>
-          </a:p>
-          <a:p>
-            <a:pPr indent="0" marL="0">
-              <a:lnSpc>
-                <a:spcPct val="102000"/>
-              </a:lnSpc>
-              <a:buNone/>
-            </a:pPr>
-            <a:r>
-              <a:rPr lang="en-US" sz="3200" spc="-80" kern="0" dirty="0">
-                <a:solidFill>
-                  <a:srgbClr val="FFFFFF"/>
-                </a:solidFill>
-                <a:latin typeface="Montserrat ExtraBold" pitchFamily="34" charset="0"/>
-                <a:ea typeface="Montserrat ExtraBold" pitchFamily="34" charset="-122"/>
-                <a:cs typeface="Montserrat ExtraBold" pitchFamily="34" charset="-120"/>
-              </a:rPr>
-              <a:t>for the company</a:t>
-            </a:r>
-            <a:endParaRPr lang="en-US" sz="3200" dirty="0"/>
+              <a:t>Thank you</a:t>
+            </a:r>
+            <a:endParaRPr lang="en-US" sz="4600" dirty="0"/>
           </a:p>
         </p:txBody>
       </p:sp>
@@ -15578,7 +15555,7 @@
         </p:nvSpPr>
         <p:spPr>
           <a:xfrm>
-            <a:off x="777240" y="2249424"/>
+            <a:off x="777240" y="2066544"/>
             <a:ext cx="640080" cy="50292"/>
           </a:xfrm>
           <a:prstGeom prst="rect">
@@ -15592,32 +15569,45 @@
       </p:sp>
       <p:sp>
         <p:nvSpPr>
-          <p:cNvPr id="8" name="Shape 3"/>
-          <p:cNvSpPr/>
-          <p:nvPr/>
-        </p:nvSpPr>
-        <p:spPr>
-          <a:xfrm>
-            <a:off x="777240" y="2615184"/>
-            <a:ext cx="5175504" cy="1280160"/>
-          </a:xfrm>
-          <a:prstGeom prst="roundRect">
-            <a:avLst>
-              <a:gd name="adj" fmla="val 4286"/>
-            </a:avLst>
-          </a:prstGeom>
-          <a:solidFill>
-            <a:srgbClr val="FFFFFF">
-              <a:alpha val="12000"/>
-            </a:srgbClr>
-          </a:solidFill>
-          <a:ln w="9525">
-            <a:solidFill>
-              <a:srgbClr val="CA949C"/>
-            </a:solidFill>
-            <a:prstDash val="solid"/>
-          </a:ln>
-        </p:spPr>
+          <p:cNvPr id="8" name="Text 3"/>
+          <p:cNvSpPr txBox="1"/>
+          <p:nvPr/>
+        </p:nvSpPr>
+        <p:spPr>
+          <a:xfrm>
+            <a:off x="777240" y="2340864"/>
+            <a:ext cx="7863840" cy="566928"/>
+          </a:xfrm>
+          <a:prstGeom prst="rect">
+            <a:avLst/>
+          </a:prstGeom>
+          <a:noFill/>
+          <a:ln/>
+        </p:spPr>
+        <p:txBody>
+          <a:bodyPr wrap="square" lIns="0" tIns="0" rIns="0" bIns="0" rtlCol="0" anchor="t"/>
+          <a:lstStyle/>
+          <a:p>
+            <a:pPr indent="0" marL="0">
+              <a:lnSpc>
+                <a:spcPct val="130000"/>
+              </a:lnSpc>
+              <a:buNone/>
+            </a:pPr>
+            <a:r>
+              <a:rPr lang="en-US" sz="1400" dirty="0">
+                <a:solidFill>
+                  <a:srgbClr val="DAB4BA"/>
+                </a:solidFill>
+                <a:latin typeface="Montserrat Medium" pitchFamily="34" charset="0"/>
+                <a:ea typeface="Montserrat Medium" pitchFamily="34" charset="-122"/>
+                <a:cs typeface="Montserrat Medium" pitchFamily="34" charset="-120"/>
+              </a:rPr>
+              <a:t>Everything in this deck exists because people here made room for an intern to do real work — and because plenty of them pushed back on it until it was right.</a:t>
+            </a:r>
+            <a:endParaRPr lang="en-US" sz="1400" dirty="0"/>
+          </a:p>
+        </p:txBody>
       </p:sp>
       <p:sp>
         <p:nvSpPr>
@@ -15627,8 +15617,8 @@
         </p:nvSpPr>
         <p:spPr>
           <a:xfrm>
-            <a:off x="777240" y="2615184"/>
-            <a:ext cx="45720" cy="1280160"/>
+            <a:off x="777240" y="3182112"/>
+            <a:ext cx="45720" cy="384048"/>
           </a:xfrm>
           <a:prstGeom prst="rect">
             <a:avLst/>
@@ -15647,24 +15637,24 @@
         </p:nvSpPr>
         <p:spPr>
           <a:xfrm>
-            <a:off x="1033272" y="2816352"/>
-            <a:ext cx="4663440" cy="274320"/>
-          </a:xfrm>
-          <a:prstGeom prst="rect">
-            <a:avLst/>
-          </a:prstGeom>
-          <a:noFill/>
-          <a:ln/>
-        </p:spPr>
-        <p:txBody>
-          <a:bodyPr wrap="square" lIns="0" tIns="0" rIns="0" bIns="0" rtlCol="0" anchor="t"/>
-          <a:lstStyle/>
-          <a:p>
-            <a:pPr indent="0" marL="0">
-              <a:buNone/>
-            </a:pPr>
-            <a:r>
-              <a:rPr lang="en-US" sz="1350" dirty="0">
+            <a:off x="1014984" y="3127248"/>
+            <a:ext cx="9692640" cy="274320"/>
+          </a:xfrm>
+          <a:prstGeom prst="rect">
+            <a:avLst/>
+          </a:prstGeom>
+          <a:noFill/>
+          <a:ln/>
+        </p:spPr>
+        <p:txBody>
+          <a:bodyPr wrap="square" lIns="0" tIns="0" rIns="0" bIns="0" rtlCol="0" anchor="t"/>
+          <a:lstStyle/>
+          <a:p>
+            <a:pPr indent="0" marL="0">
+              <a:buNone/>
+            </a:pPr>
+            <a:r>
+              <a:rPr lang="en-US" sz="1400" dirty="0">
                 <a:solidFill>
                   <a:srgbClr val="FFFFFF"/>
                 </a:solidFill>
@@ -15672,9 +15662,9 @@
                 <a:ea typeface="Montserrat SemiBold" pitchFamily="34" charset="-122"/>
                 <a:cs typeface="Montserrat SemiBold" pitchFamily="34" charset="-120"/>
               </a:rPr>
-              <a:t>Left tools behind, not just results</a:t>
-            </a:r>
-            <a:endParaRPr lang="en-US" sz="1350" dirty="0"/>
+              <a:t>To the Information Security team</a:t>
+            </a:r>
+            <a:endParaRPr lang="en-US" sz="1400" dirty="0"/>
           </a:p>
         </p:txBody>
       </p:sp>
@@ -15686,8 +15676,8 @@
         </p:nvSpPr>
         <p:spPr>
           <a:xfrm>
-            <a:off x="1033272" y="3127248"/>
-            <a:ext cx="4663440" cy="603504"/>
+            <a:off x="1014984" y="3419856"/>
+            <a:ext cx="9326880" cy="310896"/>
           </a:xfrm>
           <a:prstGeom prst="rect">
             <a:avLst/>
@@ -15708,13 +15698,13 @@
             <a:r>
               <a:rPr lang="en-US" sz="1100" dirty="0">
                 <a:solidFill>
-                  <a:srgbClr val="E4C9CE"/>
+                  <a:srgbClr val="DAB4BA"/>
                 </a:solidFill>
                 <a:latin typeface="Montserrat" pitchFamily="34" charset="0"/>
                 <a:ea typeface="Montserrat" pitchFamily="34" charset="-122"/>
                 <a:cs typeface="Montserrat" pitchFamily="34" charset="-120"/>
               </a:rPr>
-              <a:t>The scripts and frameworks I built are still in use by the team after I go.</a:t>
+              <a:t>For handing me problems that actually mattered, and trusting me to work on them properly.</a:t>
             </a:r>
             <a:endParaRPr lang="en-US" sz="1100" dirty="0"/>
           </a:p>
@@ -15728,25 +15718,16 @@
         </p:nvSpPr>
         <p:spPr>
           <a:xfrm>
-            <a:off x="6236208" y="2615184"/>
-            <a:ext cx="5175504" cy="1280160"/>
-          </a:xfrm>
-          <a:prstGeom prst="roundRect">
-            <a:avLst>
-              <a:gd name="adj" fmla="val 4286"/>
-            </a:avLst>
+            <a:off x="777240" y="3858768"/>
+            <a:ext cx="10637215" cy="7315"/>
+          </a:xfrm>
+          <a:prstGeom prst="rect">
+            <a:avLst/>
           </a:prstGeom>
           <a:solidFill>
-            <a:srgbClr val="FFFFFF">
-              <a:alpha val="12000"/>
-            </a:srgbClr>
+            <a:srgbClr val="CA949C"/>
           </a:solidFill>
-          <a:ln w="9525">
-            <a:solidFill>
-              <a:srgbClr val="CA949C"/>
-            </a:solidFill>
-            <a:prstDash val="solid"/>
-          </a:ln>
+          <a:ln/>
         </p:spPr>
       </p:sp>
       <p:sp>
@@ -15757,8 +15738,8 @@
         </p:nvSpPr>
         <p:spPr>
           <a:xfrm>
-            <a:off x="6236208" y="2615184"/>
-            <a:ext cx="45720" cy="1280160"/>
+            <a:off x="777240" y="4041648"/>
+            <a:ext cx="45720" cy="384048"/>
           </a:xfrm>
           <a:prstGeom prst="rect">
             <a:avLst/>
@@ -15777,24 +15758,24 @@
         </p:nvSpPr>
         <p:spPr>
           <a:xfrm>
-            <a:off x="6492240" y="2816352"/>
-            <a:ext cx="4663440" cy="274320"/>
-          </a:xfrm>
-          <a:prstGeom prst="rect">
-            <a:avLst/>
-          </a:prstGeom>
-          <a:noFill/>
-          <a:ln/>
-        </p:spPr>
-        <p:txBody>
-          <a:bodyPr wrap="square" lIns="0" tIns="0" rIns="0" bIns="0" rtlCol="0" anchor="t"/>
-          <a:lstStyle/>
-          <a:p>
-            <a:pPr indent="0" marL="0">
-              <a:buNone/>
-            </a:pPr>
-            <a:r>
-              <a:rPr lang="en-US" sz="1350" dirty="0">
+            <a:off x="1014984" y="3986784"/>
+            <a:ext cx="9692640" cy="274320"/>
+          </a:xfrm>
+          <a:prstGeom prst="rect">
+            <a:avLst/>
+          </a:prstGeom>
+          <a:noFill/>
+          <a:ln/>
+        </p:spPr>
+        <p:txBody>
+          <a:bodyPr wrap="square" lIns="0" tIns="0" rIns="0" bIns="0" rtlCol="0" anchor="t"/>
+          <a:lstStyle/>
+          <a:p>
+            <a:pPr indent="0" marL="0">
+              <a:buNone/>
+            </a:pPr>
+            <a:r>
+              <a:rPr lang="en-US" sz="1400" dirty="0">
                 <a:solidFill>
                   <a:srgbClr val="FFFFFF"/>
                 </a:solidFill>
@@ -15802,9 +15783,9 @@
                 <a:ea typeface="Montserrat SemiBold" pitchFamily="34" charset="-122"/>
                 <a:cs typeface="Montserrat SemiBold" pitchFamily="34" charset="-120"/>
               </a:rPr>
-              <a:t>Worked across team lines</a:t>
-            </a:r>
-            <a:endParaRPr lang="en-US" sz="1350" dirty="0"/>
+              <a:t>To Vulnerability Management, Application Security and Network Security</a:t>
+            </a:r>
+            <a:endParaRPr lang="en-US" sz="1400" dirty="0"/>
           </a:p>
         </p:txBody>
       </p:sp>
@@ -15816,8 +15797,8 @@
         </p:nvSpPr>
         <p:spPr>
           <a:xfrm>
-            <a:off x="6492240" y="3127248"/>
-            <a:ext cx="4663440" cy="603504"/>
+            <a:off x="1014984" y="4279392"/>
+            <a:ext cx="9326880" cy="310896"/>
           </a:xfrm>
           <a:prstGeom prst="rect">
             <a:avLst/>
@@ -15838,13 +15819,13 @@
             <a:r>
               <a:rPr lang="en-US" sz="1100" dirty="0">
                 <a:solidFill>
-                  <a:srgbClr val="E4C9CE"/>
+                  <a:srgbClr val="DAB4BA"/>
                 </a:solidFill>
                 <a:latin typeface="Montserrat" pitchFamily="34" charset="0"/>
                 <a:ea typeface="Montserrat" pitchFamily="34" charset="-122"/>
                 <a:cs typeface="Montserrat" pitchFamily="34" charset="-120"/>
               </a:rPr>
-              <a:t>Vulnerability Management, Application Security and Network Security — plus Cloud Operations and Development.</a:t>
+              <a:t>Three rotations, three different ways of looking at the same job. I learned something distinct in each one.</a:t>
             </a:r>
             <a:endParaRPr lang="en-US" sz="1100" dirty="0"/>
           </a:p>
@@ -15858,25 +15839,16 @@
         </p:nvSpPr>
         <p:spPr>
           <a:xfrm>
-            <a:off x="777240" y="4133088"/>
-            <a:ext cx="5175504" cy="1280160"/>
-          </a:xfrm>
-          <a:prstGeom prst="roundRect">
-            <a:avLst>
-              <a:gd name="adj" fmla="val 4286"/>
-            </a:avLst>
+            <a:off x="777240" y="4718304"/>
+            <a:ext cx="10637215" cy="7315"/>
+          </a:xfrm>
+          <a:prstGeom prst="rect">
+            <a:avLst/>
           </a:prstGeom>
           <a:solidFill>
-            <a:srgbClr val="FFFFFF">
-              <a:alpha val="12000"/>
-            </a:srgbClr>
+            <a:srgbClr val="CA949C"/>
           </a:solidFill>
-          <a:ln w="9525">
-            <a:solidFill>
-              <a:srgbClr val="CA949C"/>
-            </a:solidFill>
-            <a:prstDash val="solid"/>
-          </a:ln>
+          <a:ln/>
         </p:spPr>
       </p:sp>
       <p:sp>
@@ -15887,8 +15859,8 @@
         </p:nvSpPr>
         <p:spPr>
           <a:xfrm>
-            <a:off x="777240" y="4133088"/>
-            <a:ext cx="45720" cy="1280160"/>
+            <a:off x="777240" y="4901184"/>
+            <a:ext cx="45720" cy="384048"/>
           </a:xfrm>
           <a:prstGeom prst="rect">
             <a:avLst/>
@@ -15907,24 +15879,24 @@
         </p:nvSpPr>
         <p:spPr>
           <a:xfrm>
-            <a:off x="1033272" y="4334256"/>
-            <a:ext cx="4663440" cy="274320"/>
-          </a:xfrm>
-          <a:prstGeom prst="rect">
-            <a:avLst/>
-          </a:prstGeom>
-          <a:noFill/>
-          <a:ln/>
-        </p:spPr>
-        <p:txBody>
-          <a:bodyPr wrap="square" lIns="0" tIns="0" rIns="0" bIns="0" rtlCol="0" anchor="t"/>
-          <a:lstStyle/>
-          <a:p>
-            <a:pPr indent="0" marL="0">
-              <a:buNone/>
-            </a:pPr>
-            <a:r>
-              <a:rPr lang="en-US" sz="1350" dirty="0">
+            <a:off x="1014984" y="4846320"/>
+            <a:ext cx="9692640" cy="274320"/>
+          </a:xfrm>
+          <a:prstGeom prst="rect">
+            <a:avLst/>
+          </a:prstGeom>
+          <a:noFill/>
+          <a:ln/>
+        </p:spPr>
+        <p:txBody>
+          <a:bodyPr wrap="square" lIns="0" tIns="0" rIns="0" bIns="0" rtlCol="0" anchor="t"/>
+          <a:lstStyle/>
+          <a:p>
+            <a:pPr indent="0" marL="0">
+              <a:buNone/>
+            </a:pPr>
+            <a:r>
+              <a:rPr lang="en-US" sz="1400" dirty="0">
                 <a:solidFill>
                   <a:srgbClr val="FFFFFF"/>
                 </a:solidFill>
@@ -15932,9 +15904,9 @@
                 <a:ea typeface="Montserrat SemiBold" pitchFamily="34" charset="-122"/>
                 <a:cs typeface="Montserrat SemiBold" pitchFamily="34" charset="-120"/>
               </a:rPr>
-              <a:t>Built proof, not opinions</a:t>
-            </a:r>
-            <a:endParaRPr lang="en-US" sz="1350" dirty="0"/>
+              <a:t>To Cloud Operations and Development</a:t>
+            </a:r>
+            <a:endParaRPr lang="en-US" sz="1400" dirty="0"/>
           </a:p>
         </p:txBody>
       </p:sp>
@@ -15946,8 +15918,8 @@
         </p:nvSpPr>
         <p:spPr>
           <a:xfrm>
-            <a:off x="1033272" y="4645152"/>
-            <a:ext cx="4663440" cy="603504"/>
+            <a:off x="1014984" y="5138928"/>
+            <a:ext cx="9326880" cy="310896"/>
           </a:xfrm>
           <a:prstGeom prst="rect">
             <a:avLst/>
@@ -15968,13 +15940,13 @@
             <a:r>
               <a:rPr lang="en-US" sz="1100" dirty="0">
                 <a:solidFill>
-                  <a:srgbClr val="E4C9CE"/>
+                  <a:srgbClr val="DAB4BA"/>
                 </a:solidFill>
                 <a:latin typeface="Montserrat" pitchFamily="34" charset="0"/>
                 <a:ea typeface="Montserrat" pitchFamily="34" charset="-122"/>
                 <a:cs typeface="Montserrat" pitchFamily="34" charset="-120"/>
               </a:rPr>
-              <a:t>Every number here is either measured and independently checked, or clearly labelled as an estimate.</a:t>
+              <a:t>For making time for someone from another team who kept turning up with questions.</a:t>
             </a:r>
             <a:endParaRPr lang="en-US" sz="1100" dirty="0"/>
           </a:p>
@@ -15982,79 +15954,30 @@
       </p:sp>
       <p:sp>
         <p:nvSpPr>
-          <p:cNvPr id="20" name="Shape 15"/>
-          <p:cNvSpPr/>
-          <p:nvPr/>
-        </p:nvSpPr>
-        <p:spPr>
-          <a:xfrm>
-            <a:off x="6236208" y="4133088"/>
-            <a:ext cx="5175504" cy="1280160"/>
-          </a:xfrm>
-          <a:prstGeom prst="roundRect">
-            <a:avLst>
-              <a:gd name="adj" fmla="val 4286"/>
-            </a:avLst>
-          </a:prstGeom>
-          <a:solidFill>
-            <a:srgbClr val="FFFFFF">
-              <a:alpha val="12000"/>
-            </a:srgbClr>
-          </a:solidFill>
-          <a:ln w="9525">
-            <a:solidFill>
-              <a:srgbClr val="CA949C"/>
-            </a:solidFill>
-            <a:prstDash val="solid"/>
-          </a:ln>
-        </p:spPr>
-      </p:sp>
-      <p:sp>
-        <p:nvSpPr>
-          <p:cNvPr id="21" name="Shape 16"/>
-          <p:cNvSpPr/>
-          <p:nvPr/>
-        </p:nvSpPr>
-        <p:spPr>
-          <a:xfrm>
-            <a:off x="6236208" y="4133088"/>
-            <a:ext cx="45720" cy="1280160"/>
-          </a:xfrm>
-          <a:prstGeom prst="rect">
-            <a:avLst/>
-          </a:prstGeom>
-          <a:solidFill>
-            <a:srgbClr val="FFFFFF"/>
-          </a:solidFill>
-          <a:ln/>
-        </p:spPr>
-      </p:sp>
-      <p:sp>
-        <p:nvSpPr>
-          <p:cNvPr id="22" name="Text 17"/>
-          <p:cNvSpPr txBox="1"/>
-          <p:nvPr/>
-        </p:nvSpPr>
-        <p:spPr>
-          <a:xfrm>
-            <a:off x="6492240" y="4334256"/>
-            <a:ext cx="4663440" cy="274320"/>
-          </a:xfrm>
-          <a:prstGeom prst="rect">
-            <a:avLst/>
-          </a:prstGeom>
-          <a:noFill/>
-          <a:ln/>
-        </p:spPr>
-        <p:txBody>
-          <a:bodyPr wrap="square" lIns="0" tIns="0" rIns="0" bIns="0" rtlCol="0" anchor="t"/>
-          <a:lstStyle/>
-          <a:p>
-            <a:pPr indent="0" marL="0">
-              <a:buNone/>
-            </a:pPr>
-            <a:r>
-              <a:rPr lang="en-US" sz="1350" dirty="0">
+          <p:cNvPr id="20" name="Text 15"/>
+          <p:cNvSpPr txBox="1"/>
+          <p:nvPr/>
+        </p:nvSpPr>
+        <p:spPr>
+          <a:xfrm>
+            <a:off x="777240" y="5669280"/>
+            <a:ext cx="6949440" cy="310896"/>
+          </a:xfrm>
+          <a:prstGeom prst="rect">
+            <a:avLst/>
+          </a:prstGeom>
+          <a:noFill/>
+          <a:ln/>
+        </p:spPr>
+        <p:txBody>
+          <a:bodyPr wrap="square" lIns="0" tIns="0" rIns="0" bIns="0" rtlCol="0" anchor="t"/>
+          <a:lstStyle/>
+          <a:p>
+            <a:pPr indent="0" marL="0">
+              <a:buNone/>
+            </a:pPr>
+            <a:r>
+              <a:rPr lang="en-US" sz="1600" dirty="0">
                 <a:solidFill>
                   <a:srgbClr val="FFFFFF"/>
                 </a:solidFill>
@@ -16062,166 +15985,85 @@
                 <a:ea typeface="Montserrat SemiBold" pitchFamily="34" charset="-122"/>
                 <a:cs typeface="Montserrat SemiBold" pitchFamily="34" charset="-120"/>
               </a:rPr>
-              <a:t>Built to scale beyond one team</a:t>
-            </a:r>
-            <a:endParaRPr lang="en-US" sz="1350" dirty="0"/>
-          </a:p>
-        </p:txBody>
-      </p:sp>
-      <p:sp>
-        <p:nvSpPr>
-          <p:cNvPr id="23" name="Text 18"/>
-          <p:cNvSpPr txBox="1"/>
-          <p:nvPr/>
-        </p:nvSpPr>
-        <p:spPr>
-          <a:xfrm>
-            <a:off x="6492240" y="4645152"/>
-            <a:ext cx="4663440" cy="603504"/>
-          </a:xfrm>
-          <a:prstGeom prst="rect">
-            <a:avLst/>
-          </a:prstGeom>
-          <a:noFill/>
-          <a:ln/>
-        </p:spPr>
-        <p:txBody>
-          <a:bodyPr wrap="square" lIns="0" tIns="0" rIns="0" bIns="0" rtlCol="0" anchor="t"/>
-          <a:lstStyle/>
-          <a:p>
-            <a:pPr indent="0" marL="0">
-              <a:lnSpc>
-                <a:spcPct val="120000"/>
-              </a:lnSpc>
-              <a:buNone/>
-            </a:pPr>
-            <a:r>
-              <a:rPr lang="en-US" sz="1100" dirty="0">
+              <a:t>Happy to take any questions.</a:t>
+            </a:r>
+            <a:endParaRPr lang="en-US" sz="1600" dirty="0"/>
+          </a:p>
+        </p:txBody>
+      </p:sp>
+      <p:sp>
+        <p:nvSpPr>
+          <p:cNvPr id="21" name="Text 16"/>
+          <p:cNvSpPr txBox="1"/>
+          <p:nvPr/>
+        </p:nvSpPr>
+        <p:spPr>
+          <a:xfrm>
+            <a:off x="777240" y="6016752"/>
+            <a:ext cx="7680960" cy="256032"/>
+          </a:xfrm>
+          <a:prstGeom prst="rect">
+            <a:avLst/>
+          </a:prstGeom>
+          <a:noFill/>
+          <a:ln/>
+        </p:spPr>
+        <p:txBody>
+          <a:bodyPr wrap="square" lIns="0" tIns="0" rIns="0" bIns="0" rtlCol="0" anchor="t"/>
+          <a:lstStyle/>
+          <a:p>
+            <a:pPr indent="0" marL="0">
+              <a:buNone/>
+            </a:pPr>
+            <a:r>
+              <a:rPr lang="en-US" sz="950" spc="30" kern="0" dirty="0">
+                <a:solidFill>
+                  <a:srgbClr val="DAB4BA"/>
+                </a:solidFill>
+                <a:latin typeface="Montserrat Medium" pitchFamily="34" charset="0"/>
+                <a:ea typeface="Montserrat Medium" pitchFamily="34" charset="-122"/>
+                <a:cs typeface="Montserrat Medium" pitchFamily="34" charset="-120"/>
+              </a:rPr>
+              <a:t>Next up: the PWPA and PJPT certifications, heading toward penetration testing.</a:t>
+            </a:r>
+            <a:endParaRPr lang="en-US" sz="950" dirty="0"/>
+          </a:p>
+        </p:txBody>
+      </p:sp>
+      <p:sp>
+        <p:nvSpPr>
+          <p:cNvPr id="22" name="Text 17"/>
+          <p:cNvSpPr txBox="1"/>
+          <p:nvPr/>
+        </p:nvSpPr>
+        <p:spPr>
+          <a:xfrm>
+            <a:off x="777240" y="6327648"/>
+            <a:ext cx="7315200" cy="201168"/>
+          </a:xfrm>
+          <a:prstGeom prst="rect">
+            <a:avLst/>
+          </a:prstGeom>
+          <a:noFill/>
+          <a:ln/>
+        </p:spPr>
+        <p:txBody>
+          <a:bodyPr wrap="square" lIns="0" tIns="0" rIns="0" bIns="0" rtlCol="0" anchor="t"/>
+          <a:lstStyle/>
+          <a:p>
+            <a:pPr indent="0" marL="0">
+              <a:buNone/>
+            </a:pPr>
+            <a:r>
+              <a:rPr lang="en-US" sz="850" spc="140" kern="0" dirty="0">
                 <a:solidFill>
                   <a:srgbClr val="E4C9CE"/>
-                </a:solidFill>
-                <a:latin typeface="Montserrat" pitchFamily="34" charset="0"/>
-                <a:ea typeface="Montserrat" pitchFamily="34" charset="-122"/>
-                <a:cs typeface="Montserrat" pitchFamily="34" charset="-120"/>
-              </a:rPr>
-              <a:t>Each project was designed so another group can pick it up and run it.</a:t>
-            </a:r>
-            <a:endParaRPr lang="en-US" sz="1100" dirty="0"/>
-          </a:p>
-        </p:txBody>
-      </p:sp>
-      <p:sp>
-        <p:nvSpPr>
-          <p:cNvPr id="24" name="Text 19"/>
-          <p:cNvSpPr txBox="1"/>
-          <p:nvPr/>
-        </p:nvSpPr>
-        <p:spPr>
-          <a:xfrm>
-            <a:off x="777240" y="5614416"/>
-            <a:ext cx="6949440" cy="329184"/>
-          </a:xfrm>
-          <a:prstGeom prst="rect">
-            <a:avLst/>
-          </a:prstGeom>
-          <a:noFill/>
-          <a:ln/>
-        </p:spPr>
-        <p:txBody>
-          <a:bodyPr wrap="square" lIns="0" tIns="0" rIns="0" bIns="0" rtlCol="0" anchor="t"/>
-          <a:lstStyle/>
-          <a:p>
-            <a:pPr indent="0" marL="0">
-              <a:buNone/>
-            </a:pPr>
-            <a:r>
-              <a:rPr lang="en-US" sz="1600" dirty="0">
-                <a:solidFill>
-                  <a:srgbClr val="FFFFFF"/>
                 </a:solidFill>
                 <a:latin typeface="Montserrat SemiBold" pitchFamily="34" charset="0"/>
                 <a:ea typeface="Montserrat SemiBold" pitchFamily="34" charset="-122"/>
                 <a:cs typeface="Montserrat SemiBold" pitchFamily="34" charset="-120"/>
               </a:rPr>
-              <a:t>Thank you — happy to take questions.</a:t>
-            </a:r>
-            <a:endParaRPr lang="en-US" sz="1600" dirty="0"/>
-          </a:p>
-        </p:txBody>
-      </p:sp>
-      <p:sp>
-        <p:nvSpPr>
-          <p:cNvPr id="25" name="Text 20"/>
-          <p:cNvSpPr txBox="1"/>
-          <p:nvPr/>
-        </p:nvSpPr>
-        <p:spPr>
-          <a:xfrm>
-            <a:off x="777240" y="5980176"/>
-            <a:ext cx="7680960" cy="256032"/>
-          </a:xfrm>
-          <a:prstGeom prst="rect">
-            <a:avLst/>
-          </a:prstGeom>
-          <a:noFill/>
-          <a:ln/>
-        </p:spPr>
-        <p:txBody>
-          <a:bodyPr wrap="square" lIns="0" tIns="0" rIns="0" bIns="0" rtlCol="0" anchor="t"/>
-          <a:lstStyle/>
-          <a:p>
-            <a:pPr indent="0" marL="0">
-              <a:buNone/>
-            </a:pPr>
-            <a:r>
-              <a:rPr lang="en-US" sz="950" spc="30" kern="0" dirty="0">
-                <a:solidFill>
-                  <a:srgbClr val="DAB4BA"/>
-                </a:solidFill>
-                <a:latin typeface="Montserrat Medium" pitchFamily="34" charset="0"/>
-                <a:ea typeface="Montserrat Medium" pitchFamily="34" charset="-122"/>
-                <a:cs typeface="Montserrat Medium" pitchFamily="34" charset="-120"/>
-              </a:rPr>
-              <a:t>Next up: the PWPA and PJPT certifications, heading toward penetration testing.</a:t>
-            </a:r>
-            <a:endParaRPr lang="en-US" sz="950" dirty="0"/>
-          </a:p>
-        </p:txBody>
-      </p:sp>
-      <p:sp>
-        <p:nvSpPr>
-          <p:cNvPr id="26" name="Text 21"/>
-          <p:cNvSpPr txBox="1"/>
-          <p:nvPr/>
-        </p:nvSpPr>
-        <p:spPr>
-          <a:xfrm>
-            <a:off x="777240" y="6327648"/>
-            <a:ext cx="7315200" cy="201168"/>
-          </a:xfrm>
-          <a:prstGeom prst="rect">
-            <a:avLst/>
-          </a:prstGeom>
-          <a:noFill/>
-          <a:ln/>
-        </p:spPr>
-        <p:txBody>
-          <a:bodyPr wrap="square" lIns="0" tIns="0" rIns="0" bIns="0" rtlCol="0" anchor="t"/>
-          <a:lstStyle/>
-          <a:p>
-            <a:pPr indent="0" marL="0">
-              <a:buNone/>
-            </a:pPr>
-            <a:r>
-              <a:rPr lang="en-US" sz="850" spc="140" kern="0" dirty="0">
-                <a:solidFill>
-                  <a:srgbClr val="E4C9CE"/>
-                </a:solidFill>
-                <a:latin typeface="Montserrat SemiBold" pitchFamily="34" charset="0"/>
-                <a:ea typeface="Montserrat SemiBold" pitchFamily="34" charset="-122"/>
-                <a:cs typeface="Montserrat SemiBold" pitchFamily="34" charset="-120"/>
-              </a:rPr>
-              <a:t>SUMMARY</a:t>
+              <a:t>THANK YOU</a:t>
             </a:r>
             <a:endParaRPr lang="en-US" sz="850" dirty="0"/>
           </a:p>
@@ -16229,7 +16071,7 @@
       </p:sp>
       <p:sp>
         <p:nvSpPr>
-          <p:cNvPr id="27" name="Text 22"/>
+          <p:cNvPr id="23" name="Text 18"/>
           <p:cNvSpPr txBox="1"/>
           <p:nvPr/>
         </p:nvSpPr>

</xml_diff>

<commit_message>
Move the executive summary after the internship overview
It sat at slide 3, immediately after the contents, where it dropped 5,675 and
209 on a room that had not yet heard the words AEGIS or Kevlar. Moving it to
slide 5 puts it directly after the three-rotations overview, so 'three
rotations' and 'three problems, three working solutions' land as a matched
pair and the numbers arrive with context attached.

Also centre the proof text inside its tinted well, so a one-line proof no
longer leaves the cell looking half-empty.
</commit_message>
<xml_diff>
--- a/out/Internship_Exit_Presentation_Stewart.pptx
+++ b/out/Internship_Exit_Presentation_Stewart.pptx
@@ -1932,7 +1932,7 @@
           <a:p>
             <a:r>
               <a:rPr lang="en-US" dirty="0"/>
-              <a:t>If you only take one thing from this: three separate problems, three working solutions, and I can show the evidence for each. The detail follows — feel free to tune in and out.</a:t>
+              <a:t/>
             </a:r>
             <a:endParaRPr lang="en-US" dirty="0"/>
           </a:p>
@@ -2108,7 +2108,7 @@
           <a:p>
             <a:r>
               <a:rPr lang="en-US" dirty="0"/>
-              <a:t/>
+              <a:t>If you only take one thing from this: three separate problems, three working solutions, and I can show the evidence for each. The detail follows — feel free to tune in and out.</a:t>
             </a:r>
             <a:endParaRPr lang="en-US" dirty="0"/>
           </a:p>
@@ -16142,7 +16142,7 @@
       </p:grpSpPr>
       <p:pic>
         <p:nvPicPr>
-          <p:cNvPr id="2" name="Image 0" descr="/home/user/ai/assets/gen/logo-red.png">    </p:cNvPr>
+          <p:cNvPr id="2" name="Image 0" descr="/home/user/ai/assets/gen/panel-red-left.png">    </p:cNvPr>
           <p:cNvPicPr>
             <a:picLocks noChangeAspect="1"/>
           </p:cNvPicPr>
@@ -16156,24 +16156,48 @@
         </p:blipFill>
         <p:spPr>
           <a:xfrm>
-            <a:off x="9768535" y="457200"/>
-            <a:ext cx="1645920" cy="166053"/>
+            <a:off x="0" y="0"/>
+            <a:ext cx="4343400" cy="6858000"/>
           </a:xfrm>
           <a:prstGeom prst="rect">
             <a:avLst/>
           </a:prstGeom>
         </p:spPr>
       </p:pic>
-      <p:sp>
-        <p:nvSpPr>
-          <p:cNvPr id="3" name="Text 0"/>
-          <p:cNvSpPr txBox="1"/>
-          <p:nvPr/>
-        </p:nvSpPr>
-        <p:spPr>
-          <a:xfrm>
-            <a:off x="777240" y="658368"/>
-            <a:ext cx="7315200" cy="219456"/>
+      <p:pic>
+        <p:nvPicPr>
+          <p:cNvPr id="3" name="Image 1" descr="/home/user/ai/assets/gen/mark-slash-faint.png">    </p:cNvPr>
+          <p:cNvPicPr>
+            <a:picLocks noChangeAspect="1"/>
+          </p:cNvPicPr>
+          <p:nvPr/>
+        </p:nvPicPr>
+        <p:blipFill>
+          <a:blip r:embed="rId2"/>
+          <a:stretch>
+            <a:fillRect/>
+          </a:stretch>
+        </p:blipFill>
+        <p:spPr>
+          <a:xfrm>
+            <a:off x="-640080" y="3931920"/>
+            <a:ext cx="3840480" cy="3840480"/>
+          </a:xfrm>
+          <a:prstGeom prst="rect">
+            <a:avLst/>
+          </a:prstGeom>
+        </p:spPr>
+      </p:pic>
+      <p:sp>
+        <p:nvSpPr>
+          <p:cNvPr id="4" name="Text 0"/>
+          <p:cNvSpPr txBox="1"/>
+          <p:nvPr/>
+        </p:nvSpPr>
+        <p:spPr>
+          <a:xfrm>
+            <a:off x="777240" y="1371600"/>
+            <a:ext cx="3108960" cy="237744"/>
           </a:xfrm>
           <a:prstGeom prst="rect">
             <a:avLst/>
@@ -16191,13 +16215,13 @@
             <a:r>
               <a:rPr lang="en-US" sz="1000" spc="220" kern="0" dirty="0">
                 <a:solidFill>
-                  <a:srgbClr val="942838"/>
+                  <a:srgbClr val="E4C9CE"/>
                 </a:solidFill>
                 <a:latin typeface="Montserrat SemiBold" pitchFamily="34" charset="0"/>
                 <a:ea typeface="Montserrat SemiBold" pitchFamily="34" charset="-122"/>
                 <a:cs typeface="Montserrat SemiBold" pitchFamily="34" charset="-120"/>
               </a:rPr>
-              <a:t>EXECUTIVE SUMMARY</a:t>
+              <a:t>ABOUT ME</a:t>
             </a:r>
             <a:endParaRPr lang="en-US" sz="1000" dirty="0"/>
           </a:p>
@@ -16205,14 +16229,14 @@
       </p:sp>
       <p:sp>
         <p:nvSpPr>
-          <p:cNvPr id="4" name="Text 1"/>
-          <p:cNvSpPr txBox="1"/>
-          <p:nvPr/>
-        </p:nvSpPr>
-        <p:spPr>
-          <a:xfrm>
-            <a:off x="777240" y="932688"/>
-            <a:ext cx="10515600" cy="868680"/>
+          <p:cNvPr id="5" name="Text 1"/>
+          <p:cNvSpPr txBox="1"/>
+          <p:nvPr/>
+        </p:nvSpPr>
+        <p:spPr>
+          <a:xfrm>
+            <a:off x="777240" y="1737360"/>
+            <a:ext cx="3291840" cy="1371600"/>
           </a:xfrm>
           <a:prstGeom prst="rect">
             <a:avLst/>
@@ -16231,50 +16255,212 @@
               <a:buNone/>
             </a:pPr>
             <a:r>
-              <a:rPr lang="en-US" sz="2900" spc="-50" kern="0" dirty="0">
-                <a:solidFill>
-                  <a:srgbClr val="2B2D30"/>
+              <a:rPr lang="en-US" sz="3300" spc="-70" kern="0" dirty="0">
+                <a:solidFill>
+                  <a:srgbClr val="FFFFFF"/>
                 </a:solidFill>
                 <a:latin typeface="Montserrat ExtraBold" pitchFamily="34" charset="0"/>
                 <a:ea typeface="Montserrat ExtraBold" pitchFamily="34" charset="-122"/>
                 <a:cs typeface="Montserrat ExtraBold" pitchFamily="34" charset="-120"/>
               </a:rPr>
-              <a:t>Three problems, three working solutions</a:t>
-            </a:r>
-            <a:endParaRPr lang="en-US" sz="2900" dirty="0"/>
-          </a:p>
-        </p:txBody>
-      </p:sp>
-      <p:sp>
-        <p:nvSpPr>
-          <p:cNvPr id="5" name="Shape 2"/>
+              <a:t>Jair Maldonado</a:t>
+            </a:r>
+            <a:endParaRPr lang="en-US" sz="3300" dirty="0"/>
+          </a:p>
+        </p:txBody>
+      </p:sp>
+      <p:sp>
+        <p:nvSpPr>
+          <p:cNvPr id="6" name="Shape 2"/>
           <p:cNvSpPr/>
           <p:nvPr/>
         </p:nvSpPr>
         <p:spPr>
           <a:xfrm>
-            <a:off x="777240" y="1700784"/>
-            <a:ext cx="566928" cy="50292"/>
+            <a:off x="777240" y="3127248"/>
+            <a:ext cx="548640" cy="45720"/>
           </a:xfrm>
           <a:prstGeom prst="rect">
             <a:avLst/>
           </a:prstGeom>
           <a:solidFill>
-            <a:srgbClr val="942838"/>
+            <a:srgbClr val="FFFFFF"/>
           </a:solidFill>
           <a:ln/>
         </p:spPr>
       </p:sp>
       <p:sp>
         <p:nvSpPr>
-          <p:cNvPr id="6" name="Shape 3"/>
+          <p:cNvPr id="7" name="Text 3"/>
+          <p:cNvSpPr txBox="1"/>
+          <p:nvPr/>
+        </p:nvSpPr>
+        <p:spPr>
+          <a:xfrm>
+            <a:off x="777240" y="3364992"/>
+            <a:ext cx="3200400" cy="548640"/>
+          </a:xfrm>
+          <a:prstGeom prst="rect">
+            <a:avLst/>
+          </a:prstGeom>
+          <a:noFill/>
+          <a:ln/>
+        </p:spPr>
+        <p:txBody>
+          <a:bodyPr wrap="square" lIns="0" tIns="0" rIns="0" bIns="0" rtlCol="0" anchor="t"/>
+          <a:lstStyle/>
+          <a:p>
+            <a:pPr indent="0" marL="0">
+              <a:lnSpc>
+                <a:spcPct val="120000"/>
+              </a:lnSpc>
+              <a:buNone/>
+            </a:pPr>
+            <a:r>
+              <a:rPr lang="en-US" sz="950" spc="30" kern="0" dirty="0">
+                <a:solidFill>
+                  <a:srgbClr val="E4C9CE"/>
+                </a:solidFill>
+                <a:latin typeface="Montserrat Medium" pitchFamily="34" charset="0"/>
+                <a:ea typeface="Montserrat Medium" pitchFamily="34" charset="-122"/>
+                <a:cs typeface="Montserrat Medium" pitchFamily="34" charset="-120"/>
+              </a:rPr>
+              <a:t>Information Security Analyst Intern</a:t>
+            </a:r>
+            <a:endParaRPr lang="en-US" sz="950" dirty="0"/>
+          </a:p>
+        </p:txBody>
+      </p:sp>
+      <p:sp>
+        <p:nvSpPr>
+          <p:cNvPr id="8" name="Text 4"/>
+          <p:cNvSpPr txBox="1"/>
+          <p:nvPr/>
+        </p:nvSpPr>
+        <p:spPr>
+          <a:xfrm>
+            <a:off x="5120640" y="868680"/>
+            <a:ext cx="6293815" cy="237744"/>
+          </a:xfrm>
+          <a:prstGeom prst="rect">
+            <a:avLst/>
+          </a:prstGeom>
+          <a:noFill/>
+          <a:ln/>
+        </p:spPr>
+        <p:txBody>
+          <a:bodyPr wrap="square" lIns="0" tIns="0" rIns="0" bIns="0" rtlCol="0" anchor="t"/>
+          <a:lstStyle/>
+          <a:p>
+            <a:pPr indent="0" marL="0">
+              <a:buNone/>
+            </a:pPr>
+            <a:r>
+              <a:rPr lang="en-US" sz="1000" spc="220" kern="0" dirty="0">
+                <a:solidFill>
+                  <a:srgbClr val="942838"/>
+                </a:solidFill>
+                <a:latin typeface="Montserrat SemiBold" pitchFamily="34" charset="0"/>
+                <a:ea typeface="Montserrat SemiBold" pitchFamily="34" charset="-122"/>
+                <a:cs typeface="Montserrat SemiBold" pitchFamily="34" charset="-120"/>
+              </a:rPr>
+              <a:t>BACKGROUND</a:t>
+            </a:r>
+            <a:endParaRPr lang="en-US" sz="1000" dirty="0"/>
+          </a:p>
+        </p:txBody>
+      </p:sp>
+      <p:sp>
+        <p:nvSpPr>
+          <p:cNvPr id="9" name="Text 5"/>
+          <p:cNvSpPr txBox="1"/>
+          <p:nvPr/>
+        </p:nvSpPr>
+        <p:spPr>
+          <a:xfrm>
+            <a:off x="5120640" y="1298448"/>
+            <a:ext cx="6293815" cy="219456"/>
+          </a:xfrm>
+          <a:prstGeom prst="rect">
+            <a:avLst/>
+          </a:prstGeom>
+          <a:noFill/>
+          <a:ln/>
+        </p:spPr>
+        <p:txBody>
+          <a:bodyPr wrap="square" lIns="0" tIns="0" rIns="0" bIns="0" rtlCol="0" anchor="t"/>
+          <a:lstStyle/>
+          <a:p>
+            <a:pPr indent="0" marL="0">
+              <a:buNone/>
+            </a:pPr>
+            <a:r>
+              <a:rPr lang="en-US" sz="850" spc="140" kern="0" dirty="0">
+                <a:solidFill>
+                  <a:srgbClr val="942838"/>
+                </a:solidFill>
+                <a:latin typeface="Montserrat SemiBold" pitchFamily="34" charset="0"/>
+                <a:ea typeface="Montserrat SemiBold" pitchFamily="34" charset="-122"/>
+                <a:cs typeface="Montserrat SemiBold" pitchFamily="34" charset="-120"/>
+              </a:rPr>
+              <a:t>POSITION</a:t>
+            </a:r>
+            <a:endParaRPr lang="en-US" sz="850" dirty="0"/>
+          </a:p>
+        </p:txBody>
+      </p:sp>
+      <p:sp>
+        <p:nvSpPr>
+          <p:cNvPr id="10" name="Text 6"/>
+          <p:cNvSpPr txBox="1"/>
+          <p:nvPr/>
+        </p:nvSpPr>
+        <p:spPr>
+          <a:xfrm>
+            <a:off x="5120640" y="1545336"/>
+            <a:ext cx="6293815" cy="475488"/>
+          </a:xfrm>
+          <a:prstGeom prst="rect">
+            <a:avLst/>
+          </a:prstGeom>
+          <a:noFill/>
+          <a:ln/>
+        </p:spPr>
+        <p:txBody>
+          <a:bodyPr wrap="square" lIns="0" tIns="0" rIns="0" bIns="0" rtlCol="0" anchor="t"/>
+          <a:lstStyle/>
+          <a:p>
+            <a:pPr indent="0" marL="0">
+              <a:lnSpc>
+                <a:spcPct val="120000"/>
+              </a:lnSpc>
+              <a:buNone/>
+            </a:pPr>
+            <a:r>
+              <a:rPr lang="en-US" sz="1250" dirty="0">
+                <a:solidFill>
+                  <a:srgbClr val="43464A"/>
+                </a:solidFill>
+                <a:latin typeface="Montserrat" pitchFamily="34" charset="0"/>
+                <a:ea typeface="Montserrat" pitchFamily="34" charset="-122"/>
+                <a:cs typeface="Montserrat" pitchFamily="34" charset="-120"/>
+              </a:rPr>
+              <a:t>Information Security Analyst Intern</a:t>
+            </a:r>
+            <a:endParaRPr lang="en-US" sz="1250" dirty="0"/>
+          </a:p>
+        </p:txBody>
+      </p:sp>
+      <p:sp>
+        <p:nvSpPr>
+          <p:cNvPr id="11" name="Shape 7"/>
           <p:cNvSpPr/>
           <p:nvPr/>
         </p:nvSpPr>
         <p:spPr>
           <a:xfrm>
-            <a:off x="777240" y="6181344"/>
-            <a:ext cx="10637215" cy="10973"/>
+            <a:off x="5120640" y="2084832"/>
+            <a:ext cx="6293815" cy="10973"/>
           </a:xfrm>
           <a:prstGeom prst="rect">
             <a:avLst/>
@@ -16287,14 +16473,14 @@
       </p:sp>
       <p:sp>
         <p:nvSpPr>
-          <p:cNvPr id="7" name="Text 4"/>
-          <p:cNvSpPr txBox="1"/>
-          <p:nvPr/>
-        </p:nvSpPr>
-        <p:spPr>
-          <a:xfrm>
-            <a:off x="777240" y="6327648"/>
-            <a:ext cx="7315200" cy="201168"/>
+          <p:cNvPr id="12" name="Text 8"/>
+          <p:cNvSpPr txBox="1"/>
+          <p:nvPr/>
+        </p:nvSpPr>
+        <p:spPr>
+          <a:xfrm>
+            <a:off x="5120640" y="2240280"/>
+            <a:ext cx="6293815" cy="219456"/>
           </a:xfrm>
           <a:prstGeom prst="rect">
             <a:avLst/>
@@ -16312,13 +16498,13 @@
             <a:r>
               <a:rPr lang="en-US" sz="850" spc="140" kern="0" dirty="0">
                 <a:solidFill>
-                  <a:srgbClr val="6E7175"/>
+                  <a:srgbClr val="942838"/>
                 </a:solidFill>
                 <a:latin typeface="Montserrat SemiBold" pitchFamily="34" charset="0"/>
                 <a:ea typeface="Montserrat SemiBold" pitchFamily="34" charset="-122"/>
                 <a:cs typeface="Montserrat SemiBold" pitchFamily="34" charset="-120"/>
               </a:rPr>
-              <a:t>EXECUTIVE SUMMARY</a:t>
+              <a:t>SCHOOL</a:t>
             </a:r>
             <a:endParaRPr lang="en-US" sz="850" dirty="0"/>
           </a:p>
@@ -16326,38 +16512,100 @@
       </p:sp>
       <p:sp>
         <p:nvSpPr>
-          <p:cNvPr id="8" name="Text 5"/>
-          <p:cNvSpPr txBox="1"/>
-          <p:nvPr/>
-        </p:nvSpPr>
-        <p:spPr>
-          <a:xfrm>
-            <a:off x="10317175" y="6327648"/>
-            <a:ext cx="1097280" cy="201168"/>
-          </a:xfrm>
-          <a:prstGeom prst="rect">
-            <a:avLst/>
-          </a:prstGeom>
-          <a:noFill/>
-          <a:ln/>
-        </p:spPr>
-        <p:txBody>
-          <a:bodyPr wrap="square" lIns="0" tIns="0" rIns="0" bIns="0" rtlCol="0" anchor="t"/>
-          <a:lstStyle/>
-          <a:p>
-            <a:pPr algn="r" indent="0" marL="0">
+          <p:cNvPr id="13" name="Text 9"/>
+          <p:cNvSpPr txBox="1"/>
+          <p:nvPr/>
+        </p:nvSpPr>
+        <p:spPr>
+          <a:xfrm>
+            <a:off x="5120640" y="2487168"/>
+            <a:ext cx="6293815" cy="475488"/>
+          </a:xfrm>
+          <a:prstGeom prst="rect">
+            <a:avLst/>
+          </a:prstGeom>
+          <a:noFill/>
+          <a:ln/>
+        </p:spPr>
+        <p:txBody>
+          <a:bodyPr wrap="square" lIns="0" tIns="0" rIns="0" bIns="0" rtlCol="0" anchor="t"/>
+          <a:lstStyle/>
+          <a:p>
+            <a:pPr indent="0" marL="0">
+              <a:lnSpc>
+                <a:spcPct val="120000"/>
+              </a:lnSpc>
+              <a:buNone/>
+            </a:pPr>
+            <a:r>
+              <a:rPr lang="en-US" sz="1250" dirty="0">
+                <a:solidFill>
+                  <a:srgbClr val="43464A"/>
+                </a:solidFill>
+                <a:latin typeface="Montserrat" pitchFamily="34" charset="0"/>
+                <a:ea typeface="Montserrat" pitchFamily="34" charset="-122"/>
+                <a:cs typeface="Montserrat" pitchFamily="34" charset="-120"/>
+              </a:rPr>
+              <a:t>Studying cybersecurity, with a focus on offensive security</a:t>
+            </a:r>
+            <a:endParaRPr lang="en-US" sz="1250" dirty="0"/>
+          </a:p>
+        </p:txBody>
+      </p:sp>
+      <p:sp>
+        <p:nvSpPr>
+          <p:cNvPr id="14" name="Shape 10"/>
+          <p:cNvSpPr/>
+          <p:nvPr/>
+        </p:nvSpPr>
+        <p:spPr>
+          <a:xfrm>
+            <a:off x="5120640" y="3026664"/>
+            <a:ext cx="6293815" cy="10973"/>
+          </a:xfrm>
+          <a:prstGeom prst="rect">
+            <a:avLst/>
+          </a:prstGeom>
+          <a:solidFill>
+            <a:srgbClr val="E6E4E2"/>
+          </a:solidFill>
+          <a:ln/>
+        </p:spPr>
+      </p:sp>
+      <p:sp>
+        <p:nvSpPr>
+          <p:cNvPr id="15" name="Text 11"/>
+          <p:cNvSpPr txBox="1"/>
+          <p:nvPr/>
+        </p:nvSpPr>
+        <p:spPr>
+          <a:xfrm>
+            <a:off x="5120640" y="3182112"/>
+            <a:ext cx="6293815" cy="219456"/>
+          </a:xfrm>
+          <a:prstGeom prst="rect">
+            <a:avLst/>
+          </a:prstGeom>
+          <a:noFill/>
+          <a:ln/>
+        </p:spPr>
+        <p:txBody>
+          <a:bodyPr wrap="square" lIns="0" tIns="0" rIns="0" bIns="0" rtlCol="0" anchor="t"/>
+          <a:lstStyle/>
+          <a:p>
+            <a:pPr indent="0" marL="0">
               <a:buNone/>
             </a:pPr>
             <a:r>
               <a:rPr lang="en-US" sz="850" spc="140" kern="0" dirty="0">
                 <a:solidFill>
-                  <a:srgbClr val="6E7175"/>
+                  <a:srgbClr val="942838"/>
                 </a:solidFill>
                 <a:latin typeface="Montserrat SemiBold" pitchFamily="34" charset="0"/>
                 <a:ea typeface="Montserrat SemiBold" pitchFamily="34" charset="-122"/>
                 <a:cs typeface="Montserrat SemiBold" pitchFamily="34" charset="-120"/>
               </a:rPr>
-              <a:t>03</a:t>
+              <a:t>BACKGROUND</a:t>
             </a:r>
             <a:endParaRPr lang="en-US" sz="850" dirty="0"/>
           </a:p>
@@ -16365,53 +16613,76 @@
       </p:sp>
       <p:sp>
         <p:nvSpPr>
-          <p:cNvPr id="9" name="Text 6"/>
-          <p:cNvSpPr txBox="1"/>
-          <p:nvPr/>
-        </p:nvSpPr>
-        <p:spPr>
-          <a:xfrm>
-            <a:off x="777240" y="1956816"/>
-            <a:ext cx="10241280" cy="310896"/>
-          </a:xfrm>
-          <a:prstGeom prst="rect">
-            <a:avLst/>
-          </a:prstGeom>
-          <a:noFill/>
-          <a:ln/>
-        </p:spPr>
-        <p:txBody>
-          <a:bodyPr wrap="square" lIns="0" tIns="0" rIns="0" bIns="0" rtlCol="0" anchor="t"/>
-          <a:lstStyle/>
-          <a:p>
-            <a:pPr indent="0" marL="0">
-              <a:buNone/>
-            </a:pPr>
-            <a:r>
-              <a:rPr lang="en-US" sz="1400" dirty="0">
-                <a:solidFill>
-                  <a:srgbClr val="6E7175"/>
-                </a:solidFill>
-                <a:latin typeface="Montserrat Medium" pitchFamily="34" charset="0"/>
-                <a:ea typeface="Montserrat Medium" pitchFamily="34" charset="-122"/>
-                <a:cs typeface="Montserrat Medium" pitchFamily="34" charset="-120"/>
-              </a:rPr>
-              <a:t>Three separate gaps, three things the team keeps using. This is the whole story on one slide.</a:t>
-            </a:r>
-            <a:endParaRPr lang="en-US" sz="1400" dirty="0"/>
-          </a:p>
-        </p:txBody>
-      </p:sp>
-      <p:sp>
-        <p:nvSpPr>
-          <p:cNvPr id="10" name="Text 7"/>
-          <p:cNvSpPr txBox="1"/>
-          <p:nvPr/>
-        </p:nvSpPr>
-        <p:spPr>
-          <a:xfrm>
-            <a:off x="777240" y="2487168"/>
-            <a:ext cx="3200400" cy="201168"/>
+          <p:cNvPr id="16" name="Text 12"/>
+          <p:cNvSpPr txBox="1"/>
+          <p:nvPr/>
+        </p:nvSpPr>
+        <p:spPr>
+          <a:xfrm>
+            <a:off x="5120640" y="3429000"/>
+            <a:ext cx="6293815" cy="475488"/>
+          </a:xfrm>
+          <a:prstGeom prst="rect">
+            <a:avLst/>
+          </a:prstGeom>
+          <a:noFill/>
+          <a:ln/>
+        </p:spPr>
+        <p:txBody>
+          <a:bodyPr wrap="square" lIns="0" tIns="0" rIns="0" bIns="0" rtlCol="0" anchor="t"/>
+          <a:lstStyle/>
+          <a:p>
+            <a:pPr indent="0" marL="0">
+              <a:lnSpc>
+                <a:spcPct val="120000"/>
+              </a:lnSpc>
+              <a:buNone/>
+            </a:pPr>
+            <a:r>
+              <a:rPr lang="en-US" sz="1250" dirty="0">
+                <a:solidFill>
+                  <a:srgbClr val="43464A"/>
+                </a:solidFill>
+                <a:latin typeface="Montserrat" pitchFamily="34" charset="0"/>
+                <a:ea typeface="Montserrat" pitchFamily="34" charset="-122"/>
+                <a:cs typeface="Montserrat" pitchFamily="34" charset="-120"/>
+              </a:rPr>
+              <a:t>Hands-on security work across vulnerability management, application security, and network security</a:t>
+            </a:r>
+            <a:endParaRPr lang="en-US" sz="1250" dirty="0"/>
+          </a:p>
+        </p:txBody>
+      </p:sp>
+      <p:sp>
+        <p:nvSpPr>
+          <p:cNvPr id="17" name="Shape 13"/>
+          <p:cNvSpPr/>
+          <p:nvPr/>
+        </p:nvSpPr>
+        <p:spPr>
+          <a:xfrm>
+            <a:off x="5120640" y="3968496"/>
+            <a:ext cx="6293815" cy="10973"/>
+          </a:xfrm>
+          <a:prstGeom prst="rect">
+            <a:avLst/>
+          </a:prstGeom>
+          <a:solidFill>
+            <a:srgbClr val="E6E4E2"/>
+          </a:solidFill>
+          <a:ln/>
+        </p:spPr>
+      </p:sp>
+      <p:sp>
+        <p:nvSpPr>
+          <p:cNvPr id="18" name="Text 14"/>
+          <p:cNvSpPr txBox="1"/>
+          <p:nvPr/>
+        </p:nvSpPr>
+        <p:spPr>
+          <a:xfrm>
+            <a:off x="5120640" y="4123944"/>
+            <a:ext cx="6293815" cy="219456"/>
           </a:xfrm>
           <a:prstGeom prst="rect">
             <a:avLst/>
@@ -16435,7 +16706,7 @@
                 <a:ea typeface="Montserrat SemiBold" pitchFamily="34" charset="-122"/>
                 <a:cs typeface="Montserrat SemiBold" pitchFamily="34" charset="-120"/>
               </a:rPr>
-              <a:t>THE PROBLEM</a:t>
+              <a:t>CERTIFICATIONS</a:t>
             </a:r>
             <a:endParaRPr lang="en-US" sz="850" dirty="0"/>
           </a:p>
@@ -16443,14 +16714,76 @@
       </p:sp>
       <p:sp>
         <p:nvSpPr>
-          <p:cNvPr id="11" name="Text 8"/>
-          <p:cNvSpPr txBox="1"/>
-          <p:nvPr/>
-        </p:nvSpPr>
-        <p:spPr>
-          <a:xfrm>
-            <a:off x="4224528" y="2487168"/>
-            <a:ext cx="3657600" cy="201168"/>
+          <p:cNvPr id="19" name="Text 15"/>
+          <p:cNvSpPr txBox="1"/>
+          <p:nvPr/>
+        </p:nvSpPr>
+        <p:spPr>
+          <a:xfrm>
+            <a:off x="5120640" y="4370832"/>
+            <a:ext cx="6293815" cy="475488"/>
+          </a:xfrm>
+          <a:prstGeom prst="rect">
+            <a:avLst/>
+          </a:prstGeom>
+          <a:noFill/>
+          <a:ln/>
+        </p:spPr>
+        <p:txBody>
+          <a:bodyPr wrap="square" lIns="0" tIns="0" rIns="0" bIns="0" rtlCol="0" anchor="t"/>
+          <a:lstStyle/>
+          <a:p>
+            <a:pPr indent="0" marL="0">
+              <a:lnSpc>
+                <a:spcPct val="120000"/>
+              </a:lnSpc>
+              <a:buNone/>
+            </a:pPr>
+            <a:r>
+              <a:rPr lang="en-US" sz="1250" dirty="0">
+                <a:solidFill>
+                  <a:srgbClr val="43464A"/>
+                </a:solidFill>
+                <a:latin typeface="Montserrat" pitchFamily="34" charset="0"/>
+                <a:ea typeface="Montserrat" pitchFamily="34" charset="-122"/>
+                <a:cs typeface="Montserrat" pitchFamily="34" charset="-120"/>
+              </a:rPr>
+              <a:t>Working toward the PWPA and PJPT practical certifications</a:t>
+            </a:r>
+            <a:endParaRPr lang="en-US" sz="1250" dirty="0"/>
+          </a:p>
+        </p:txBody>
+      </p:sp>
+      <p:sp>
+        <p:nvSpPr>
+          <p:cNvPr id="20" name="Shape 16"/>
+          <p:cNvSpPr/>
+          <p:nvPr/>
+        </p:nvSpPr>
+        <p:spPr>
+          <a:xfrm>
+            <a:off x="5120640" y="4910328"/>
+            <a:ext cx="6293815" cy="10973"/>
+          </a:xfrm>
+          <a:prstGeom prst="rect">
+            <a:avLst/>
+          </a:prstGeom>
+          <a:solidFill>
+            <a:srgbClr val="E6E4E2"/>
+          </a:solidFill>
+          <a:ln/>
+        </p:spPr>
+      </p:sp>
+      <p:sp>
+        <p:nvSpPr>
+          <p:cNvPr id="21" name="Text 17"/>
+          <p:cNvSpPr txBox="1"/>
+          <p:nvPr/>
+        </p:nvSpPr>
+        <p:spPr>
+          <a:xfrm>
+            <a:off x="5120640" y="5065776"/>
+            <a:ext cx="6293815" cy="219456"/>
           </a:xfrm>
           <a:prstGeom prst="rect">
             <a:avLst/>
@@ -16474,7 +16807,7 @@
                 <a:ea typeface="Montserrat SemiBold" pitchFamily="34" charset="-122"/>
                 <a:cs typeface="Montserrat SemiBold" pitchFamily="34" charset="-120"/>
               </a:rPr>
-              <a:t>WHAT I BUILT</a:t>
+              <a:t>CAREER DIRECTION</a:t>
             </a:r>
             <a:endParaRPr lang="en-US" sz="850" dirty="0"/>
           </a:p>
@@ -16482,14 +16815,100 @@
       </p:sp>
       <p:sp>
         <p:nvSpPr>
-          <p:cNvPr id="12" name="Text 9"/>
-          <p:cNvSpPr txBox="1"/>
-          <p:nvPr/>
-        </p:nvSpPr>
-        <p:spPr>
-          <a:xfrm>
-            <a:off x="8101584" y="2487168"/>
-            <a:ext cx="3312871" cy="201168"/>
+          <p:cNvPr id="22" name="Text 18"/>
+          <p:cNvSpPr txBox="1"/>
+          <p:nvPr/>
+        </p:nvSpPr>
+        <p:spPr>
+          <a:xfrm>
+            <a:off x="5120640" y="5312664"/>
+            <a:ext cx="6293815" cy="475488"/>
+          </a:xfrm>
+          <a:prstGeom prst="rect">
+            <a:avLst/>
+          </a:prstGeom>
+          <a:noFill/>
+          <a:ln/>
+        </p:spPr>
+        <p:txBody>
+          <a:bodyPr wrap="square" lIns="0" tIns="0" rIns="0" bIns="0" rtlCol="0" anchor="t"/>
+          <a:lstStyle/>
+          <a:p>
+            <a:pPr indent="0" marL="0">
+              <a:lnSpc>
+                <a:spcPct val="120000"/>
+              </a:lnSpc>
+              <a:buNone/>
+            </a:pPr>
+            <a:r>
+              <a:rPr lang="en-US" sz="1250" dirty="0">
+                <a:solidFill>
+                  <a:srgbClr val="43464A"/>
+                </a:solidFill>
+                <a:latin typeface="Montserrat" pitchFamily="34" charset="0"/>
+                <a:ea typeface="Montserrat" pitchFamily="34" charset="-122"/>
+                <a:cs typeface="Montserrat" pitchFamily="34" charset="-120"/>
+              </a:rPr>
+              <a:t>Penetration testing — finding weaknesses before an attacker does</a:t>
+            </a:r>
+            <a:endParaRPr lang="en-US" sz="1250" dirty="0"/>
+          </a:p>
+        </p:txBody>
+      </p:sp>
+      <p:pic>
+        <p:nvPicPr>
+          <p:cNvPr id="23" name="Image 2" descr="/home/user/ai/assets/gen/logo-red.png">    </p:cNvPr>
+          <p:cNvPicPr>
+            <a:picLocks noChangeAspect="1"/>
+          </p:cNvPicPr>
+          <p:nvPr/>
+        </p:nvPicPr>
+        <p:blipFill>
+          <a:blip r:embed="rId3"/>
+          <a:stretch>
+            <a:fillRect/>
+          </a:stretch>
+        </p:blipFill>
+        <p:spPr>
+          <a:xfrm>
+            <a:off x="9768535" y="457200"/>
+            <a:ext cx="1645920" cy="166053"/>
+          </a:xfrm>
+          <a:prstGeom prst="rect">
+            <a:avLst/>
+          </a:prstGeom>
+        </p:spPr>
+      </p:pic>
+      <p:sp>
+        <p:nvSpPr>
+          <p:cNvPr id="24" name="Shape 19"/>
+          <p:cNvSpPr/>
+          <p:nvPr/>
+        </p:nvSpPr>
+        <p:spPr>
+          <a:xfrm>
+            <a:off x="5120640" y="6181344"/>
+            <a:ext cx="6293815" cy="10973"/>
+          </a:xfrm>
+          <a:prstGeom prst="rect">
+            <a:avLst/>
+          </a:prstGeom>
+          <a:solidFill>
+            <a:srgbClr val="E6E4E2"/>
+          </a:solidFill>
+          <a:ln/>
+        </p:spPr>
+      </p:sp>
+      <p:sp>
+        <p:nvSpPr>
+          <p:cNvPr id="25" name="Text 20"/>
+          <p:cNvSpPr txBox="1"/>
+          <p:nvPr/>
+        </p:nvSpPr>
+        <p:spPr>
+          <a:xfrm>
+            <a:off x="5120640" y="6327648"/>
+            <a:ext cx="7315200" cy="201168"/>
           </a:xfrm>
           <a:prstGeom prst="rect">
             <a:avLst/>
@@ -16507,13 +16926,13 @@
             <a:r>
               <a:rPr lang="en-US" sz="850" spc="140" kern="0" dirty="0">
                 <a:solidFill>
-                  <a:srgbClr val="942838"/>
+                  <a:srgbClr val="6E7175"/>
                 </a:solidFill>
                 <a:latin typeface="Montserrat SemiBold" pitchFamily="34" charset="0"/>
                 <a:ea typeface="Montserrat SemiBold" pitchFamily="34" charset="-122"/>
                 <a:cs typeface="Montserrat SemiBold" pitchFamily="34" charset="-120"/>
               </a:rPr>
-              <a:t>THE PROOF</a:t>
+              <a:t>ABOUT ME</a:t>
             </a:r>
             <a:endParaRPr lang="en-US" sz="850" dirty="0"/>
           </a:p>
@@ -16521,505 +16940,40 @@
       </p:sp>
       <p:sp>
         <p:nvSpPr>
-          <p:cNvPr id="13" name="Shape 10"/>
-          <p:cNvSpPr/>
-          <p:nvPr/>
-        </p:nvSpPr>
-        <p:spPr>
-          <a:xfrm>
-            <a:off x="777240" y="2743200"/>
-            <a:ext cx="10637215" cy="10973"/>
-          </a:xfrm>
-          <a:prstGeom prst="rect">
-            <a:avLst/>
-          </a:prstGeom>
-          <a:solidFill>
-            <a:srgbClr val="E6E4E2"/>
-          </a:solidFill>
-          <a:ln/>
-        </p:spPr>
-      </p:sp>
-      <p:sp>
-        <p:nvSpPr>
-          <p:cNvPr id="14" name="Text 11"/>
-          <p:cNvSpPr txBox="1"/>
-          <p:nvPr/>
-        </p:nvSpPr>
-        <p:spPr>
-          <a:xfrm>
-            <a:off x="777240" y="2889504"/>
-            <a:ext cx="3200400" cy="822960"/>
-          </a:xfrm>
-          <a:prstGeom prst="rect">
-            <a:avLst/>
-          </a:prstGeom>
-          <a:noFill/>
-          <a:ln/>
-        </p:spPr>
-        <p:txBody>
-          <a:bodyPr wrap="square" lIns="0" tIns="0" rIns="0" bIns="0" rtlCol="0" anchor="t"/>
-          <a:lstStyle/>
-          <a:p>
-            <a:pPr indent="0" marL="0">
-              <a:lnSpc>
-                <a:spcPct val="124000"/>
-              </a:lnSpc>
-              <a:buNone/>
-            </a:pPr>
-            <a:r>
-              <a:rPr lang="en-US" sz="1100" dirty="0">
-                <a:solidFill>
-                  <a:srgbClr val="43464A"/>
-                </a:solidFill>
-                <a:latin typeface="Montserrat" pitchFamily="34" charset="0"/>
-                <a:ea typeface="Montserrat" pitchFamily="34" charset="-122"/>
-                <a:cs typeface="Montserrat" pitchFamily="34" charset="-120"/>
-              </a:rPr>
-              <a:t>New machines could ship without the security tools they need.</a:t>
-            </a:r>
-            <a:endParaRPr lang="en-US" sz="1100" dirty="0"/>
-          </a:p>
-        </p:txBody>
-      </p:sp>
-      <p:sp>
-        <p:nvSpPr>
-          <p:cNvPr id="15" name="Text 12"/>
-          <p:cNvSpPr txBox="1"/>
-          <p:nvPr/>
-        </p:nvSpPr>
-        <p:spPr>
-          <a:xfrm>
-            <a:off x="4224528" y="2889504"/>
-            <a:ext cx="3383280" cy="822960"/>
-          </a:xfrm>
-          <a:prstGeom prst="rect">
-            <a:avLst/>
-          </a:prstGeom>
-          <a:noFill/>
-          <a:ln/>
-        </p:spPr>
-        <p:txBody>
-          <a:bodyPr wrap="square" lIns="0" tIns="0" rIns="0" bIns="0" rtlCol="0" anchor="t"/>
-          <a:lstStyle/>
-          <a:p>
-            <a:pPr indent="0" marL="0">
-              <a:lnSpc>
-                <a:spcPct val="124000"/>
-              </a:lnSpc>
-              <a:buNone/>
-            </a:pPr>
-            <a:r>
-              <a:rPr lang="en-US" sz="1100" dirty="0">
-                <a:solidFill>
-                  <a:srgbClr val="2B2D30"/>
+          <p:cNvPr id="26" name="Text 21"/>
+          <p:cNvSpPr txBox="1"/>
+          <p:nvPr/>
+        </p:nvSpPr>
+        <p:spPr>
+          <a:xfrm>
+            <a:off x="10317175" y="6327648"/>
+            <a:ext cx="1097280" cy="201168"/>
+          </a:xfrm>
+          <a:prstGeom prst="rect">
+            <a:avLst/>
+          </a:prstGeom>
+          <a:noFill/>
+          <a:ln/>
+        </p:spPr>
+        <p:txBody>
+          <a:bodyPr wrap="square" lIns="0" tIns="0" rIns="0" bIns="0" rtlCol="0" anchor="t"/>
+          <a:lstStyle/>
+          <a:p>
+            <a:pPr algn="r" indent="0" marL="0">
+              <a:buNone/>
+            </a:pPr>
+            <a:r>
+              <a:rPr lang="en-US" sz="850" spc="140" kern="0" dirty="0">
+                <a:solidFill>
+                  <a:srgbClr val="6E7175"/>
                 </a:solidFill>
                 <a:latin typeface="Montserrat SemiBold" pitchFamily="34" charset="0"/>
                 <a:ea typeface="Montserrat SemiBold" pitchFamily="34" charset="-122"/>
                 <a:cs typeface="Montserrat SemiBold" pitchFamily="34" charset="-120"/>
               </a:rPr>
-              <a:t>A written framework naming all nine required tools and who owns each.</a:t>
-            </a:r>
-            <a:endParaRPr lang="en-US" sz="1100" dirty="0"/>
-          </a:p>
-        </p:txBody>
-      </p:sp>
-      <p:sp>
-        <p:nvSpPr>
-          <p:cNvPr id="16" name="Shape 13"/>
-          <p:cNvSpPr/>
-          <p:nvPr/>
-        </p:nvSpPr>
-        <p:spPr>
-          <a:xfrm>
-            <a:off x="7918704" y="2779776"/>
-            <a:ext cx="3495751" cy="859536"/>
-          </a:xfrm>
-          <a:prstGeom prst="roundRect">
-            <a:avLst>
-              <a:gd name="adj" fmla="val 5319"/>
-            </a:avLst>
-          </a:prstGeom>
-          <a:solidFill>
-            <a:srgbClr val="F6EEF0"/>
-          </a:solidFill>
-          <a:ln/>
-        </p:spPr>
-      </p:sp>
-      <p:sp>
-        <p:nvSpPr>
-          <p:cNvPr id="17" name="Text 14"/>
-          <p:cNvSpPr txBox="1"/>
-          <p:nvPr/>
-        </p:nvSpPr>
-        <p:spPr>
-          <a:xfrm>
-            <a:off x="8101584" y="2907792"/>
-            <a:ext cx="3129991" cy="658368"/>
-          </a:xfrm>
-          <a:prstGeom prst="rect">
-            <a:avLst/>
-          </a:prstGeom>
-          <a:noFill/>
-          <a:ln/>
-        </p:spPr>
-        <p:txBody>
-          <a:bodyPr wrap="square" lIns="0" tIns="0" rIns="0" bIns="0" rtlCol="0" anchor="t"/>
-          <a:lstStyle/>
-          <a:p>
-            <a:pPr indent="0" marL="0">
-              <a:lnSpc>
-                <a:spcPct val="124000"/>
-              </a:lnSpc>
-              <a:buNone/>
-            </a:pPr>
-            <a:r>
-              <a:rPr lang="en-US" sz="1100" dirty="0">
-                <a:solidFill>
-                  <a:srgbClr val="942838"/>
-                </a:solidFill>
-                <a:latin typeface="Montserrat SemiBold" pitchFamily="34" charset="0"/>
-                <a:ea typeface="Montserrat SemiBold" pitchFamily="34" charset="-122"/>
-                <a:cs typeface="Montserrat SemiBold" pitchFamily="34" charset="-120"/>
-              </a:rPr>
-              <a:t>Drafted and staged for Q4 sign-off</a:t>
-            </a:r>
-            <a:endParaRPr lang="en-US" sz="1100" dirty="0"/>
-          </a:p>
-        </p:txBody>
-      </p:sp>
-      <p:sp>
-        <p:nvSpPr>
-          <p:cNvPr id="18" name="Shape 15"/>
-          <p:cNvSpPr/>
-          <p:nvPr/>
-        </p:nvSpPr>
-        <p:spPr>
-          <a:xfrm>
-            <a:off x="777240" y="3858768"/>
-            <a:ext cx="10637215" cy="10973"/>
-          </a:xfrm>
-          <a:prstGeom prst="rect">
-            <a:avLst/>
-          </a:prstGeom>
-          <a:solidFill>
-            <a:srgbClr val="E6E4E2"/>
-          </a:solidFill>
-          <a:ln/>
-        </p:spPr>
-      </p:sp>
-      <p:sp>
-        <p:nvSpPr>
-          <p:cNvPr id="19" name="Text 16"/>
-          <p:cNvSpPr txBox="1"/>
-          <p:nvPr/>
-        </p:nvSpPr>
-        <p:spPr>
-          <a:xfrm>
-            <a:off x="777240" y="4023360"/>
-            <a:ext cx="3200400" cy="822960"/>
-          </a:xfrm>
-          <a:prstGeom prst="rect">
-            <a:avLst/>
-          </a:prstGeom>
-          <a:noFill/>
-          <a:ln/>
-        </p:spPr>
-        <p:txBody>
-          <a:bodyPr wrap="square" lIns="0" tIns="0" rIns="0" bIns="0" rtlCol="0" anchor="t"/>
-          <a:lstStyle/>
-          <a:p>
-            <a:pPr indent="0" marL="0">
-              <a:lnSpc>
-                <a:spcPct val="124000"/>
-              </a:lnSpc>
-              <a:buNone/>
-            </a:pPr>
-            <a:r>
-              <a:rPr lang="en-US" sz="1100" dirty="0">
-                <a:solidFill>
-                  <a:srgbClr val="43464A"/>
-                </a:solidFill>
-                <a:latin typeface="Montserrat" pitchFamily="34" charset="0"/>
-                <a:ea typeface="Montserrat" pitchFamily="34" charset="-122"/>
-                <a:cs typeface="Montserrat" pitchFamily="34" charset="-120"/>
-              </a:rPr>
-              <a:t>Attackers hide malicious code inside the open-source packages we depend on.</a:t>
-            </a:r>
-            <a:endParaRPr lang="en-US" sz="1100" dirty="0"/>
-          </a:p>
-        </p:txBody>
-      </p:sp>
-      <p:sp>
-        <p:nvSpPr>
-          <p:cNvPr id="20" name="Text 17"/>
-          <p:cNvSpPr txBox="1"/>
-          <p:nvPr/>
-        </p:nvSpPr>
-        <p:spPr>
-          <a:xfrm>
-            <a:off x="4224528" y="4023360"/>
-            <a:ext cx="3383280" cy="822960"/>
-          </a:xfrm>
-          <a:prstGeom prst="rect">
-            <a:avLst/>
-          </a:prstGeom>
-          <a:noFill/>
-          <a:ln/>
-        </p:spPr>
-        <p:txBody>
-          <a:bodyPr wrap="square" lIns="0" tIns="0" rIns="0" bIns="0" rtlCol="0" anchor="t"/>
-          <a:lstStyle/>
-          <a:p>
-            <a:pPr indent="0" marL="0">
-              <a:lnSpc>
-                <a:spcPct val="124000"/>
-              </a:lnSpc>
-              <a:buNone/>
-            </a:pPr>
-            <a:r>
-              <a:rPr lang="en-US" sz="1100" dirty="0">
-                <a:solidFill>
-                  <a:srgbClr val="2B2D30"/>
-                </a:solidFill>
-                <a:latin typeface="Montserrat SemiBold" pitchFamily="34" charset="0"/>
-                <a:ea typeface="Montserrat SemiBold" pitchFamily="34" charset="-122"/>
-                <a:cs typeface="Montserrat SemiBold" pitchFamily="34" charset="-120"/>
-              </a:rPr>
-              <a:t>AEGIS — a scanner that checks whether our code actually reaches the flaw.</a:t>
-            </a:r>
-            <a:endParaRPr lang="en-US" sz="1100" dirty="0"/>
-          </a:p>
-        </p:txBody>
-      </p:sp>
-      <p:sp>
-        <p:nvSpPr>
-          <p:cNvPr id="21" name="Shape 18"/>
-          <p:cNvSpPr/>
-          <p:nvPr/>
-        </p:nvSpPr>
-        <p:spPr>
-          <a:xfrm>
-            <a:off x="7918704" y="3913632"/>
-            <a:ext cx="3495751" cy="859536"/>
-          </a:xfrm>
-          <a:prstGeom prst="roundRect">
-            <a:avLst>
-              <a:gd name="adj" fmla="val 5319"/>
-            </a:avLst>
-          </a:prstGeom>
-          <a:solidFill>
-            <a:srgbClr val="F6EEF0"/>
-          </a:solidFill>
-          <a:ln/>
-        </p:spPr>
-      </p:sp>
-      <p:sp>
-        <p:nvSpPr>
-          <p:cNvPr id="22" name="Text 19"/>
-          <p:cNvSpPr txBox="1"/>
-          <p:nvPr/>
-        </p:nvSpPr>
-        <p:spPr>
-          <a:xfrm>
-            <a:off x="8101584" y="4041648"/>
-            <a:ext cx="3129991" cy="658368"/>
-          </a:xfrm>
-          <a:prstGeom prst="rect">
-            <a:avLst/>
-          </a:prstGeom>
-          <a:noFill/>
-          <a:ln/>
-        </p:spPr>
-        <p:txBody>
-          <a:bodyPr wrap="square" lIns="0" tIns="0" rIns="0" bIns="0" rtlCol="0" anchor="t"/>
-          <a:lstStyle/>
-          <a:p>
-            <a:pPr indent="0" marL="0">
-              <a:lnSpc>
-                <a:spcPct val="124000"/>
-              </a:lnSpc>
-              <a:buNone/>
-            </a:pPr>
-            <a:r>
-              <a:rPr lang="en-US" sz="1100" dirty="0">
-                <a:solidFill>
-                  <a:srgbClr val="942838"/>
-                </a:solidFill>
-                <a:latin typeface="Montserrat SemiBold" pitchFamily="34" charset="0"/>
-                <a:ea typeface="Montserrat SemiBold" pitchFamily="34" charset="-122"/>
-                <a:cs typeface="Montserrat SemiBold" pitchFamily="34" charset="-120"/>
-              </a:rPr>
-              <a:t>5,675 packages scanned in production by an earlier version</a:t>
-            </a:r>
-            <a:endParaRPr lang="en-US" sz="1100" dirty="0"/>
-          </a:p>
-        </p:txBody>
-      </p:sp>
-      <p:sp>
-        <p:nvSpPr>
-          <p:cNvPr id="23" name="Shape 20"/>
-          <p:cNvSpPr/>
-          <p:nvPr/>
-        </p:nvSpPr>
-        <p:spPr>
-          <a:xfrm>
-            <a:off x="777240" y="4992624"/>
-            <a:ext cx="10637215" cy="10973"/>
-          </a:xfrm>
-          <a:prstGeom prst="rect">
-            <a:avLst/>
-          </a:prstGeom>
-          <a:solidFill>
-            <a:srgbClr val="E6E4E2"/>
-          </a:solidFill>
-          <a:ln/>
-        </p:spPr>
-      </p:sp>
-      <p:sp>
-        <p:nvSpPr>
-          <p:cNvPr id="24" name="Text 21"/>
-          <p:cNvSpPr txBox="1"/>
-          <p:nvPr/>
-        </p:nvSpPr>
-        <p:spPr>
-          <a:xfrm>
-            <a:off x="777240" y="5157216"/>
-            <a:ext cx="3200400" cy="822960"/>
-          </a:xfrm>
-          <a:prstGeom prst="rect">
-            <a:avLst/>
-          </a:prstGeom>
-          <a:noFill/>
-          <a:ln/>
-        </p:spPr>
-        <p:txBody>
-          <a:bodyPr wrap="square" lIns="0" tIns="0" rIns="0" bIns="0" rtlCol="0" anchor="t"/>
-          <a:lstStyle/>
-          <a:p>
-            <a:pPr indent="0" marL="0">
-              <a:lnSpc>
-                <a:spcPct val="124000"/>
-              </a:lnSpc>
-              <a:buNone/>
-            </a:pPr>
-            <a:r>
-              <a:rPr lang="en-US" sz="1100" dirty="0">
-                <a:solidFill>
-                  <a:srgbClr val="43464A"/>
-                </a:solidFill>
-                <a:latin typeface="Montserrat" pitchFamily="34" charset="0"/>
-                <a:ea typeface="Montserrat" pitchFamily="34" charset="-122"/>
-                <a:cs typeface="Montserrat" pitchFamily="34" charset="-120"/>
-              </a:rPr>
-              <a:t>Matching every tracked flaw to its patch took about two days of analyst time.</a:t>
-            </a:r>
-            <a:endParaRPr lang="en-US" sz="1100" dirty="0"/>
-          </a:p>
-        </p:txBody>
-      </p:sp>
-      <p:sp>
-        <p:nvSpPr>
-          <p:cNvPr id="25" name="Text 22"/>
-          <p:cNvSpPr txBox="1"/>
-          <p:nvPr/>
-        </p:nvSpPr>
-        <p:spPr>
-          <a:xfrm>
-            <a:off x="4224528" y="5157216"/>
-            <a:ext cx="3383280" cy="822960"/>
-          </a:xfrm>
-          <a:prstGeom prst="rect">
-            <a:avLst/>
-          </a:prstGeom>
-          <a:noFill/>
-          <a:ln/>
-        </p:spPr>
-        <p:txBody>
-          <a:bodyPr wrap="square" lIns="0" tIns="0" rIns="0" bIns="0" rtlCol="0" anchor="t"/>
-          <a:lstStyle/>
-          <a:p>
-            <a:pPr indent="0" marL="0">
-              <a:lnSpc>
-                <a:spcPct val="124000"/>
-              </a:lnSpc>
-              <a:buNone/>
-            </a:pPr>
-            <a:r>
-              <a:rPr lang="en-US" sz="1100" dirty="0">
-                <a:solidFill>
-                  <a:srgbClr val="2B2D30"/>
-                </a:solidFill>
-                <a:latin typeface="Montserrat SemiBold" pitchFamily="34" charset="0"/>
-                <a:ea typeface="Montserrat SemiBold" pitchFamily="34" charset="-122"/>
-                <a:cs typeface="Montserrat SemiBold" pitchFamily="34" charset="-120"/>
-              </a:rPr>
-              <a:t>A script that does the matching automatically, then consolidates the result.</a:t>
-            </a:r>
-            <a:endParaRPr lang="en-US" sz="1100" dirty="0"/>
-          </a:p>
-        </p:txBody>
-      </p:sp>
-      <p:sp>
-        <p:nvSpPr>
-          <p:cNvPr id="26" name="Shape 23"/>
-          <p:cNvSpPr/>
-          <p:nvPr/>
-        </p:nvSpPr>
-        <p:spPr>
-          <a:xfrm>
-            <a:off x="7918704" y="5047488"/>
-            <a:ext cx="3495751" cy="859536"/>
-          </a:xfrm>
-          <a:prstGeom prst="roundRect">
-            <a:avLst>
-              <a:gd name="adj" fmla="val 5319"/>
-            </a:avLst>
-          </a:prstGeom>
-          <a:solidFill>
-            <a:srgbClr val="F6EEF0"/>
-          </a:solidFill>
-          <a:ln/>
-        </p:spPr>
-      </p:sp>
-      <p:sp>
-        <p:nvSpPr>
-          <p:cNvPr id="27" name="Text 24"/>
-          <p:cNvSpPr txBox="1"/>
-          <p:nvPr/>
-        </p:nvSpPr>
-        <p:spPr>
-          <a:xfrm>
-            <a:off x="8101584" y="5175504"/>
-            <a:ext cx="3129991" cy="658368"/>
-          </a:xfrm>
-          <a:prstGeom prst="rect">
-            <a:avLst/>
-          </a:prstGeom>
-          <a:noFill/>
-          <a:ln/>
-        </p:spPr>
-        <p:txBody>
-          <a:bodyPr wrap="square" lIns="0" tIns="0" rIns="0" bIns="0" rtlCol="0" anchor="t"/>
-          <a:lstStyle/>
-          <a:p>
-            <a:pPr indent="0" marL="0">
-              <a:lnSpc>
-                <a:spcPct val="124000"/>
-              </a:lnSpc>
-              <a:buNone/>
-            </a:pPr>
-            <a:r>
-              <a:rPr lang="en-US" sz="1100" dirty="0">
-                <a:solidFill>
-                  <a:srgbClr val="942838"/>
-                </a:solidFill>
-                <a:latin typeface="Montserrat SemiBold" pitchFamily="34" charset="0"/>
-                <a:ea typeface="Montserrat SemiBold" pitchFamily="34" charset="-122"/>
-                <a:cs typeface="Montserrat SemiBold" pitchFamily="34" charset="-120"/>
-              </a:rPr>
-              <a:t>117 matched in ~12 sec; 209 rows became 46 tickets</a:t>
-            </a:r>
-            <a:endParaRPr lang="en-US" sz="1100" dirty="0"/>
+              <a:t>03</a:t>
+            </a:r>
+            <a:endParaRPr lang="en-US" sz="850" dirty="0"/>
           </a:p>
         </p:txBody>
       </p:sp>
@@ -17057,7 +17011,7 @@
       </p:grpSpPr>
       <p:pic>
         <p:nvPicPr>
-          <p:cNvPr id="2" name="Image 0" descr="/home/user/ai/assets/gen/panel-red-left.png">    </p:cNvPr>
+          <p:cNvPr id="2" name="Image 0" descr="/home/user/ai/assets/gen/logo-red.png">    </p:cNvPr>
           <p:cNvPicPr>
             <a:picLocks noChangeAspect="1"/>
           </p:cNvPicPr>
@@ -17071,48 +17025,24 @@
         </p:blipFill>
         <p:spPr>
           <a:xfrm>
-            <a:off x="0" y="0"/>
-            <a:ext cx="4343400" cy="6858000"/>
+            <a:off x="9768535" y="457200"/>
+            <a:ext cx="1645920" cy="166053"/>
           </a:xfrm>
           <a:prstGeom prst="rect">
             <a:avLst/>
           </a:prstGeom>
         </p:spPr>
       </p:pic>
-      <p:pic>
-        <p:nvPicPr>
-          <p:cNvPr id="3" name="Image 1" descr="/home/user/ai/assets/gen/mark-slash-faint.png">    </p:cNvPr>
-          <p:cNvPicPr>
-            <a:picLocks noChangeAspect="1"/>
-          </p:cNvPicPr>
-          <p:nvPr/>
-        </p:nvPicPr>
-        <p:blipFill>
-          <a:blip r:embed="rId2"/>
-          <a:stretch>
-            <a:fillRect/>
-          </a:stretch>
-        </p:blipFill>
-        <p:spPr>
-          <a:xfrm>
-            <a:off x="-640080" y="3931920"/>
-            <a:ext cx="3840480" cy="3840480"/>
-          </a:xfrm>
-          <a:prstGeom prst="rect">
-            <a:avLst/>
-          </a:prstGeom>
-        </p:spPr>
-      </p:pic>
-      <p:sp>
-        <p:nvSpPr>
-          <p:cNvPr id="4" name="Text 0"/>
-          <p:cNvSpPr txBox="1"/>
-          <p:nvPr/>
-        </p:nvSpPr>
-        <p:spPr>
-          <a:xfrm>
-            <a:off x="777240" y="1371600"/>
-            <a:ext cx="3108960" cy="237744"/>
+      <p:sp>
+        <p:nvSpPr>
+          <p:cNvPr id="3" name="Text 0"/>
+          <p:cNvSpPr txBox="1"/>
+          <p:nvPr/>
+        </p:nvSpPr>
+        <p:spPr>
+          <a:xfrm>
+            <a:off x="777240" y="658368"/>
+            <a:ext cx="7315200" cy="219456"/>
           </a:xfrm>
           <a:prstGeom prst="rect">
             <a:avLst/>
@@ -17130,13 +17060,13 @@
             <a:r>
               <a:rPr lang="en-US" sz="1000" spc="220" kern="0" dirty="0">
                 <a:solidFill>
-                  <a:srgbClr val="E4C9CE"/>
+                  <a:srgbClr val="942838"/>
                 </a:solidFill>
                 <a:latin typeface="Montserrat SemiBold" pitchFamily="34" charset="0"/>
                 <a:ea typeface="Montserrat SemiBold" pitchFamily="34" charset="-122"/>
                 <a:cs typeface="Montserrat SemiBold" pitchFamily="34" charset="-120"/>
               </a:rPr>
-              <a:t>ABOUT ME</a:t>
+              <a:t>INTERNSHIP OVERVIEW</a:t>
             </a:r>
             <a:endParaRPr lang="en-US" sz="1000" dirty="0"/>
           </a:p>
@@ -17144,14 +17074,14 @@
       </p:sp>
       <p:sp>
         <p:nvSpPr>
-          <p:cNvPr id="5" name="Text 1"/>
-          <p:cNvSpPr txBox="1"/>
-          <p:nvPr/>
-        </p:nvSpPr>
-        <p:spPr>
-          <a:xfrm>
-            <a:off x="777240" y="1737360"/>
-            <a:ext cx="3291840" cy="1371600"/>
+          <p:cNvPr id="4" name="Text 1"/>
+          <p:cNvSpPr txBox="1"/>
+          <p:nvPr/>
+        </p:nvSpPr>
+        <p:spPr>
+          <a:xfrm>
+            <a:off x="777240" y="932688"/>
+            <a:ext cx="10515600" cy="868680"/>
           </a:xfrm>
           <a:prstGeom prst="rect">
             <a:avLst/>
@@ -17170,50 +17100,325 @@
               <a:buNone/>
             </a:pPr>
             <a:r>
-              <a:rPr lang="en-US" sz="3300" spc="-70" kern="0" dirty="0">
-                <a:solidFill>
-                  <a:srgbClr val="FFFFFF"/>
+              <a:rPr lang="en-US" sz="2900" spc="-50" kern="0" dirty="0">
+                <a:solidFill>
+                  <a:srgbClr val="2B2D30"/>
                 </a:solidFill>
                 <a:latin typeface="Montserrat ExtraBold" pitchFamily="34" charset="0"/>
                 <a:ea typeface="Montserrat ExtraBold" pitchFamily="34" charset="-122"/>
                 <a:cs typeface="Montserrat ExtraBold" pitchFamily="34" charset="-120"/>
               </a:rPr>
-              <a:t>Jair Maldonado</a:t>
-            </a:r>
-            <a:endParaRPr lang="en-US" sz="3300" dirty="0"/>
-          </a:p>
-        </p:txBody>
-      </p:sp>
-      <p:sp>
-        <p:nvSpPr>
-          <p:cNvPr id="6" name="Shape 2"/>
+              <a:t>Three rotations across the security team</a:t>
+            </a:r>
+            <a:endParaRPr lang="en-US" sz="2900" dirty="0"/>
+          </a:p>
+        </p:txBody>
+      </p:sp>
+      <p:sp>
+        <p:nvSpPr>
+          <p:cNvPr id="5" name="Shape 2"/>
           <p:cNvSpPr/>
           <p:nvPr/>
         </p:nvSpPr>
         <p:spPr>
           <a:xfrm>
-            <a:off x="777240" y="3127248"/>
-            <a:ext cx="548640" cy="45720"/>
-          </a:xfrm>
-          <a:prstGeom prst="rect">
-            <a:avLst/>
+            <a:off x="777240" y="1700784"/>
+            <a:ext cx="566928" cy="50292"/>
+          </a:xfrm>
+          <a:prstGeom prst="rect">
+            <a:avLst/>
+          </a:prstGeom>
+          <a:solidFill>
+            <a:srgbClr val="942838"/>
+          </a:solidFill>
+          <a:ln/>
+        </p:spPr>
+      </p:sp>
+      <p:sp>
+        <p:nvSpPr>
+          <p:cNvPr id="6" name="Shape 3"/>
+          <p:cNvSpPr/>
+          <p:nvPr/>
+        </p:nvSpPr>
+        <p:spPr>
+          <a:xfrm>
+            <a:off x="777240" y="6181344"/>
+            <a:ext cx="10637215" cy="10973"/>
+          </a:xfrm>
+          <a:prstGeom prst="rect">
+            <a:avLst/>
+          </a:prstGeom>
+          <a:solidFill>
+            <a:srgbClr val="E6E4E2"/>
+          </a:solidFill>
+          <a:ln/>
+        </p:spPr>
+      </p:sp>
+      <p:sp>
+        <p:nvSpPr>
+          <p:cNvPr id="7" name="Text 4"/>
+          <p:cNvSpPr txBox="1"/>
+          <p:nvPr/>
+        </p:nvSpPr>
+        <p:spPr>
+          <a:xfrm>
+            <a:off x="777240" y="6327648"/>
+            <a:ext cx="7315200" cy="201168"/>
+          </a:xfrm>
+          <a:prstGeom prst="rect">
+            <a:avLst/>
+          </a:prstGeom>
+          <a:noFill/>
+          <a:ln/>
+        </p:spPr>
+        <p:txBody>
+          <a:bodyPr wrap="square" lIns="0" tIns="0" rIns="0" bIns="0" rtlCol="0" anchor="t"/>
+          <a:lstStyle/>
+          <a:p>
+            <a:pPr indent="0" marL="0">
+              <a:buNone/>
+            </a:pPr>
+            <a:r>
+              <a:rPr lang="en-US" sz="850" spc="140" kern="0" dirty="0">
+                <a:solidFill>
+                  <a:srgbClr val="6E7175"/>
+                </a:solidFill>
+                <a:latin typeface="Montserrat SemiBold" pitchFamily="34" charset="0"/>
+                <a:ea typeface="Montserrat SemiBold" pitchFamily="34" charset="-122"/>
+                <a:cs typeface="Montserrat SemiBold" pitchFamily="34" charset="-120"/>
+              </a:rPr>
+              <a:t>INTERNSHIP OVERVIEW</a:t>
+            </a:r>
+            <a:endParaRPr lang="en-US" sz="850" dirty="0"/>
+          </a:p>
+        </p:txBody>
+      </p:sp>
+      <p:sp>
+        <p:nvSpPr>
+          <p:cNvPr id="8" name="Text 5"/>
+          <p:cNvSpPr txBox="1"/>
+          <p:nvPr/>
+        </p:nvSpPr>
+        <p:spPr>
+          <a:xfrm>
+            <a:off x="10317175" y="6327648"/>
+            <a:ext cx="1097280" cy="201168"/>
+          </a:xfrm>
+          <a:prstGeom prst="rect">
+            <a:avLst/>
+          </a:prstGeom>
+          <a:noFill/>
+          <a:ln/>
+        </p:spPr>
+        <p:txBody>
+          <a:bodyPr wrap="square" lIns="0" tIns="0" rIns="0" bIns="0" rtlCol="0" anchor="t"/>
+          <a:lstStyle/>
+          <a:p>
+            <a:pPr algn="r" indent="0" marL="0">
+              <a:buNone/>
+            </a:pPr>
+            <a:r>
+              <a:rPr lang="en-US" sz="850" spc="140" kern="0" dirty="0">
+                <a:solidFill>
+                  <a:srgbClr val="6E7175"/>
+                </a:solidFill>
+                <a:latin typeface="Montserrat SemiBold" pitchFamily="34" charset="0"/>
+                <a:ea typeface="Montserrat SemiBold" pitchFamily="34" charset="-122"/>
+                <a:cs typeface="Montserrat SemiBold" pitchFamily="34" charset="-120"/>
+              </a:rPr>
+              <a:t>04</a:t>
+            </a:r>
+            <a:endParaRPr lang="en-US" sz="850" dirty="0"/>
+          </a:p>
+        </p:txBody>
+      </p:sp>
+      <p:sp>
+        <p:nvSpPr>
+          <p:cNvPr id="9" name="Text 6"/>
+          <p:cNvSpPr txBox="1"/>
+          <p:nvPr/>
+        </p:nvSpPr>
+        <p:spPr>
+          <a:xfrm>
+            <a:off x="777240" y="1883664"/>
+            <a:ext cx="9052560" cy="310896"/>
+          </a:xfrm>
+          <a:prstGeom prst="rect">
+            <a:avLst/>
+          </a:prstGeom>
+          <a:noFill/>
+          <a:ln/>
+        </p:spPr>
+        <p:txBody>
+          <a:bodyPr wrap="square" lIns="0" tIns="0" rIns="0" bIns="0" rtlCol="0" anchor="t"/>
+          <a:lstStyle/>
+          <a:p>
+            <a:pPr indent="0" marL="0">
+              <a:buNone/>
+            </a:pPr>
+            <a:r>
+              <a:rPr lang="en-US" sz="1400" dirty="0">
+                <a:solidFill>
+                  <a:srgbClr val="6E7175"/>
+                </a:solidFill>
+                <a:latin typeface="Montserrat Medium" pitchFamily="34" charset="0"/>
+                <a:ea typeface="Montserrat Medium" pitchFamily="34" charset="-122"/>
+                <a:cs typeface="Montserrat Medium" pitchFamily="34" charset="-120"/>
+              </a:rPr>
+              <a:t>I moved through three different areas of Information Security. Each rotation produced one project.</a:t>
+            </a:r>
+            <a:endParaRPr lang="en-US" sz="1400" dirty="0"/>
+          </a:p>
+        </p:txBody>
+      </p:sp>
+      <p:sp>
+        <p:nvSpPr>
+          <p:cNvPr id="10" name="Shape 7"/>
+          <p:cNvSpPr/>
+          <p:nvPr/>
+        </p:nvSpPr>
+        <p:spPr>
+          <a:xfrm>
+            <a:off x="777240" y="2852928"/>
+            <a:ext cx="10637215" cy="10973"/>
+          </a:xfrm>
+          <a:prstGeom prst="rect">
+            <a:avLst/>
+          </a:prstGeom>
+          <a:solidFill>
+            <a:srgbClr val="C9C6C4"/>
+          </a:solidFill>
+          <a:ln/>
+        </p:spPr>
+      </p:sp>
+      <p:sp>
+        <p:nvSpPr>
+          <p:cNvPr id="11" name="Shape 8"/>
+          <p:cNvSpPr/>
+          <p:nvPr/>
+        </p:nvSpPr>
+        <p:spPr>
+          <a:xfrm>
+            <a:off x="1033272" y="2756916"/>
+            <a:ext cx="201168" cy="201168"/>
+          </a:xfrm>
+          <a:prstGeom prst="ellipse">
+            <a:avLst/>
+          </a:prstGeom>
+          <a:solidFill>
+            <a:srgbClr val="942838"/>
+          </a:solidFill>
+          <a:ln w="25400">
+            <a:solidFill>
+              <a:srgbClr val="FFFFFF"/>
+            </a:solidFill>
+            <a:prstDash val="solid"/>
+          </a:ln>
+        </p:spPr>
+      </p:sp>
+      <p:sp>
+        <p:nvSpPr>
+          <p:cNvPr id="12" name="Shape 9"/>
+          <p:cNvSpPr/>
+          <p:nvPr/>
+        </p:nvSpPr>
+        <p:spPr>
+          <a:xfrm>
+            <a:off x="777240" y="3310128"/>
+            <a:ext cx="3310128" cy="2286000"/>
+          </a:xfrm>
+          <a:prstGeom prst="roundRect">
+            <a:avLst>
+              <a:gd name="adj" fmla="val 2400"/>
+            </a:avLst>
           </a:prstGeom>
           <a:solidFill>
             <a:srgbClr val="FFFFFF"/>
           </a:solidFill>
-          <a:ln/>
-        </p:spPr>
-      </p:sp>
-      <p:sp>
-        <p:nvSpPr>
-          <p:cNvPr id="7" name="Text 3"/>
-          <p:cNvSpPr txBox="1"/>
-          <p:nvPr/>
-        </p:nvSpPr>
-        <p:spPr>
-          <a:xfrm>
-            <a:off x="777240" y="3364992"/>
-            <a:ext cx="3200400" cy="548640"/>
+          <a:ln w="9525">
+            <a:solidFill>
+              <a:srgbClr val="E6E4E2"/>
+            </a:solidFill>
+            <a:prstDash val="solid"/>
+          </a:ln>
+          <a:effectLst>
+            <a:outerShdw sx="100000" sy="100000" kx="0" ky="0" algn="bl" rotWithShape="0" blurRad="177800" dist="44450" dir="5400000">
+              <a:srgbClr val="959092">
+                <a:alpha val="22000"/>
+              </a:srgbClr>
+            </a:outerShdw>
+          </a:effectLst>
+        </p:spPr>
+      </p:sp>
+      <p:sp>
+        <p:nvSpPr>
+          <p:cNvPr id="13" name="Shape 10"/>
+          <p:cNvSpPr/>
+          <p:nvPr/>
+        </p:nvSpPr>
+        <p:spPr>
+          <a:xfrm>
+            <a:off x="777240" y="3310128"/>
+            <a:ext cx="3310128" cy="50292"/>
+          </a:xfrm>
+          <a:prstGeom prst="rect">
+            <a:avLst/>
+          </a:prstGeom>
+          <a:solidFill>
+            <a:srgbClr val="942838"/>
+          </a:solidFill>
+          <a:ln/>
+        </p:spPr>
+      </p:sp>
+      <p:sp>
+        <p:nvSpPr>
+          <p:cNvPr id="14" name="Text 11"/>
+          <p:cNvSpPr txBox="1"/>
+          <p:nvPr/>
+        </p:nvSpPr>
+        <p:spPr>
+          <a:xfrm>
+            <a:off x="1088136" y="3566160"/>
+            <a:ext cx="914400" cy="384048"/>
+          </a:xfrm>
+          <a:prstGeom prst="rect">
+            <a:avLst/>
+          </a:prstGeom>
+          <a:noFill/>
+          <a:ln/>
+        </p:spPr>
+        <p:txBody>
+          <a:bodyPr wrap="square" lIns="0" tIns="0" rIns="0" bIns="0" rtlCol="0" anchor="t"/>
+          <a:lstStyle/>
+          <a:p>
+            <a:pPr indent="0" marL="0">
+              <a:buNone/>
+            </a:pPr>
+            <a:r>
+              <a:rPr lang="en-US" sz="2400" spc="-50" kern="0" dirty="0">
+                <a:solidFill>
+                  <a:srgbClr val="DFBEC4"/>
+                </a:solidFill>
+                <a:latin typeface="Montserrat ExtraBold" pitchFamily="34" charset="0"/>
+                <a:ea typeface="Montserrat ExtraBold" pitchFamily="34" charset="-122"/>
+                <a:cs typeface="Montserrat ExtraBold" pitchFamily="34" charset="-120"/>
+              </a:rPr>
+              <a:t>01</a:t>
+            </a:r>
+            <a:endParaRPr lang="en-US" sz="2400" dirty="0"/>
+          </a:p>
+        </p:txBody>
+      </p:sp>
+      <p:sp>
+        <p:nvSpPr>
+          <p:cNvPr id="15" name="Text 12"/>
+          <p:cNvSpPr txBox="1"/>
+          <p:nvPr/>
+        </p:nvSpPr>
+        <p:spPr>
+          <a:xfrm>
+            <a:off x="1088136" y="4041648"/>
+            <a:ext cx="2688336" cy="329184"/>
           </a:xfrm>
           <a:prstGeom prst="rect">
             <a:avLst/>
@@ -17227,113 +17432,237 @@
           <a:p>
             <a:pPr indent="0" marL="0">
               <a:lnSpc>
-                <a:spcPct val="120000"/>
+                <a:spcPct val="105000"/>
               </a:lnSpc>
               <a:buNone/>
             </a:pPr>
             <a:r>
-              <a:rPr lang="en-US" sz="950" spc="30" kern="0" dirty="0">
-                <a:solidFill>
-                  <a:srgbClr val="E4C9CE"/>
-                </a:solidFill>
-                <a:latin typeface="Montserrat Medium" pitchFamily="34" charset="0"/>
-                <a:ea typeface="Montserrat Medium" pitchFamily="34" charset="-122"/>
-                <a:cs typeface="Montserrat Medium" pitchFamily="34" charset="-120"/>
-              </a:rPr>
-              <a:t>Information Security Analyst Intern</a:t>
-            </a:r>
-            <a:endParaRPr lang="en-US" sz="950" dirty="0"/>
-          </a:p>
-        </p:txBody>
-      </p:sp>
-      <p:sp>
-        <p:nvSpPr>
-          <p:cNvPr id="8" name="Text 4"/>
-          <p:cNvSpPr txBox="1"/>
-          <p:nvPr/>
-        </p:nvSpPr>
-        <p:spPr>
-          <a:xfrm>
-            <a:off x="5120640" y="868680"/>
-            <a:ext cx="6293815" cy="237744"/>
-          </a:xfrm>
-          <a:prstGeom prst="rect">
-            <a:avLst/>
-          </a:prstGeom>
-          <a:noFill/>
-          <a:ln/>
-        </p:spPr>
-        <p:txBody>
-          <a:bodyPr wrap="square" lIns="0" tIns="0" rIns="0" bIns="0" rtlCol="0" anchor="t"/>
-          <a:lstStyle/>
-          <a:p>
-            <a:pPr indent="0" marL="0">
-              <a:buNone/>
-            </a:pPr>
-            <a:r>
-              <a:rPr lang="en-US" sz="1000" spc="220" kern="0" dirty="0">
-                <a:solidFill>
-                  <a:srgbClr val="942838"/>
+              <a:rPr lang="en-US" sz="1500" dirty="0">
+                <a:solidFill>
+                  <a:srgbClr val="2B2D30"/>
                 </a:solidFill>
                 <a:latin typeface="Montserrat SemiBold" pitchFamily="34" charset="0"/>
                 <a:ea typeface="Montserrat SemiBold" pitchFamily="34" charset="-122"/>
                 <a:cs typeface="Montserrat SemiBold" pitchFamily="34" charset="-120"/>
               </a:rPr>
-              <a:t>BACKGROUND</a:t>
-            </a:r>
-            <a:endParaRPr lang="en-US" sz="1000" dirty="0"/>
-          </a:p>
-        </p:txBody>
-      </p:sp>
-      <p:sp>
-        <p:nvSpPr>
-          <p:cNvPr id="9" name="Text 5"/>
-          <p:cNvSpPr txBox="1"/>
-          <p:nvPr/>
-        </p:nvSpPr>
-        <p:spPr>
-          <a:xfrm>
-            <a:off x="5120640" y="1298448"/>
-            <a:ext cx="6293815" cy="219456"/>
-          </a:xfrm>
-          <a:prstGeom prst="rect">
-            <a:avLst/>
-          </a:prstGeom>
-          <a:noFill/>
-          <a:ln/>
-        </p:spPr>
-        <p:txBody>
-          <a:bodyPr wrap="square" lIns="0" tIns="0" rIns="0" bIns="0" rtlCol="0" anchor="t"/>
-          <a:lstStyle/>
-          <a:p>
-            <a:pPr indent="0" marL="0">
-              <a:buNone/>
-            </a:pPr>
-            <a:r>
-              <a:rPr lang="en-US" sz="850" spc="140" kern="0" dirty="0">
-                <a:solidFill>
-                  <a:srgbClr val="942838"/>
+              <a:t>Vulnerability Management</a:t>
+            </a:r>
+            <a:endParaRPr lang="en-US" sz="1500" dirty="0"/>
+          </a:p>
+        </p:txBody>
+      </p:sp>
+      <p:sp>
+        <p:nvSpPr>
+          <p:cNvPr id="16" name="Text 13"/>
+          <p:cNvSpPr txBox="1"/>
+          <p:nvPr/>
+        </p:nvSpPr>
+        <p:spPr>
+          <a:xfrm>
+            <a:off x="1088136" y="4462272"/>
+            <a:ext cx="2688336" cy="777240"/>
+          </a:xfrm>
+          <a:prstGeom prst="rect">
+            <a:avLst/>
+          </a:prstGeom>
+          <a:noFill/>
+          <a:ln/>
+        </p:spPr>
+        <p:txBody>
+          <a:bodyPr wrap="square" lIns="0" tIns="0" rIns="0" bIns="0" rtlCol="0" anchor="t"/>
+          <a:lstStyle/>
+          <a:p>
+            <a:pPr indent="0" marL="0">
+              <a:lnSpc>
+                <a:spcPct val="122000"/>
+              </a:lnSpc>
+              <a:buNone/>
+            </a:pPr>
+            <a:r>
+              <a:rPr lang="en-US" sz="1100" dirty="0">
+                <a:solidFill>
+                  <a:srgbClr val="6E7175"/>
+                </a:solidFill>
+                <a:latin typeface="Montserrat" pitchFamily="34" charset="0"/>
+                <a:ea typeface="Montserrat" pitchFamily="34" charset="-122"/>
+                <a:cs typeface="Montserrat" pitchFamily="34" charset="-120"/>
+              </a:rPr>
+              <a:t>Finding known weaknesses across company machines and making sure they actually get fixed.</a:t>
+            </a:r>
+            <a:endParaRPr lang="en-US" sz="1100" dirty="0"/>
+          </a:p>
+        </p:txBody>
+      </p:sp>
+      <p:sp>
+        <p:nvSpPr>
+          <p:cNvPr id="17" name="Shape 14"/>
+          <p:cNvSpPr/>
+          <p:nvPr/>
+        </p:nvSpPr>
+        <p:spPr>
+          <a:xfrm>
+            <a:off x="4696816" y="2756916"/>
+            <a:ext cx="201168" cy="201168"/>
+          </a:xfrm>
+          <a:prstGeom prst="ellipse">
+            <a:avLst/>
+          </a:prstGeom>
+          <a:solidFill>
+            <a:srgbClr val="942838"/>
+          </a:solidFill>
+          <a:ln w="25400">
+            <a:solidFill>
+              <a:srgbClr val="FFFFFF"/>
+            </a:solidFill>
+            <a:prstDash val="solid"/>
+          </a:ln>
+        </p:spPr>
+      </p:sp>
+      <p:sp>
+        <p:nvSpPr>
+          <p:cNvPr id="18" name="Shape 15"/>
+          <p:cNvSpPr/>
+          <p:nvPr/>
+        </p:nvSpPr>
+        <p:spPr>
+          <a:xfrm>
+            <a:off x="4440784" y="3310128"/>
+            <a:ext cx="3310128" cy="2286000"/>
+          </a:xfrm>
+          <a:prstGeom prst="roundRect">
+            <a:avLst>
+              <a:gd name="adj" fmla="val 2400"/>
+            </a:avLst>
+          </a:prstGeom>
+          <a:solidFill>
+            <a:srgbClr val="FFFFFF"/>
+          </a:solidFill>
+          <a:ln w="9525">
+            <a:solidFill>
+              <a:srgbClr val="E6E4E2"/>
+            </a:solidFill>
+            <a:prstDash val="solid"/>
+          </a:ln>
+          <a:effectLst>
+            <a:outerShdw sx="100000" sy="100000" kx="0" ky="0" algn="bl" rotWithShape="0" blurRad="2258060000" dist="564515000" dir="324000000000">
+              <a:srgbClr val="959092">
+                <a:alpha val="2200000000"/>
+              </a:srgbClr>
+            </a:outerShdw>
+          </a:effectLst>
+        </p:spPr>
+      </p:sp>
+      <p:sp>
+        <p:nvSpPr>
+          <p:cNvPr id="19" name="Shape 16"/>
+          <p:cNvSpPr/>
+          <p:nvPr/>
+        </p:nvSpPr>
+        <p:spPr>
+          <a:xfrm>
+            <a:off x="4440784" y="3310128"/>
+            <a:ext cx="3310128" cy="50292"/>
+          </a:xfrm>
+          <a:prstGeom prst="rect">
+            <a:avLst/>
+          </a:prstGeom>
+          <a:solidFill>
+            <a:srgbClr val="942838"/>
+          </a:solidFill>
+          <a:ln/>
+        </p:spPr>
+      </p:sp>
+      <p:sp>
+        <p:nvSpPr>
+          <p:cNvPr id="20" name="Text 17"/>
+          <p:cNvSpPr txBox="1"/>
+          <p:nvPr/>
+        </p:nvSpPr>
+        <p:spPr>
+          <a:xfrm>
+            <a:off x="4751680" y="3566160"/>
+            <a:ext cx="914400" cy="384048"/>
+          </a:xfrm>
+          <a:prstGeom prst="rect">
+            <a:avLst/>
+          </a:prstGeom>
+          <a:noFill/>
+          <a:ln/>
+        </p:spPr>
+        <p:txBody>
+          <a:bodyPr wrap="square" lIns="0" tIns="0" rIns="0" bIns="0" rtlCol="0" anchor="t"/>
+          <a:lstStyle/>
+          <a:p>
+            <a:pPr indent="0" marL="0">
+              <a:buNone/>
+            </a:pPr>
+            <a:r>
+              <a:rPr lang="en-US" sz="2400" spc="-50" kern="0" dirty="0">
+                <a:solidFill>
+                  <a:srgbClr val="DFBEC4"/>
+                </a:solidFill>
+                <a:latin typeface="Montserrat ExtraBold" pitchFamily="34" charset="0"/>
+                <a:ea typeface="Montserrat ExtraBold" pitchFamily="34" charset="-122"/>
+                <a:cs typeface="Montserrat ExtraBold" pitchFamily="34" charset="-120"/>
+              </a:rPr>
+              <a:t>02</a:t>
+            </a:r>
+            <a:endParaRPr lang="en-US" sz="2400" dirty="0"/>
+          </a:p>
+        </p:txBody>
+      </p:sp>
+      <p:sp>
+        <p:nvSpPr>
+          <p:cNvPr id="21" name="Text 18"/>
+          <p:cNvSpPr txBox="1"/>
+          <p:nvPr/>
+        </p:nvSpPr>
+        <p:spPr>
+          <a:xfrm>
+            <a:off x="4751680" y="4041648"/>
+            <a:ext cx="2688336" cy="329184"/>
+          </a:xfrm>
+          <a:prstGeom prst="rect">
+            <a:avLst/>
+          </a:prstGeom>
+          <a:noFill/>
+          <a:ln/>
+        </p:spPr>
+        <p:txBody>
+          <a:bodyPr wrap="square" lIns="0" tIns="0" rIns="0" bIns="0" rtlCol="0" anchor="t"/>
+          <a:lstStyle/>
+          <a:p>
+            <a:pPr indent="0" marL="0">
+              <a:lnSpc>
+                <a:spcPct val="105000"/>
+              </a:lnSpc>
+              <a:buNone/>
+            </a:pPr>
+            <a:r>
+              <a:rPr lang="en-US" sz="1500" dirty="0">
+                <a:solidFill>
+                  <a:srgbClr val="2B2D30"/>
                 </a:solidFill>
                 <a:latin typeface="Montserrat SemiBold" pitchFamily="34" charset="0"/>
                 <a:ea typeface="Montserrat SemiBold" pitchFamily="34" charset="-122"/>
                 <a:cs typeface="Montserrat SemiBold" pitchFamily="34" charset="-120"/>
               </a:rPr>
-              <a:t>POSITION</a:t>
-            </a:r>
-            <a:endParaRPr lang="en-US" sz="850" dirty="0"/>
-          </a:p>
-        </p:txBody>
-      </p:sp>
-      <p:sp>
-        <p:nvSpPr>
-          <p:cNvPr id="10" name="Text 6"/>
-          <p:cNvSpPr txBox="1"/>
-          <p:nvPr/>
-        </p:nvSpPr>
-        <p:spPr>
-          <a:xfrm>
-            <a:off x="5120640" y="1545336"/>
-            <a:ext cx="6293815" cy="475488"/>
+              <a:t>Application Security</a:t>
+            </a:r>
+            <a:endParaRPr lang="en-US" sz="1500" dirty="0"/>
+          </a:p>
+        </p:txBody>
+      </p:sp>
+      <p:sp>
+        <p:nvSpPr>
+          <p:cNvPr id="22" name="Text 19"/>
+          <p:cNvSpPr txBox="1"/>
+          <p:nvPr/>
+        </p:nvSpPr>
+        <p:spPr>
+          <a:xfrm>
+            <a:off x="4751680" y="4462272"/>
+            <a:ext cx="2688336" cy="777240"/>
           </a:xfrm>
           <a:prstGeom prst="rect">
             <a:avLst/>
@@ -17347,94 +17676,195 @@
           <a:p>
             <a:pPr indent="0" marL="0">
               <a:lnSpc>
-                <a:spcPct val="120000"/>
+                <a:spcPct val="122000"/>
               </a:lnSpc>
               <a:buNone/>
             </a:pPr>
             <a:r>
-              <a:rPr lang="en-US" sz="1250" dirty="0">
-                <a:solidFill>
-                  <a:srgbClr val="43464A"/>
+              <a:rPr lang="en-US" sz="1100" dirty="0">
+                <a:solidFill>
+                  <a:srgbClr val="6E7175"/>
                 </a:solidFill>
                 <a:latin typeface="Montserrat" pitchFamily="34" charset="0"/>
                 <a:ea typeface="Montserrat" pitchFamily="34" charset="-122"/>
                 <a:cs typeface="Montserrat" pitchFamily="34" charset="-120"/>
               </a:rPr>
-              <a:t>Information Security Analyst Intern</a:t>
-            </a:r>
-            <a:endParaRPr lang="en-US" sz="1250" dirty="0"/>
-          </a:p>
-        </p:txBody>
-      </p:sp>
-      <p:sp>
-        <p:nvSpPr>
-          <p:cNvPr id="11" name="Shape 7"/>
+              <a:t>Checking the software we build and the outside code we rely on for weaknesses.</a:t>
+            </a:r>
+            <a:endParaRPr lang="en-US" sz="1100" dirty="0"/>
+          </a:p>
+        </p:txBody>
+      </p:sp>
+      <p:sp>
+        <p:nvSpPr>
+          <p:cNvPr id="23" name="Shape 20"/>
           <p:cNvSpPr/>
           <p:nvPr/>
         </p:nvSpPr>
         <p:spPr>
           <a:xfrm>
-            <a:off x="5120640" y="2084832"/>
-            <a:ext cx="6293815" cy="10973"/>
-          </a:xfrm>
-          <a:prstGeom prst="rect">
+            <a:off x="8360359" y="2756916"/>
+            <a:ext cx="201168" cy="201168"/>
+          </a:xfrm>
+          <a:prstGeom prst="ellipse">
             <a:avLst/>
           </a:prstGeom>
           <a:solidFill>
-            <a:srgbClr val="E6E4E2"/>
+            <a:srgbClr val="942838"/>
           </a:solidFill>
-          <a:ln/>
-        </p:spPr>
-      </p:sp>
-      <p:sp>
-        <p:nvSpPr>
-          <p:cNvPr id="12" name="Text 8"/>
-          <p:cNvSpPr txBox="1"/>
-          <p:nvPr/>
-        </p:nvSpPr>
-        <p:spPr>
-          <a:xfrm>
-            <a:off x="5120640" y="2240280"/>
-            <a:ext cx="6293815" cy="219456"/>
-          </a:xfrm>
-          <a:prstGeom prst="rect">
-            <a:avLst/>
-          </a:prstGeom>
-          <a:noFill/>
-          <a:ln/>
-        </p:spPr>
-        <p:txBody>
-          <a:bodyPr wrap="square" lIns="0" tIns="0" rIns="0" bIns="0" rtlCol="0" anchor="t"/>
-          <a:lstStyle/>
-          <a:p>
-            <a:pPr indent="0" marL="0">
-              <a:buNone/>
-            </a:pPr>
-            <a:r>
-              <a:rPr lang="en-US" sz="850" spc="140" kern="0" dirty="0">
-                <a:solidFill>
-                  <a:srgbClr val="942838"/>
+          <a:ln w="25400">
+            <a:solidFill>
+              <a:srgbClr val="FFFFFF"/>
+            </a:solidFill>
+            <a:prstDash val="solid"/>
+          </a:ln>
+        </p:spPr>
+      </p:sp>
+      <p:sp>
+        <p:nvSpPr>
+          <p:cNvPr id="24" name="Shape 21"/>
+          <p:cNvSpPr/>
+          <p:nvPr/>
+        </p:nvSpPr>
+        <p:spPr>
+          <a:xfrm>
+            <a:off x="8104327" y="3310128"/>
+            <a:ext cx="3310128" cy="2286000"/>
+          </a:xfrm>
+          <a:prstGeom prst="roundRect">
+            <a:avLst>
+              <a:gd name="adj" fmla="val 2400"/>
+            </a:avLst>
+          </a:prstGeom>
+          <a:solidFill>
+            <a:srgbClr val="FFFFFF"/>
+          </a:solidFill>
+          <a:ln w="9525">
+            <a:solidFill>
+              <a:srgbClr val="E6E4E2"/>
+            </a:solidFill>
+            <a:prstDash val="solid"/>
+          </a:ln>
+          <a:effectLst>
+            <a:outerShdw sx="100000" sy="100000" kx="0" ky="0" algn="bl" rotWithShape="0" blurRad="28677362000000" dist="7169340500000" dir="19440000000000000">
+              <a:srgbClr val="959092">
+                <a:alpha val="220000000000000"/>
+              </a:srgbClr>
+            </a:outerShdw>
+          </a:effectLst>
+        </p:spPr>
+      </p:sp>
+      <p:sp>
+        <p:nvSpPr>
+          <p:cNvPr id="25" name="Shape 22"/>
+          <p:cNvSpPr/>
+          <p:nvPr/>
+        </p:nvSpPr>
+        <p:spPr>
+          <a:xfrm>
+            <a:off x="8104327" y="3310128"/>
+            <a:ext cx="3310128" cy="50292"/>
+          </a:xfrm>
+          <a:prstGeom prst="rect">
+            <a:avLst/>
+          </a:prstGeom>
+          <a:solidFill>
+            <a:srgbClr val="942838"/>
+          </a:solidFill>
+          <a:ln/>
+        </p:spPr>
+      </p:sp>
+      <p:sp>
+        <p:nvSpPr>
+          <p:cNvPr id="26" name="Text 23"/>
+          <p:cNvSpPr txBox="1"/>
+          <p:nvPr/>
+        </p:nvSpPr>
+        <p:spPr>
+          <a:xfrm>
+            <a:off x="8415223" y="3566160"/>
+            <a:ext cx="914400" cy="384048"/>
+          </a:xfrm>
+          <a:prstGeom prst="rect">
+            <a:avLst/>
+          </a:prstGeom>
+          <a:noFill/>
+          <a:ln/>
+        </p:spPr>
+        <p:txBody>
+          <a:bodyPr wrap="square" lIns="0" tIns="0" rIns="0" bIns="0" rtlCol="0" anchor="t"/>
+          <a:lstStyle/>
+          <a:p>
+            <a:pPr indent="0" marL="0">
+              <a:buNone/>
+            </a:pPr>
+            <a:r>
+              <a:rPr lang="en-US" sz="2400" spc="-50" kern="0" dirty="0">
+                <a:solidFill>
+                  <a:srgbClr val="DFBEC4"/>
+                </a:solidFill>
+                <a:latin typeface="Montserrat ExtraBold" pitchFamily="34" charset="0"/>
+                <a:ea typeface="Montserrat ExtraBold" pitchFamily="34" charset="-122"/>
+                <a:cs typeface="Montserrat ExtraBold" pitchFamily="34" charset="-120"/>
+              </a:rPr>
+              <a:t>03</a:t>
+            </a:r>
+            <a:endParaRPr lang="en-US" sz="2400" dirty="0"/>
+          </a:p>
+        </p:txBody>
+      </p:sp>
+      <p:sp>
+        <p:nvSpPr>
+          <p:cNvPr id="27" name="Text 24"/>
+          <p:cNvSpPr txBox="1"/>
+          <p:nvPr/>
+        </p:nvSpPr>
+        <p:spPr>
+          <a:xfrm>
+            <a:off x="8415223" y="4041648"/>
+            <a:ext cx="2688336" cy="329184"/>
+          </a:xfrm>
+          <a:prstGeom prst="rect">
+            <a:avLst/>
+          </a:prstGeom>
+          <a:noFill/>
+          <a:ln/>
+        </p:spPr>
+        <p:txBody>
+          <a:bodyPr wrap="square" lIns="0" tIns="0" rIns="0" bIns="0" rtlCol="0" anchor="t"/>
+          <a:lstStyle/>
+          <a:p>
+            <a:pPr indent="0" marL="0">
+              <a:lnSpc>
+                <a:spcPct val="105000"/>
+              </a:lnSpc>
+              <a:buNone/>
+            </a:pPr>
+            <a:r>
+              <a:rPr lang="en-US" sz="1500" dirty="0">
+                <a:solidFill>
+                  <a:srgbClr val="2B2D30"/>
                 </a:solidFill>
                 <a:latin typeface="Montserrat SemiBold" pitchFamily="34" charset="0"/>
                 <a:ea typeface="Montserrat SemiBold" pitchFamily="34" charset="-122"/>
                 <a:cs typeface="Montserrat SemiBold" pitchFamily="34" charset="-120"/>
               </a:rPr>
-              <a:t>SCHOOL</a:t>
-            </a:r>
-            <a:endParaRPr lang="en-US" sz="850" dirty="0"/>
-          </a:p>
-        </p:txBody>
-      </p:sp>
-      <p:sp>
-        <p:nvSpPr>
-          <p:cNvPr id="13" name="Text 9"/>
-          <p:cNvSpPr txBox="1"/>
-          <p:nvPr/>
-        </p:nvSpPr>
-        <p:spPr>
-          <a:xfrm>
-            <a:off x="5120640" y="2487168"/>
-            <a:ext cx="6293815" cy="475488"/>
+              <a:t>Network Security</a:t>
+            </a:r>
+            <a:endParaRPr lang="en-US" sz="1500" dirty="0"/>
+          </a:p>
+        </p:txBody>
+      </p:sp>
+      <p:sp>
+        <p:nvSpPr>
+          <p:cNvPr id="28" name="Text 25"/>
+          <p:cNvSpPr txBox="1"/>
+          <p:nvPr/>
+        </p:nvSpPr>
+        <p:spPr>
+          <a:xfrm>
+            <a:off x="8415223" y="4462272"/>
+            <a:ext cx="2688336" cy="777240"/>
           </a:xfrm>
           <a:prstGeom prst="rect">
             <a:avLst/>
@@ -17448,447 +17878,22 @@
           <a:p>
             <a:pPr indent="0" marL="0">
               <a:lnSpc>
-                <a:spcPct val="120000"/>
+                <a:spcPct val="122000"/>
               </a:lnSpc>
               <a:buNone/>
             </a:pPr>
             <a:r>
-              <a:rPr lang="en-US" sz="1250" dirty="0">
-                <a:solidFill>
-                  <a:srgbClr val="43464A"/>
+              <a:rPr lang="en-US" sz="1100" dirty="0">
+                <a:solidFill>
+                  <a:srgbClr val="6E7175"/>
                 </a:solidFill>
                 <a:latin typeface="Montserrat" pitchFamily="34" charset="0"/>
                 <a:ea typeface="Montserrat" pitchFamily="34" charset="-122"/>
                 <a:cs typeface="Montserrat" pitchFamily="34" charset="-120"/>
               </a:rPr>
-              <a:t>Studying cybersecurity, with a focus on offensive security</a:t>
-            </a:r>
-            <a:endParaRPr lang="en-US" sz="1250" dirty="0"/>
-          </a:p>
-        </p:txBody>
-      </p:sp>
-      <p:sp>
-        <p:nvSpPr>
-          <p:cNvPr id="14" name="Shape 10"/>
-          <p:cNvSpPr/>
-          <p:nvPr/>
-        </p:nvSpPr>
-        <p:spPr>
-          <a:xfrm>
-            <a:off x="5120640" y="3026664"/>
-            <a:ext cx="6293815" cy="10973"/>
-          </a:xfrm>
-          <a:prstGeom prst="rect">
-            <a:avLst/>
-          </a:prstGeom>
-          <a:solidFill>
-            <a:srgbClr val="E6E4E2"/>
-          </a:solidFill>
-          <a:ln/>
-        </p:spPr>
-      </p:sp>
-      <p:sp>
-        <p:nvSpPr>
-          <p:cNvPr id="15" name="Text 11"/>
-          <p:cNvSpPr txBox="1"/>
-          <p:nvPr/>
-        </p:nvSpPr>
-        <p:spPr>
-          <a:xfrm>
-            <a:off x="5120640" y="3182112"/>
-            <a:ext cx="6293815" cy="219456"/>
-          </a:xfrm>
-          <a:prstGeom prst="rect">
-            <a:avLst/>
-          </a:prstGeom>
-          <a:noFill/>
-          <a:ln/>
-        </p:spPr>
-        <p:txBody>
-          <a:bodyPr wrap="square" lIns="0" tIns="0" rIns="0" bIns="0" rtlCol="0" anchor="t"/>
-          <a:lstStyle/>
-          <a:p>
-            <a:pPr indent="0" marL="0">
-              <a:buNone/>
-            </a:pPr>
-            <a:r>
-              <a:rPr lang="en-US" sz="850" spc="140" kern="0" dirty="0">
-                <a:solidFill>
-                  <a:srgbClr val="942838"/>
-                </a:solidFill>
-                <a:latin typeface="Montserrat SemiBold" pitchFamily="34" charset="0"/>
-                <a:ea typeface="Montserrat SemiBold" pitchFamily="34" charset="-122"/>
-                <a:cs typeface="Montserrat SemiBold" pitchFamily="34" charset="-120"/>
-              </a:rPr>
-              <a:t>BACKGROUND</a:t>
-            </a:r>
-            <a:endParaRPr lang="en-US" sz="850" dirty="0"/>
-          </a:p>
-        </p:txBody>
-      </p:sp>
-      <p:sp>
-        <p:nvSpPr>
-          <p:cNvPr id="16" name="Text 12"/>
-          <p:cNvSpPr txBox="1"/>
-          <p:nvPr/>
-        </p:nvSpPr>
-        <p:spPr>
-          <a:xfrm>
-            <a:off x="5120640" y="3429000"/>
-            <a:ext cx="6293815" cy="475488"/>
-          </a:xfrm>
-          <a:prstGeom prst="rect">
-            <a:avLst/>
-          </a:prstGeom>
-          <a:noFill/>
-          <a:ln/>
-        </p:spPr>
-        <p:txBody>
-          <a:bodyPr wrap="square" lIns="0" tIns="0" rIns="0" bIns="0" rtlCol="0" anchor="t"/>
-          <a:lstStyle/>
-          <a:p>
-            <a:pPr indent="0" marL="0">
-              <a:lnSpc>
-                <a:spcPct val="120000"/>
-              </a:lnSpc>
-              <a:buNone/>
-            </a:pPr>
-            <a:r>
-              <a:rPr lang="en-US" sz="1250" dirty="0">
-                <a:solidFill>
-                  <a:srgbClr val="43464A"/>
-                </a:solidFill>
-                <a:latin typeface="Montserrat" pitchFamily="34" charset="0"/>
-                <a:ea typeface="Montserrat" pitchFamily="34" charset="-122"/>
-                <a:cs typeface="Montserrat" pitchFamily="34" charset="-120"/>
-              </a:rPr>
-              <a:t>Hands-on security work across vulnerability management, application security, and network security</a:t>
-            </a:r>
-            <a:endParaRPr lang="en-US" sz="1250" dirty="0"/>
-          </a:p>
-        </p:txBody>
-      </p:sp>
-      <p:sp>
-        <p:nvSpPr>
-          <p:cNvPr id="17" name="Shape 13"/>
-          <p:cNvSpPr/>
-          <p:nvPr/>
-        </p:nvSpPr>
-        <p:spPr>
-          <a:xfrm>
-            <a:off x="5120640" y="3968496"/>
-            <a:ext cx="6293815" cy="10973"/>
-          </a:xfrm>
-          <a:prstGeom prst="rect">
-            <a:avLst/>
-          </a:prstGeom>
-          <a:solidFill>
-            <a:srgbClr val="E6E4E2"/>
-          </a:solidFill>
-          <a:ln/>
-        </p:spPr>
-      </p:sp>
-      <p:sp>
-        <p:nvSpPr>
-          <p:cNvPr id="18" name="Text 14"/>
-          <p:cNvSpPr txBox="1"/>
-          <p:nvPr/>
-        </p:nvSpPr>
-        <p:spPr>
-          <a:xfrm>
-            <a:off x="5120640" y="4123944"/>
-            <a:ext cx="6293815" cy="219456"/>
-          </a:xfrm>
-          <a:prstGeom prst="rect">
-            <a:avLst/>
-          </a:prstGeom>
-          <a:noFill/>
-          <a:ln/>
-        </p:spPr>
-        <p:txBody>
-          <a:bodyPr wrap="square" lIns="0" tIns="0" rIns="0" bIns="0" rtlCol="0" anchor="t"/>
-          <a:lstStyle/>
-          <a:p>
-            <a:pPr indent="0" marL="0">
-              <a:buNone/>
-            </a:pPr>
-            <a:r>
-              <a:rPr lang="en-US" sz="850" spc="140" kern="0" dirty="0">
-                <a:solidFill>
-                  <a:srgbClr val="942838"/>
-                </a:solidFill>
-                <a:latin typeface="Montserrat SemiBold" pitchFamily="34" charset="0"/>
-                <a:ea typeface="Montserrat SemiBold" pitchFamily="34" charset="-122"/>
-                <a:cs typeface="Montserrat SemiBold" pitchFamily="34" charset="-120"/>
-              </a:rPr>
-              <a:t>CERTIFICATIONS</a:t>
-            </a:r>
-            <a:endParaRPr lang="en-US" sz="850" dirty="0"/>
-          </a:p>
-        </p:txBody>
-      </p:sp>
-      <p:sp>
-        <p:nvSpPr>
-          <p:cNvPr id="19" name="Text 15"/>
-          <p:cNvSpPr txBox="1"/>
-          <p:nvPr/>
-        </p:nvSpPr>
-        <p:spPr>
-          <a:xfrm>
-            <a:off x="5120640" y="4370832"/>
-            <a:ext cx="6293815" cy="475488"/>
-          </a:xfrm>
-          <a:prstGeom prst="rect">
-            <a:avLst/>
-          </a:prstGeom>
-          <a:noFill/>
-          <a:ln/>
-        </p:spPr>
-        <p:txBody>
-          <a:bodyPr wrap="square" lIns="0" tIns="0" rIns="0" bIns="0" rtlCol="0" anchor="t"/>
-          <a:lstStyle/>
-          <a:p>
-            <a:pPr indent="0" marL="0">
-              <a:lnSpc>
-                <a:spcPct val="120000"/>
-              </a:lnSpc>
-              <a:buNone/>
-            </a:pPr>
-            <a:r>
-              <a:rPr lang="en-US" sz="1250" dirty="0">
-                <a:solidFill>
-                  <a:srgbClr val="43464A"/>
-                </a:solidFill>
-                <a:latin typeface="Montserrat" pitchFamily="34" charset="0"/>
-                <a:ea typeface="Montserrat" pitchFamily="34" charset="-122"/>
-                <a:cs typeface="Montserrat" pitchFamily="34" charset="-120"/>
-              </a:rPr>
-              <a:t>Working toward the PWPA and PJPT practical certifications</a:t>
-            </a:r>
-            <a:endParaRPr lang="en-US" sz="1250" dirty="0"/>
-          </a:p>
-        </p:txBody>
-      </p:sp>
-      <p:sp>
-        <p:nvSpPr>
-          <p:cNvPr id="20" name="Shape 16"/>
-          <p:cNvSpPr/>
-          <p:nvPr/>
-        </p:nvSpPr>
-        <p:spPr>
-          <a:xfrm>
-            <a:off x="5120640" y="4910328"/>
-            <a:ext cx="6293815" cy="10973"/>
-          </a:xfrm>
-          <a:prstGeom prst="rect">
-            <a:avLst/>
-          </a:prstGeom>
-          <a:solidFill>
-            <a:srgbClr val="E6E4E2"/>
-          </a:solidFill>
-          <a:ln/>
-        </p:spPr>
-      </p:sp>
-      <p:sp>
-        <p:nvSpPr>
-          <p:cNvPr id="21" name="Text 17"/>
-          <p:cNvSpPr txBox="1"/>
-          <p:nvPr/>
-        </p:nvSpPr>
-        <p:spPr>
-          <a:xfrm>
-            <a:off x="5120640" y="5065776"/>
-            <a:ext cx="6293815" cy="219456"/>
-          </a:xfrm>
-          <a:prstGeom prst="rect">
-            <a:avLst/>
-          </a:prstGeom>
-          <a:noFill/>
-          <a:ln/>
-        </p:spPr>
-        <p:txBody>
-          <a:bodyPr wrap="square" lIns="0" tIns="0" rIns="0" bIns="0" rtlCol="0" anchor="t"/>
-          <a:lstStyle/>
-          <a:p>
-            <a:pPr indent="0" marL="0">
-              <a:buNone/>
-            </a:pPr>
-            <a:r>
-              <a:rPr lang="en-US" sz="850" spc="140" kern="0" dirty="0">
-                <a:solidFill>
-                  <a:srgbClr val="942838"/>
-                </a:solidFill>
-                <a:latin typeface="Montserrat SemiBold" pitchFamily="34" charset="0"/>
-                <a:ea typeface="Montserrat SemiBold" pitchFamily="34" charset="-122"/>
-                <a:cs typeface="Montserrat SemiBold" pitchFamily="34" charset="-120"/>
-              </a:rPr>
-              <a:t>CAREER DIRECTION</a:t>
-            </a:r>
-            <a:endParaRPr lang="en-US" sz="850" dirty="0"/>
-          </a:p>
-        </p:txBody>
-      </p:sp>
-      <p:sp>
-        <p:nvSpPr>
-          <p:cNvPr id="22" name="Text 18"/>
-          <p:cNvSpPr txBox="1"/>
-          <p:nvPr/>
-        </p:nvSpPr>
-        <p:spPr>
-          <a:xfrm>
-            <a:off x="5120640" y="5312664"/>
-            <a:ext cx="6293815" cy="475488"/>
-          </a:xfrm>
-          <a:prstGeom prst="rect">
-            <a:avLst/>
-          </a:prstGeom>
-          <a:noFill/>
-          <a:ln/>
-        </p:spPr>
-        <p:txBody>
-          <a:bodyPr wrap="square" lIns="0" tIns="0" rIns="0" bIns="0" rtlCol="0" anchor="t"/>
-          <a:lstStyle/>
-          <a:p>
-            <a:pPr indent="0" marL="0">
-              <a:lnSpc>
-                <a:spcPct val="120000"/>
-              </a:lnSpc>
-              <a:buNone/>
-            </a:pPr>
-            <a:r>
-              <a:rPr lang="en-US" sz="1250" dirty="0">
-                <a:solidFill>
-                  <a:srgbClr val="43464A"/>
-                </a:solidFill>
-                <a:latin typeface="Montserrat" pitchFamily="34" charset="0"/>
-                <a:ea typeface="Montserrat" pitchFamily="34" charset="-122"/>
-                <a:cs typeface="Montserrat" pitchFamily="34" charset="-120"/>
-              </a:rPr>
-              <a:t>Penetration testing — finding weaknesses before an attacker does</a:t>
-            </a:r>
-            <a:endParaRPr lang="en-US" sz="1250" dirty="0"/>
-          </a:p>
-        </p:txBody>
-      </p:sp>
-      <p:pic>
-        <p:nvPicPr>
-          <p:cNvPr id="23" name="Image 2" descr="/home/user/ai/assets/gen/logo-red.png">    </p:cNvPr>
-          <p:cNvPicPr>
-            <a:picLocks noChangeAspect="1"/>
-          </p:cNvPicPr>
-          <p:nvPr/>
-        </p:nvPicPr>
-        <p:blipFill>
-          <a:blip r:embed="rId3"/>
-          <a:stretch>
-            <a:fillRect/>
-          </a:stretch>
-        </p:blipFill>
-        <p:spPr>
-          <a:xfrm>
-            <a:off x="9768535" y="457200"/>
-            <a:ext cx="1645920" cy="166053"/>
-          </a:xfrm>
-          <a:prstGeom prst="rect">
-            <a:avLst/>
-          </a:prstGeom>
-        </p:spPr>
-      </p:pic>
-      <p:sp>
-        <p:nvSpPr>
-          <p:cNvPr id="24" name="Shape 19"/>
-          <p:cNvSpPr/>
-          <p:nvPr/>
-        </p:nvSpPr>
-        <p:spPr>
-          <a:xfrm>
-            <a:off x="5120640" y="6181344"/>
-            <a:ext cx="6293815" cy="10973"/>
-          </a:xfrm>
-          <a:prstGeom prst="rect">
-            <a:avLst/>
-          </a:prstGeom>
-          <a:solidFill>
-            <a:srgbClr val="E6E4E2"/>
-          </a:solidFill>
-          <a:ln/>
-        </p:spPr>
-      </p:sp>
-      <p:sp>
-        <p:nvSpPr>
-          <p:cNvPr id="25" name="Text 20"/>
-          <p:cNvSpPr txBox="1"/>
-          <p:nvPr/>
-        </p:nvSpPr>
-        <p:spPr>
-          <a:xfrm>
-            <a:off x="5120640" y="6327648"/>
-            <a:ext cx="7315200" cy="201168"/>
-          </a:xfrm>
-          <a:prstGeom prst="rect">
-            <a:avLst/>
-          </a:prstGeom>
-          <a:noFill/>
-          <a:ln/>
-        </p:spPr>
-        <p:txBody>
-          <a:bodyPr wrap="square" lIns="0" tIns="0" rIns="0" bIns="0" rtlCol="0" anchor="t"/>
-          <a:lstStyle/>
-          <a:p>
-            <a:pPr indent="0" marL="0">
-              <a:buNone/>
-            </a:pPr>
-            <a:r>
-              <a:rPr lang="en-US" sz="850" spc="140" kern="0" dirty="0">
-                <a:solidFill>
-                  <a:srgbClr val="6E7175"/>
-                </a:solidFill>
-                <a:latin typeface="Montserrat SemiBold" pitchFamily="34" charset="0"/>
-                <a:ea typeface="Montserrat SemiBold" pitchFamily="34" charset="-122"/>
-                <a:cs typeface="Montserrat SemiBold" pitchFamily="34" charset="-120"/>
-              </a:rPr>
-              <a:t>ABOUT ME</a:t>
-            </a:r>
-            <a:endParaRPr lang="en-US" sz="850" dirty="0"/>
-          </a:p>
-        </p:txBody>
-      </p:sp>
-      <p:sp>
-        <p:nvSpPr>
-          <p:cNvPr id="26" name="Text 21"/>
-          <p:cNvSpPr txBox="1"/>
-          <p:nvPr/>
-        </p:nvSpPr>
-        <p:spPr>
-          <a:xfrm>
-            <a:off x="10317175" y="6327648"/>
-            <a:ext cx="1097280" cy="201168"/>
-          </a:xfrm>
-          <a:prstGeom prst="rect">
-            <a:avLst/>
-          </a:prstGeom>
-          <a:noFill/>
-          <a:ln/>
-        </p:spPr>
-        <p:txBody>
-          <a:bodyPr wrap="square" lIns="0" tIns="0" rIns="0" bIns="0" rtlCol="0" anchor="t"/>
-          <a:lstStyle/>
-          <a:p>
-            <a:pPr algn="r" indent="0" marL="0">
-              <a:buNone/>
-            </a:pPr>
-            <a:r>
-              <a:rPr lang="en-US" sz="850" spc="140" kern="0" dirty="0">
-                <a:solidFill>
-                  <a:srgbClr val="6E7175"/>
-                </a:solidFill>
-                <a:latin typeface="Montserrat SemiBold" pitchFamily="34" charset="0"/>
-                <a:ea typeface="Montserrat SemiBold" pitchFamily="34" charset="-122"/>
-                <a:cs typeface="Montserrat SemiBold" pitchFamily="34" charset="-120"/>
-              </a:rPr>
-              <a:t>04</a:t>
-            </a:r>
-            <a:endParaRPr lang="en-US" sz="850" dirty="0"/>
+              <a:t>Protecting how machines talk to each other, and what is allowed in and out.</a:t>
+            </a:r>
+            <a:endParaRPr lang="en-US" sz="1100" dirty="0"/>
           </a:p>
         </p:txBody>
       </p:sp>
@@ -17981,7 +17986,7 @@
                 <a:ea typeface="Montserrat SemiBold" pitchFamily="34" charset="-122"/>
                 <a:cs typeface="Montserrat SemiBold" pitchFamily="34" charset="-120"/>
               </a:rPr>
-              <a:t>INTERNSHIP OVERVIEW</a:t>
+              <a:t>EXECUTIVE SUMMARY</a:t>
             </a:r>
             <a:endParaRPr lang="en-US" sz="1000" dirty="0"/>
           </a:p>
@@ -18023,7 +18028,7 @@
                 <a:ea typeface="Montserrat ExtraBold" pitchFamily="34" charset="-122"/>
                 <a:cs typeface="Montserrat ExtraBold" pitchFamily="34" charset="-120"/>
               </a:rPr>
-              <a:t>Three rotations across the security team</a:t>
+              <a:t>Three problems, three working solutions</a:t>
             </a:r>
             <a:endParaRPr lang="en-US" sz="2900" dirty="0"/>
           </a:p>
@@ -18102,7 +18107,7 @@
                 <a:ea typeface="Montserrat SemiBold" pitchFamily="34" charset="-122"/>
                 <a:cs typeface="Montserrat SemiBold" pitchFamily="34" charset="-120"/>
               </a:rPr>
-              <a:t>INTERNSHIP OVERVIEW</a:t>
+              <a:t>EXECUTIVE SUMMARY</a:t>
             </a:r>
             <a:endParaRPr lang="en-US" sz="850" dirty="0"/>
           </a:p>
@@ -18155,8 +18160,8 @@
         </p:nvSpPr>
         <p:spPr>
           <a:xfrm>
-            <a:off x="777240" y="1883664"/>
-            <a:ext cx="9052560" cy="310896"/>
+            <a:off x="777240" y="1956816"/>
+            <a:ext cx="10241280" cy="310896"/>
           </a:xfrm>
           <a:prstGeom prst="rect">
             <a:avLst/>
@@ -18180,7 +18185,7 @@
                 <a:ea typeface="Montserrat Medium" pitchFamily="34" charset="-122"/>
                 <a:cs typeface="Montserrat Medium" pitchFamily="34" charset="-120"/>
               </a:rPr>
-              <a:t>I moved through three different areas of Information Security. Each rotation produced one project.</a:t>
+              <a:t>One from each rotation. Three separate gaps, three things the team keeps using — then the detail on each.</a:t>
             </a:r>
             <a:endParaRPr lang="en-US" sz="1400" dirty="0"/>
           </a:p>
@@ -18188,194 +18193,151 @@
       </p:sp>
       <p:sp>
         <p:nvSpPr>
-          <p:cNvPr id="10" name="Shape 7"/>
-          <p:cNvSpPr/>
-          <p:nvPr/>
-        </p:nvSpPr>
-        <p:spPr>
-          <a:xfrm>
-            <a:off x="777240" y="2852928"/>
-            <a:ext cx="10637215" cy="10973"/>
-          </a:xfrm>
-          <a:prstGeom prst="rect">
-            <a:avLst/>
-          </a:prstGeom>
-          <a:solidFill>
-            <a:srgbClr val="C9C6C4"/>
-          </a:solidFill>
-          <a:ln/>
-        </p:spPr>
-      </p:sp>
-      <p:sp>
-        <p:nvSpPr>
-          <p:cNvPr id="11" name="Shape 8"/>
-          <p:cNvSpPr/>
-          <p:nvPr/>
-        </p:nvSpPr>
-        <p:spPr>
-          <a:xfrm>
-            <a:off x="1033272" y="2756916"/>
-            <a:ext cx="201168" cy="201168"/>
-          </a:xfrm>
-          <a:prstGeom prst="ellipse">
-            <a:avLst/>
-          </a:prstGeom>
-          <a:solidFill>
-            <a:srgbClr val="942838"/>
-          </a:solidFill>
-          <a:ln w="25400">
-            <a:solidFill>
-              <a:srgbClr val="FFFFFF"/>
-            </a:solidFill>
-            <a:prstDash val="solid"/>
-          </a:ln>
-        </p:spPr>
-      </p:sp>
-      <p:sp>
-        <p:nvSpPr>
-          <p:cNvPr id="12" name="Shape 9"/>
-          <p:cNvSpPr/>
-          <p:nvPr/>
-        </p:nvSpPr>
-        <p:spPr>
-          <a:xfrm>
-            <a:off x="777240" y="3310128"/>
-            <a:ext cx="3310128" cy="2286000"/>
-          </a:xfrm>
-          <a:prstGeom prst="roundRect">
-            <a:avLst>
-              <a:gd name="adj" fmla="val 2400"/>
-            </a:avLst>
-          </a:prstGeom>
-          <a:solidFill>
-            <a:srgbClr val="FFFFFF"/>
-          </a:solidFill>
-          <a:ln w="9525">
-            <a:solidFill>
-              <a:srgbClr val="E6E4E2"/>
-            </a:solidFill>
-            <a:prstDash val="solid"/>
-          </a:ln>
-          <a:effectLst>
-            <a:outerShdw sx="100000" sy="100000" kx="0" ky="0" algn="bl" rotWithShape="0" blurRad="177800" dist="44450" dir="5400000">
-              <a:srgbClr val="959092">
-                <a:alpha val="22000"/>
-              </a:srgbClr>
-            </a:outerShdw>
-          </a:effectLst>
-        </p:spPr>
-      </p:sp>
-      <p:sp>
-        <p:nvSpPr>
-          <p:cNvPr id="13" name="Shape 10"/>
-          <p:cNvSpPr/>
-          <p:nvPr/>
-        </p:nvSpPr>
-        <p:spPr>
-          <a:xfrm>
-            <a:off x="777240" y="3310128"/>
-            <a:ext cx="3310128" cy="50292"/>
-          </a:xfrm>
-          <a:prstGeom prst="rect">
-            <a:avLst/>
-          </a:prstGeom>
-          <a:solidFill>
-            <a:srgbClr val="942838"/>
-          </a:solidFill>
-          <a:ln/>
-        </p:spPr>
-      </p:sp>
-      <p:sp>
-        <p:nvSpPr>
-          <p:cNvPr id="14" name="Text 11"/>
-          <p:cNvSpPr txBox="1"/>
-          <p:nvPr/>
-        </p:nvSpPr>
-        <p:spPr>
-          <a:xfrm>
-            <a:off x="1088136" y="3566160"/>
-            <a:ext cx="914400" cy="384048"/>
-          </a:xfrm>
-          <a:prstGeom prst="rect">
-            <a:avLst/>
-          </a:prstGeom>
-          <a:noFill/>
-          <a:ln/>
-        </p:spPr>
-        <p:txBody>
-          <a:bodyPr wrap="square" lIns="0" tIns="0" rIns="0" bIns="0" rtlCol="0" anchor="t"/>
-          <a:lstStyle/>
-          <a:p>
-            <a:pPr indent="0" marL="0">
-              <a:buNone/>
-            </a:pPr>
-            <a:r>
-              <a:rPr lang="en-US" sz="2400" spc="-50" kern="0" dirty="0">
-                <a:solidFill>
-                  <a:srgbClr val="DFBEC4"/>
-                </a:solidFill>
-                <a:latin typeface="Montserrat ExtraBold" pitchFamily="34" charset="0"/>
-                <a:ea typeface="Montserrat ExtraBold" pitchFamily="34" charset="-122"/>
-                <a:cs typeface="Montserrat ExtraBold" pitchFamily="34" charset="-120"/>
-              </a:rPr>
-              <a:t>01</a:t>
-            </a:r>
-            <a:endParaRPr lang="en-US" sz="2400" dirty="0"/>
-          </a:p>
-        </p:txBody>
-      </p:sp>
-      <p:sp>
-        <p:nvSpPr>
-          <p:cNvPr id="15" name="Text 12"/>
-          <p:cNvSpPr txBox="1"/>
-          <p:nvPr/>
-        </p:nvSpPr>
-        <p:spPr>
-          <a:xfrm>
-            <a:off x="1088136" y="4041648"/>
-            <a:ext cx="2688336" cy="329184"/>
-          </a:xfrm>
-          <a:prstGeom prst="rect">
-            <a:avLst/>
-          </a:prstGeom>
-          <a:noFill/>
-          <a:ln/>
-        </p:spPr>
-        <p:txBody>
-          <a:bodyPr wrap="square" lIns="0" tIns="0" rIns="0" bIns="0" rtlCol="0" anchor="t"/>
-          <a:lstStyle/>
-          <a:p>
-            <a:pPr indent="0" marL="0">
-              <a:lnSpc>
-                <a:spcPct val="105000"/>
-              </a:lnSpc>
-              <a:buNone/>
-            </a:pPr>
-            <a:r>
-              <a:rPr lang="en-US" sz="1500" dirty="0">
-                <a:solidFill>
-                  <a:srgbClr val="2B2D30"/>
+          <p:cNvPr id="10" name="Text 7"/>
+          <p:cNvSpPr txBox="1"/>
+          <p:nvPr/>
+        </p:nvSpPr>
+        <p:spPr>
+          <a:xfrm>
+            <a:off x="777240" y="2487168"/>
+            <a:ext cx="3200400" cy="201168"/>
+          </a:xfrm>
+          <a:prstGeom prst="rect">
+            <a:avLst/>
+          </a:prstGeom>
+          <a:noFill/>
+          <a:ln/>
+        </p:spPr>
+        <p:txBody>
+          <a:bodyPr wrap="square" lIns="0" tIns="0" rIns="0" bIns="0" rtlCol="0" anchor="t"/>
+          <a:lstStyle/>
+          <a:p>
+            <a:pPr indent="0" marL="0">
+              <a:buNone/>
+            </a:pPr>
+            <a:r>
+              <a:rPr lang="en-US" sz="850" spc="140" kern="0" dirty="0">
+                <a:solidFill>
+                  <a:srgbClr val="942838"/>
                 </a:solidFill>
                 <a:latin typeface="Montserrat SemiBold" pitchFamily="34" charset="0"/>
                 <a:ea typeface="Montserrat SemiBold" pitchFamily="34" charset="-122"/>
                 <a:cs typeface="Montserrat SemiBold" pitchFamily="34" charset="-120"/>
               </a:rPr>
-              <a:t>Vulnerability Management</a:t>
-            </a:r>
-            <a:endParaRPr lang="en-US" sz="1500" dirty="0"/>
-          </a:p>
-        </p:txBody>
-      </p:sp>
-      <p:sp>
-        <p:nvSpPr>
-          <p:cNvPr id="16" name="Text 13"/>
-          <p:cNvSpPr txBox="1"/>
-          <p:nvPr/>
-        </p:nvSpPr>
-        <p:spPr>
-          <a:xfrm>
-            <a:off x="1088136" y="4462272"/>
-            <a:ext cx="2688336" cy="777240"/>
+              <a:t>THE PROBLEM</a:t>
+            </a:r>
+            <a:endParaRPr lang="en-US" sz="850" dirty="0"/>
+          </a:p>
+        </p:txBody>
+      </p:sp>
+      <p:sp>
+        <p:nvSpPr>
+          <p:cNvPr id="11" name="Text 8"/>
+          <p:cNvSpPr txBox="1"/>
+          <p:nvPr/>
+        </p:nvSpPr>
+        <p:spPr>
+          <a:xfrm>
+            <a:off x="4224528" y="2487168"/>
+            <a:ext cx="3657600" cy="201168"/>
+          </a:xfrm>
+          <a:prstGeom prst="rect">
+            <a:avLst/>
+          </a:prstGeom>
+          <a:noFill/>
+          <a:ln/>
+        </p:spPr>
+        <p:txBody>
+          <a:bodyPr wrap="square" lIns="0" tIns="0" rIns="0" bIns="0" rtlCol="0" anchor="t"/>
+          <a:lstStyle/>
+          <a:p>
+            <a:pPr indent="0" marL="0">
+              <a:buNone/>
+            </a:pPr>
+            <a:r>
+              <a:rPr lang="en-US" sz="850" spc="140" kern="0" dirty="0">
+                <a:solidFill>
+                  <a:srgbClr val="942838"/>
+                </a:solidFill>
+                <a:latin typeface="Montserrat SemiBold" pitchFamily="34" charset="0"/>
+                <a:ea typeface="Montserrat SemiBold" pitchFamily="34" charset="-122"/>
+                <a:cs typeface="Montserrat SemiBold" pitchFamily="34" charset="-120"/>
+              </a:rPr>
+              <a:t>WHAT I BUILT</a:t>
+            </a:r>
+            <a:endParaRPr lang="en-US" sz="850" dirty="0"/>
+          </a:p>
+        </p:txBody>
+      </p:sp>
+      <p:sp>
+        <p:nvSpPr>
+          <p:cNvPr id="12" name="Text 9"/>
+          <p:cNvSpPr txBox="1"/>
+          <p:nvPr/>
+        </p:nvSpPr>
+        <p:spPr>
+          <a:xfrm>
+            <a:off x="8101584" y="2487168"/>
+            <a:ext cx="3312871" cy="201168"/>
+          </a:xfrm>
+          <a:prstGeom prst="rect">
+            <a:avLst/>
+          </a:prstGeom>
+          <a:noFill/>
+          <a:ln/>
+        </p:spPr>
+        <p:txBody>
+          <a:bodyPr wrap="square" lIns="0" tIns="0" rIns="0" bIns="0" rtlCol="0" anchor="t"/>
+          <a:lstStyle/>
+          <a:p>
+            <a:pPr indent="0" marL="0">
+              <a:buNone/>
+            </a:pPr>
+            <a:r>
+              <a:rPr lang="en-US" sz="850" spc="140" kern="0" dirty="0">
+                <a:solidFill>
+                  <a:srgbClr val="942838"/>
+                </a:solidFill>
+                <a:latin typeface="Montserrat SemiBold" pitchFamily="34" charset="0"/>
+                <a:ea typeface="Montserrat SemiBold" pitchFamily="34" charset="-122"/>
+                <a:cs typeface="Montserrat SemiBold" pitchFamily="34" charset="-120"/>
+              </a:rPr>
+              <a:t>THE PROOF</a:t>
+            </a:r>
+            <a:endParaRPr lang="en-US" sz="850" dirty="0"/>
+          </a:p>
+        </p:txBody>
+      </p:sp>
+      <p:sp>
+        <p:nvSpPr>
+          <p:cNvPr id="13" name="Shape 10"/>
+          <p:cNvSpPr/>
+          <p:nvPr/>
+        </p:nvSpPr>
+        <p:spPr>
+          <a:xfrm>
+            <a:off x="777240" y="2743200"/>
+            <a:ext cx="10637215" cy="10973"/>
+          </a:xfrm>
+          <a:prstGeom prst="rect">
+            <a:avLst/>
+          </a:prstGeom>
+          <a:solidFill>
+            <a:srgbClr val="E6E4E2"/>
+          </a:solidFill>
+          <a:ln/>
+        </p:spPr>
+      </p:sp>
+      <p:sp>
+        <p:nvSpPr>
+          <p:cNvPr id="14" name="Text 11"/>
+          <p:cNvSpPr txBox="1"/>
+          <p:nvPr/>
+        </p:nvSpPr>
+        <p:spPr>
+          <a:xfrm>
+            <a:off x="777240" y="2889504"/>
+            <a:ext cx="3200400" cy="822960"/>
           </a:xfrm>
           <a:prstGeom prst="rect">
             <a:avLst/>
@@ -18389,20 +18351,20 @@
           <a:p>
             <a:pPr indent="0" marL="0">
               <a:lnSpc>
-                <a:spcPct val="122000"/>
+                <a:spcPct val="124000"/>
               </a:lnSpc>
               <a:buNone/>
             </a:pPr>
             <a:r>
               <a:rPr lang="en-US" sz="1100" dirty="0">
                 <a:solidFill>
-                  <a:srgbClr val="6E7175"/>
+                  <a:srgbClr val="43464A"/>
                 </a:solidFill>
                 <a:latin typeface="Montserrat" pitchFamily="34" charset="0"/>
                 <a:ea typeface="Montserrat" pitchFamily="34" charset="-122"/>
                 <a:cs typeface="Montserrat" pitchFamily="34" charset="-120"/>
               </a:rPr>
-              <a:t>Finding known weaknesses across company machines and making sure they actually get fixed.</a:t>
+              <a:t>New machines could ship without the security tools they need.</a:t>
             </a:r>
             <a:endParaRPr lang="en-US" sz="1100" dirty="0"/>
           </a:p>
@@ -18410,132 +18372,14 @@
       </p:sp>
       <p:sp>
         <p:nvSpPr>
-          <p:cNvPr id="17" name="Shape 14"/>
-          <p:cNvSpPr/>
-          <p:nvPr/>
-        </p:nvSpPr>
-        <p:spPr>
-          <a:xfrm>
-            <a:off x="4696816" y="2756916"/>
-            <a:ext cx="201168" cy="201168"/>
-          </a:xfrm>
-          <a:prstGeom prst="ellipse">
-            <a:avLst/>
-          </a:prstGeom>
-          <a:solidFill>
-            <a:srgbClr val="942838"/>
-          </a:solidFill>
-          <a:ln w="25400">
-            <a:solidFill>
-              <a:srgbClr val="FFFFFF"/>
-            </a:solidFill>
-            <a:prstDash val="solid"/>
-          </a:ln>
-        </p:spPr>
-      </p:sp>
-      <p:sp>
-        <p:nvSpPr>
-          <p:cNvPr id="18" name="Shape 15"/>
-          <p:cNvSpPr/>
-          <p:nvPr/>
-        </p:nvSpPr>
-        <p:spPr>
-          <a:xfrm>
-            <a:off x="4440784" y="3310128"/>
-            <a:ext cx="3310128" cy="2286000"/>
-          </a:xfrm>
-          <a:prstGeom prst="roundRect">
-            <a:avLst>
-              <a:gd name="adj" fmla="val 2400"/>
-            </a:avLst>
-          </a:prstGeom>
-          <a:solidFill>
-            <a:srgbClr val="FFFFFF"/>
-          </a:solidFill>
-          <a:ln w="9525">
-            <a:solidFill>
-              <a:srgbClr val="E6E4E2"/>
-            </a:solidFill>
-            <a:prstDash val="solid"/>
-          </a:ln>
-          <a:effectLst>
-            <a:outerShdw sx="100000" sy="100000" kx="0" ky="0" algn="bl" rotWithShape="0" blurRad="2258060000" dist="564515000" dir="324000000000">
-              <a:srgbClr val="959092">
-                <a:alpha val="2200000000"/>
-              </a:srgbClr>
-            </a:outerShdw>
-          </a:effectLst>
-        </p:spPr>
-      </p:sp>
-      <p:sp>
-        <p:nvSpPr>
-          <p:cNvPr id="19" name="Shape 16"/>
-          <p:cNvSpPr/>
-          <p:nvPr/>
-        </p:nvSpPr>
-        <p:spPr>
-          <a:xfrm>
-            <a:off x="4440784" y="3310128"/>
-            <a:ext cx="3310128" cy="50292"/>
-          </a:xfrm>
-          <a:prstGeom prst="rect">
-            <a:avLst/>
-          </a:prstGeom>
-          <a:solidFill>
-            <a:srgbClr val="942838"/>
-          </a:solidFill>
-          <a:ln/>
-        </p:spPr>
-      </p:sp>
-      <p:sp>
-        <p:nvSpPr>
-          <p:cNvPr id="20" name="Text 17"/>
-          <p:cNvSpPr txBox="1"/>
-          <p:nvPr/>
-        </p:nvSpPr>
-        <p:spPr>
-          <a:xfrm>
-            <a:off x="4751680" y="3566160"/>
-            <a:ext cx="914400" cy="384048"/>
-          </a:xfrm>
-          <a:prstGeom prst="rect">
-            <a:avLst/>
-          </a:prstGeom>
-          <a:noFill/>
-          <a:ln/>
-        </p:spPr>
-        <p:txBody>
-          <a:bodyPr wrap="square" lIns="0" tIns="0" rIns="0" bIns="0" rtlCol="0" anchor="t"/>
-          <a:lstStyle/>
-          <a:p>
-            <a:pPr indent="0" marL="0">
-              <a:buNone/>
-            </a:pPr>
-            <a:r>
-              <a:rPr lang="en-US" sz="2400" spc="-50" kern="0" dirty="0">
-                <a:solidFill>
-                  <a:srgbClr val="DFBEC4"/>
-                </a:solidFill>
-                <a:latin typeface="Montserrat ExtraBold" pitchFamily="34" charset="0"/>
-                <a:ea typeface="Montserrat ExtraBold" pitchFamily="34" charset="-122"/>
-                <a:cs typeface="Montserrat ExtraBold" pitchFamily="34" charset="-120"/>
-              </a:rPr>
-              <a:t>02</a:t>
-            </a:r>
-            <a:endParaRPr lang="en-US" sz="2400" dirty="0"/>
-          </a:p>
-        </p:txBody>
-      </p:sp>
-      <p:sp>
-        <p:nvSpPr>
-          <p:cNvPr id="21" name="Text 18"/>
-          <p:cNvSpPr txBox="1"/>
-          <p:nvPr/>
-        </p:nvSpPr>
-        <p:spPr>
-          <a:xfrm>
-            <a:off x="4751680" y="4041648"/>
-            <a:ext cx="2688336" cy="329184"/>
+          <p:cNvPr id="15" name="Text 12"/>
+          <p:cNvSpPr txBox="1"/>
+          <p:nvPr/>
+        </p:nvSpPr>
+        <p:spPr>
+          <a:xfrm>
+            <a:off x="4224528" y="2889504"/>
+            <a:ext cx="3383280" cy="822960"/>
           </a:xfrm>
           <a:prstGeom prst="rect">
             <a:avLst/>
@@ -18549,12 +18393,12 @@
           <a:p>
             <a:pPr indent="0" marL="0">
               <a:lnSpc>
-                <a:spcPct val="105000"/>
+                <a:spcPct val="124000"/>
               </a:lnSpc>
               <a:buNone/>
             </a:pPr>
             <a:r>
-              <a:rPr lang="en-US" sz="1500" dirty="0">
+              <a:rPr lang="en-US" sz="1100" dirty="0">
                 <a:solidFill>
                   <a:srgbClr val="2B2D30"/>
                 </a:solidFill>
@@ -18562,49 +18406,133 @@
                 <a:ea typeface="Montserrat SemiBold" pitchFamily="34" charset="-122"/>
                 <a:cs typeface="Montserrat SemiBold" pitchFamily="34" charset="-120"/>
               </a:rPr>
-              <a:t>Application Security</a:t>
-            </a:r>
-            <a:endParaRPr lang="en-US" sz="1500" dirty="0"/>
-          </a:p>
-        </p:txBody>
-      </p:sp>
-      <p:sp>
-        <p:nvSpPr>
-          <p:cNvPr id="22" name="Text 19"/>
-          <p:cNvSpPr txBox="1"/>
-          <p:nvPr/>
-        </p:nvSpPr>
-        <p:spPr>
-          <a:xfrm>
-            <a:off x="4751680" y="4462272"/>
-            <a:ext cx="2688336" cy="777240"/>
-          </a:xfrm>
-          <a:prstGeom prst="rect">
-            <a:avLst/>
-          </a:prstGeom>
-          <a:noFill/>
-          <a:ln/>
-        </p:spPr>
-        <p:txBody>
-          <a:bodyPr wrap="square" lIns="0" tIns="0" rIns="0" bIns="0" rtlCol="0" anchor="t"/>
+              <a:t>A written framework naming all nine required tools and who owns each.</a:t>
+            </a:r>
+            <a:endParaRPr lang="en-US" sz="1100" dirty="0"/>
+          </a:p>
+        </p:txBody>
+      </p:sp>
+      <p:sp>
+        <p:nvSpPr>
+          <p:cNvPr id="16" name="Shape 13"/>
+          <p:cNvSpPr/>
+          <p:nvPr/>
+        </p:nvSpPr>
+        <p:spPr>
+          <a:xfrm>
+            <a:off x="7918704" y="2779776"/>
+            <a:ext cx="3495751" cy="859536"/>
+          </a:xfrm>
+          <a:prstGeom prst="roundRect">
+            <a:avLst>
+              <a:gd name="adj" fmla="val 5319"/>
+            </a:avLst>
+          </a:prstGeom>
+          <a:solidFill>
+            <a:srgbClr val="F6EEF0"/>
+          </a:solidFill>
+          <a:ln/>
+        </p:spPr>
+      </p:sp>
+      <p:sp>
+        <p:nvSpPr>
+          <p:cNvPr id="17" name="Text 14"/>
+          <p:cNvSpPr txBox="1"/>
+          <p:nvPr/>
+        </p:nvSpPr>
+        <p:spPr>
+          <a:xfrm>
+            <a:off x="8101584" y="2779776"/>
+            <a:ext cx="3129991" cy="859536"/>
+          </a:xfrm>
+          <a:prstGeom prst="rect">
+            <a:avLst/>
+          </a:prstGeom>
+          <a:noFill/>
+          <a:ln/>
+        </p:spPr>
+        <p:txBody>
+          <a:bodyPr wrap="square" lIns="0" tIns="0" rIns="0" bIns="0" rtlCol="0" anchor="ctr"/>
           <a:lstStyle/>
           <a:p>
             <a:pPr indent="0" marL="0">
               <a:lnSpc>
-                <a:spcPct val="122000"/>
+                <a:spcPct val="124000"/>
               </a:lnSpc>
               <a:buNone/>
             </a:pPr>
             <a:r>
               <a:rPr lang="en-US" sz="1100" dirty="0">
                 <a:solidFill>
-                  <a:srgbClr val="6E7175"/>
+                  <a:srgbClr val="942838"/>
+                </a:solidFill>
+                <a:latin typeface="Montserrat SemiBold" pitchFamily="34" charset="0"/>
+                <a:ea typeface="Montserrat SemiBold" pitchFamily="34" charset="-122"/>
+                <a:cs typeface="Montserrat SemiBold" pitchFamily="34" charset="-120"/>
+              </a:rPr>
+              <a:t>Drafted and staged for Q4 sign-off</a:t>
+            </a:r>
+            <a:endParaRPr lang="en-US" sz="1100" dirty="0"/>
+          </a:p>
+        </p:txBody>
+      </p:sp>
+      <p:sp>
+        <p:nvSpPr>
+          <p:cNvPr id="18" name="Shape 15"/>
+          <p:cNvSpPr/>
+          <p:nvPr/>
+        </p:nvSpPr>
+        <p:spPr>
+          <a:xfrm>
+            <a:off x="777240" y="3858768"/>
+            <a:ext cx="10637215" cy="10973"/>
+          </a:xfrm>
+          <a:prstGeom prst="rect">
+            <a:avLst/>
+          </a:prstGeom>
+          <a:solidFill>
+            <a:srgbClr val="E6E4E2"/>
+          </a:solidFill>
+          <a:ln/>
+        </p:spPr>
+      </p:sp>
+      <p:sp>
+        <p:nvSpPr>
+          <p:cNvPr id="19" name="Text 16"/>
+          <p:cNvSpPr txBox="1"/>
+          <p:nvPr/>
+        </p:nvSpPr>
+        <p:spPr>
+          <a:xfrm>
+            <a:off x="777240" y="4023360"/>
+            <a:ext cx="3200400" cy="822960"/>
+          </a:xfrm>
+          <a:prstGeom prst="rect">
+            <a:avLst/>
+          </a:prstGeom>
+          <a:noFill/>
+          <a:ln/>
+        </p:spPr>
+        <p:txBody>
+          <a:bodyPr wrap="square" lIns="0" tIns="0" rIns="0" bIns="0" rtlCol="0" anchor="t"/>
+          <a:lstStyle/>
+          <a:p>
+            <a:pPr indent="0" marL="0">
+              <a:lnSpc>
+                <a:spcPct val="124000"/>
+              </a:lnSpc>
+              <a:buNone/>
+            </a:pPr>
+            <a:r>
+              <a:rPr lang="en-US" sz="1100" dirty="0">
+                <a:solidFill>
+                  <a:srgbClr val="43464A"/>
                 </a:solidFill>
                 <a:latin typeface="Montserrat" pitchFamily="34" charset="0"/>
                 <a:ea typeface="Montserrat" pitchFamily="34" charset="-122"/>
                 <a:cs typeface="Montserrat" pitchFamily="34" charset="-120"/>
               </a:rPr>
-              <a:t>Checking the software we build and the outside code we rely on for weaknesses.</a:t>
+              <a:t>Attackers hide malicious code inside the open-source packages we depend on.</a:t>
             </a:r>
             <a:endParaRPr lang="en-US" sz="1100" dirty="0"/>
           </a:p>
@@ -18612,132 +18540,14 @@
       </p:sp>
       <p:sp>
         <p:nvSpPr>
-          <p:cNvPr id="23" name="Shape 20"/>
-          <p:cNvSpPr/>
-          <p:nvPr/>
-        </p:nvSpPr>
-        <p:spPr>
-          <a:xfrm>
-            <a:off x="8360359" y="2756916"/>
-            <a:ext cx="201168" cy="201168"/>
-          </a:xfrm>
-          <a:prstGeom prst="ellipse">
-            <a:avLst/>
-          </a:prstGeom>
-          <a:solidFill>
-            <a:srgbClr val="942838"/>
-          </a:solidFill>
-          <a:ln w="25400">
-            <a:solidFill>
-              <a:srgbClr val="FFFFFF"/>
-            </a:solidFill>
-            <a:prstDash val="solid"/>
-          </a:ln>
-        </p:spPr>
-      </p:sp>
-      <p:sp>
-        <p:nvSpPr>
-          <p:cNvPr id="24" name="Shape 21"/>
-          <p:cNvSpPr/>
-          <p:nvPr/>
-        </p:nvSpPr>
-        <p:spPr>
-          <a:xfrm>
-            <a:off x="8104327" y="3310128"/>
-            <a:ext cx="3310128" cy="2286000"/>
-          </a:xfrm>
-          <a:prstGeom prst="roundRect">
-            <a:avLst>
-              <a:gd name="adj" fmla="val 2400"/>
-            </a:avLst>
-          </a:prstGeom>
-          <a:solidFill>
-            <a:srgbClr val="FFFFFF"/>
-          </a:solidFill>
-          <a:ln w="9525">
-            <a:solidFill>
-              <a:srgbClr val="E6E4E2"/>
-            </a:solidFill>
-            <a:prstDash val="solid"/>
-          </a:ln>
-          <a:effectLst>
-            <a:outerShdw sx="100000" sy="100000" kx="0" ky="0" algn="bl" rotWithShape="0" blurRad="28677362000000" dist="7169340500000" dir="19440000000000000">
-              <a:srgbClr val="959092">
-                <a:alpha val="220000000000000"/>
-              </a:srgbClr>
-            </a:outerShdw>
-          </a:effectLst>
-        </p:spPr>
-      </p:sp>
-      <p:sp>
-        <p:nvSpPr>
-          <p:cNvPr id="25" name="Shape 22"/>
-          <p:cNvSpPr/>
-          <p:nvPr/>
-        </p:nvSpPr>
-        <p:spPr>
-          <a:xfrm>
-            <a:off x="8104327" y="3310128"/>
-            <a:ext cx="3310128" cy="50292"/>
-          </a:xfrm>
-          <a:prstGeom prst="rect">
-            <a:avLst/>
-          </a:prstGeom>
-          <a:solidFill>
-            <a:srgbClr val="942838"/>
-          </a:solidFill>
-          <a:ln/>
-        </p:spPr>
-      </p:sp>
-      <p:sp>
-        <p:nvSpPr>
-          <p:cNvPr id="26" name="Text 23"/>
-          <p:cNvSpPr txBox="1"/>
-          <p:nvPr/>
-        </p:nvSpPr>
-        <p:spPr>
-          <a:xfrm>
-            <a:off x="8415223" y="3566160"/>
-            <a:ext cx="914400" cy="384048"/>
-          </a:xfrm>
-          <a:prstGeom prst="rect">
-            <a:avLst/>
-          </a:prstGeom>
-          <a:noFill/>
-          <a:ln/>
-        </p:spPr>
-        <p:txBody>
-          <a:bodyPr wrap="square" lIns="0" tIns="0" rIns="0" bIns="0" rtlCol="0" anchor="t"/>
-          <a:lstStyle/>
-          <a:p>
-            <a:pPr indent="0" marL="0">
-              <a:buNone/>
-            </a:pPr>
-            <a:r>
-              <a:rPr lang="en-US" sz="2400" spc="-50" kern="0" dirty="0">
-                <a:solidFill>
-                  <a:srgbClr val="DFBEC4"/>
-                </a:solidFill>
-                <a:latin typeface="Montserrat ExtraBold" pitchFamily="34" charset="0"/>
-                <a:ea typeface="Montserrat ExtraBold" pitchFamily="34" charset="-122"/>
-                <a:cs typeface="Montserrat ExtraBold" pitchFamily="34" charset="-120"/>
-              </a:rPr>
-              <a:t>03</a:t>
-            </a:r>
-            <a:endParaRPr lang="en-US" sz="2400" dirty="0"/>
-          </a:p>
-        </p:txBody>
-      </p:sp>
-      <p:sp>
-        <p:nvSpPr>
-          <p:cNvPr id="27" name="Text 24"/>
-          <p:cNvSpPr txBox="1"/>
-          <p:nvPr/>
-        </p:nvSpPr>
-        <p:spPr>
-          <a:xfrm>
-            <a:off x="8415223" y="4041648"/>
-            <a:ext cx="2688336" cy="329184"/>
+          <p:cNvPr id="20" name="Text 17"/>
+          <p:cNvSpPr txBox="1"/>
+          <p:nvPr/>
+        </p:nvSpPr>
+        <p:spPr>
+          <a:xfrm>
+            <a:off x="4224528" y="4023360"/>
+            <a:ext cx="3383280" cy="822960"/>
           </a:xfrm>
           <a:prstGeom prst="rect">
             <a:avLst/>
@@ -18751,12 +18561,12 @@
           <a:p>
             <a:pPr indent="0" marL="0">
               <a:lnSpc>
-                <a:spcPct val="105000"/>
+                <a:spcPct val="124000"/>
               </a:lnSpc>
               <a:buNone/>
             </a:pPr>
             <a:r>
-              <a:rPr lang="en-US" sz="1500" dirty="0">
+              <a:rPr lang="en-US" sz="1100" dirty="0">
                 <a:solidFill>
                   <a:srgbClr val="2B2D30"/>
                 </a:solidFill>
@@ -18764,49 +18574,239 @@
                 <a:ea typeface="Montserrat SemiBold" pitchFamily="34" charset="-122"/>
                 <a:cs typeface="Montserrat SemiBold" pitchFamily="34" charset="-120"/>
               </a:rPr>
-              <a:t>Network Security</a:t>
-            </a:r>
-            <a:endParaRPr lang="en-US" sz="1500" dirty="0"/>
-          </a:p>
-        </p:txBody>
-      </p:sp>
-      <p:sp>
-        <p:nvSpPr>
-          <p:cNvPr id="28" name="Text 25"/>
-          <p:cNvSpPr txBox="1"/>
-          <p:nvPr/>
-        </p:nvSpPr>
-        <p:spPr>
-          <a:xfrm>
-            <a:off x="8415223" y="4462272"/>
-            <a:ext cx="2688336" cy="777240"/>
-          </a:xfrm>
-          <a:prstGeom prst="rect">
-            <a:avLst/>
-          </a:prstGeom>
-          <a:noFill/>
-          <a:ln/>
-        </p:spPr>
-        <p:txBody>
-          <a:bodyPr wrap="square" lIns="0" tIns="0" rIns="0" bIns="0" rtlCol="0" anchor="t"/>
+              <a:t>AEGIS — a scanner that checks whether our code actually reaches the flaw.</a:t>
+            </a:r>
+            <a:endParaRPr lang="en-US" sz="1100" dirty="0"/>
+          </a:p>
+        </p:txBody>
+      </p:sp>
+      <p:sp>
+        <p:nvSpPr>
+          <p:cNvPr id="21" name="Shape 18"/>
+          <p:cNvSpPr/>
+          <p:nvPr/>
+        </p:nvSpPr>
+        <p:spPr>
+          <a:xfrm>
+            <a:off x="7918704" y="3913632"/>
+            <a:ext cx="3495751" cy="859536"/>
+          </a:xfrm>
+          <a:prstGeom prst="roundRect">
+            <a:avLst>
+              <a:gd name="adj" fmla="val 5319"/>
+            </a:avLst>
+          </a:prstGeom>
+          <a:solidFill>
+            <a:srgbClr val="F6EEF0"/>
+          </a:solidFill>
+          <a:ln/>
+        </p:spPr>
+      </p:sp>
+      <p:sp>
+        <p:nvSpPr>
+          <p:cNvPr id="22" name="Text 19"/>
+          <p:cNvSpPr txBox="1"/>
+          <p:nvPr/>
+        </p:nvSpPr>
+        <p:spPr>
+          <a:xfrm>
+            <a:off x="8101584" y="3913632"/>
+            <a:ext cx="3129991" cy="859536"/>
+          </a:xfrm>
+          <a:prstGeom prst="rect">
+            <a:avLst/>
+          </a:prstGeom>
+          <a:noFill/>
+          <a:ln/>
+        </p:spPr>
+        <p:txBody>
+          <a:bodyPr wrap="square" lIns="0" tIns="0" rIns="0" bIns="0" rtlCol="0" anchor="ctr"/>
           <a:lstStyle/>
           <a:p>
             <a:pPr indent="0" marL="0">
               <a:lnSpc>
-                <a:spcPct val="122000"/>
+                <a:spcPct val="124000"/>
               </a:lnSpc>
               <a:buNone/>
             </a:pPr>
             <a:r>
               <a:rPr lang="en-US" sz="1100" dirty="0">
                 <a:solidFill>
-                  <a:srgbClr val="6E7175"/>
+                  <a:srgbClr val="942838"/>
+                </a:solidFill>
+                <a:latin typeface="Montserrat SemiBold" pitchFamily="34" charset="0"/>
+                <a:ea typeface="Montserrat SemiBold" pitchFamily="34" charset="-122"/>
+                <a:cs typeface="Montserrat SemiBold" pitchFamily="34" charset="-120"/>
+              </a:rPr>
+              <a:t>5,675 packages scanned in production by an earlier version</a:t>
+            </a:r>
+            <a:endParaRPr lang="en-US" sz="1100" dirty="0"/>
+          </a:p>
+        </p:txBody>
+      </p:sp>
+      <p:sp>
+        <p:nvSpPr>
+          <p:cNvPr id="23" name="Shape 20"/>
+          <p:cNvSpPr/>
+          <p:nvPr/>
+        </p:nvSpPr>
+        <p:spPr>
+          <a:xfrm>
+            <a:off x="777240" y="4992624"/>
+            <a:ext cx="10637215" cy="10973"/>
+          </a:xfrm>
+          <a:prstGeom prst="rect">
+            <a:avLst/>
+          </a:prstGeom>
+          <a:solidFill>
+            <a:srgbClr val="E6E4E2"/>
+          </a:solidFill>
+          <a:ln/>
+        </p:spPr>
+      </p:sp>
+      <p:sp>
+        <p:nvSpPr>
+          <p:cNvPr id="24" name="Text 21"/>
+          <p:cNvSpPr txBox="1"/>
+          <p:nvPr/>
+        </p:nvSpPr>
+        <p:spPr>
+          <a:xfrm>
+            <a:off x="777240" y="5157216"/>
+            <a:ext cx="3200400" cy="822960"/>
+          </a:xfrm>
+          <a:prstGeom prst="rect">
+            <a:avLst/>
+          </a:prstGeom>
+          <a:noFill/>
+          <a:ln/>
+        </p:spPr>
+        <p:txBody>
+          <a:bodyPr wrap="square" lIns="0" tIns="0" rIns="0" bIns="0" rtlCol="0" anchor="t"/>
+          <a:lstStyle/>
+          <a:p>
+            <a:pPr indent="0" marL="0">
+              <a:lnSpc>
+                <a:spcPct val="124000"/>
+              </a:lnSpc>
+              <a:buNone/>
+            </a:pPr>
+            <a:r>
+              <a:rPr lang="en-US" sz="1100" dirty="0">
+                <a:solidFill>
+                  <a:srgbClr val="43464A"/>
                 </a:solidFill>
                 <a:latin typeface="Montserrat" pitchFamily="34" charset="0"/>
                 <a:ea typeface="Montserrat" pitchFamily="34" charset="-122"/>
                 <a:cs typeface="Montserrat" pitchFamily="34" charset="-120"/>
               </a:rPr>
-              <a:t>Protecting how machines talk to each other, and what is allowed in and out.</a:t>
+              <a:t>Matching every tracked flaw to its patch took about two days of analyst time.</a:t>
+            </a:r>
+            <a:endParaRPr lang="en-US" sz="1100" dirty="0"/>
+          </a:p>
+        </p:txBody>
+      </p:sp>
+      <p:sp>
+        <p:nvSpPr>
+          <p:cNvPr id="25" name="Text 22"/>
+          <p:cNvSpPr txBox="1"/>
+          <p:nvPr/>
+        </p:nvSpPr>
+        <p:spPr>
+          <a:xfrm>
+            <a:off x="4224528" y="5157216"/>
+            <a:ext cx="3383280" cy="822960"/>
+          </a:xfrm>
+          <a:prstGeom prst="rect">
+            <a:avLst/>
+          </a:prstGeom>
+          <a:noFill/>
+          <a:ln/>
+        </p:spPr>
+        <p:txBody>
+          <a:bodyPr wrap="square" lIns="0" tIns="0" rIns="0" bIns="0" rtlCol="0" anchor="t"/>
+          <a:lstStyle/>
+          <a:p>
+            <a:pPr indent="0" marL="0">
+              <a:lnSpc>
+                <a:spcPct val="124000"/>
+              </a:lnSpc>
+              <a:buNone/>
+            </a:pPr>
+            <a:r>
+              <a:rPr lang="en-US" sz="1100" dirty="0">
+                <a:solidFill>
+                  <a:srgbClr val="2B2D30"/>
+                </a:solidFill>
+                <a:latin typeface="Montserrat SemiBold" pitchFamily="34" charset="0"/>
+                <a:ea typeface="Montserrat SemiBold" pitchFamily="34" charset="-122"/>
+                <a:cs typeface="Montserrat SemiBold" pitchFamily="34" charset="-120"/>
+              </a:rPr>
+              <a:t>A script that does the matching automatically, then consolidates the result.</a:t>
+            </a:r>
+            <a:endParaRPr lang="en-US" sz="1100" dirty="0"/>
+          </a:p>
+        </p:txBody>
+      </p:sp>
+      <p:sp>
+        <p:nvSpPr>
+          <p:cNvPr id="26" name="Shape 23"/>
+          <p:cNvSpPr/>
+          <p:nvPr/>
+        </p:nvSpPr>
+        <p:spPr>
+          <a:xfrm>
+            <a:off x="7918704" y="5047488"/>
+            <a:ext cx="3495751" cy="859536"/>
+          </a:xfrm>
+          <a:prstGeom prst="roundRect">
+            <a:avLst>
+              <a:gd name="adj" fmla="val 5319"/>
+            </a:avLst>
+          </a:prstGeom>
+          <a:solidFill>
+            <a:srgbClr val="F6EEF0"/>
+          </a:solidFill>
+          <a:ln/>
+        </p:spPr>
+      </p:sp>
+      <p:sp>
+        <p:nvSpPr>
+          <p:cNvPr id="27" name="Text 24"/>
+          <p:cNvSpPr txBox="1"/>
+          <p:nvPr/>
+        </p:nvSpPr>
+        <p:spPr>
+          <a:xfrm>
+            <a:off x="8101584" y="5047488"/>
+            <a:ext cx="3129991" cy="859536"/>
+          </a:xfrm>
+          <a:prstGeom prst="rect">
+            <a:avLst/>
+          </a:prstGeom>
+          <a:noFill/>
+          <a:ln/>
+        </p:spPr>
+        <p:txBody>
+          <a:bodyPr wrap="square" lIns="0" tIns="0" rIns="0" bIns="0" rtlCol="0" anchor="ctr"/>
+          <a:lstStyle/>
+          <a:p>
+            <a:pPr indent="0" marL="0">
+              <a:lnSpc>
+                <a:spcPct val="124000"/>
+              </a:lnSpc>
+              <a:buNone/>
+            </a:pPr>
+            <a:r>
+              <a:rPr lang="en-US" sz="1100" dirty="0">
+                <a:solidFill>
+                  <a:srgbClr val="942838"/>
+                </a:solidFill>
+                <a:latin typeface="Montserrat SemiBold" pitchFamily="34" charset="0"/>
+                <a:ea typeface="Montserrat SemiBold" pitchFamily="34" charset="-122"/>
+                <a:cs typeface="Montserrat SemiBold" pitchFamily="34" charset="-120"/>
+              </a:rPr>
+              <a:t>117 matched in ~12 sec; 209 rows became 46 tickets</a:t>
             </a:r>
             <a:endParaRPr lang="en-US" sz="1100" dirty="0"/>
           </a:p>

</xml_diff>

<commit_message>
Add the business summary the contents page promises
The contents lists '06 Summary — what this means for Stewart', but rebuilding
the close as a thank-you left nothing to fulfil it. Add a wrap-up slide
before the thank-you, framed as was/now per project so it reads as a closing
verdict rather than a repeat of the executive summary's problem/built/proof
table, and ending on what survives the internship.
</commit_message>
<xml_diff>
--- a/out/Internship_Exit_Presentation_Stewart.pptx
+++ b/out/Internship_Exit_Presentation_Stewart.pptx
@@ -28,9 +28,10 @@
     <p:sldId id="276" r:id="rId22"/>
     <p:sldId id="277" r:id="rId23"/>
     <p:sldId id="278" r:id="rId24"/>
+    <p:sldId id="279" r:id="rId25"/>
   </p:sldIdLst>
   <p:notesMasterIdLst>
-    <p:notesMasterId r:id="rId25"/>
+    <p:notesMasterId r:id="rId26"/>
   </p:notesMasterIdLst>
   <p:sldSz cx="12191695" cy="6858000"/>
   <p:notesSz cx="6858000" cy="12191695"/>
@@ -1868,6 +1869,94 @@
             <a:fld id="{F7021451-1387-4CA6-816F-3879F97B5CBC}" type="slidenum">
               <a:rPr lang="en-US"/>
               <a:t>23</a:t>
+            </a:fld>
+            <a:endParaRPr lang="en-US"/>
+          </a:p>
+        </p:txBody>
+      </p:sp>
+    </p:spTree>
+    <p:extLst>
+      <p:ext uri="{BB962C8B-B14F-4D97-AF65-F5344CB8AC3E}">
+        <p14:creationId xmlns:p14="http://schemas.microsoft.com/office/powerpoint/2010/main" val="1024086991"/>
+      </p:ext>
+    </p:extLst>
+  </p:cSld>
+  <p:clrMapOvr>
+    <a:masterClrMapping/>
+  </p:clrMapOvr>
+</p:notes>
+</file>
+
+<file path=ppt/notesSlides/notesSlide24.xml><?xml version="1.0" encoding="utf-8"?>
+<p:notes xmlns:a="http://schemas.openxmlformats.org/drawingml/2006/main" xmlns:r="http://schemas.openxmlformats.org/officeDocument/2006/relationships" xmlns:p="http://schemas.openxmlformats.org/presentationml/2006/main">
+  <p:cSld>
+    <p:spTree>
+      <p:nvGrpSpPr>
+        <p:cNvPr id="1" name=""/>
+        <p:cNvGrpSpPr/>
+        <p:nvPr/>
+      </p:nvGrpSpPr>
+      <p:grpSpPr>
+        <a:xfrm>
+          <a:off x="0" y="0"/>
+          <a:ext cx="0" cy="0"/>
+          <a:chOff x="0" y="0"/>
+          <a:chExt cx="0" cy="0"/>
+        </a:xfrm>
+      </p:grpSpPr>
+      <p:sp>
+        <p:nvSpPr>
+          <p:cNvPr id="2" name="Slide Image Placeholder 1"/>
+          <p:cNvSpPr>
+            <a:spLocks noGrp="1" noRot="1" noChangeAspect="1"/>
+          </p:cNvSpPr>
+          <p:nvPr>
+            <p:ph type="sldImg"/>
+          </p:nvPr>
+        </p:nvSpPr>
+        <p:spPr/>
+      </p:sp>
+      <p:sp>
+        <p:nvSpPr>
+          <p:cNvPr id="3" name="Notes Placeholder 2"/>
+          <p:cNvSpPr>
+            <a:spLocks noGrp="1"/>
+          </p:cNvSpPr>
+          <p:nvPr>
+            <p:ph type="body" idx="1"/>
+          </p:nvPr>
+        </p:nvSpPr>
+        <p:spPr/>
+        <p:txBody>
+          <a:bodyPr/>
+          <a:lstStyle/>
+          <a:p>
+            <a:r>
+              <a:rPr lang="en-US" dirty="0"/>
+              <a:t/>
+            </a:r>
+            <a:endParaRPr lang="en-US" dirty="0"/>
+          </a:p>
+        </p:txBody>
+      </p:sp>
+      <p:sp>
+        <p:nvSpPr>
+          <p:cNvPr id="4" name="Slide Number Placeholder 3"/>
+          <p:cNvSpPr>
+            <a:spLocks noGrp="1"/>
+          </p:cNvSpPr>
+          <p:nvPr>
+            <p:ph type="sldNum" sz="quarter" idx="10"/>
+          </p:nvPr>
+        </p:nvSpPr>
+        <p:spPr/>
+        <p:txBody>
+          <a:bodyPr/>
+          <a:lstStyle/>
+          <a:p>
+            <a:fld id="{F7021451-1387-4CA6-816F-3879F97B5CBC}" type="slidenum">
+              <a:rPr lang="en-US"/>
+              <a:t>24</a:t>
             </a:fld>
             <a:endParaRPr lang="en-US"/>
           </a:p>
@@ -15664,6 +15753,1225 @@
 <file path=ppt/slides/slide23.xml><?xml version="1.0" encoding="utf-8"?>
 <p:sld xmlns:a="http://schemas.openxmlformats.org/drawingml/2006/main" xmlns:r="http://schemas.openxmlformats.org/officeDocument/2006/relationships" xmlns:p="http://schemas.openxmlformats.org/presentationml/2006/main">
   <p:cSld name="Slide 23">
+    <p:bg>
+      <p:bgPr>
+        <a:solidFill>
+          <a:srgbClr val="FFFFFF"/>
+        </a:solidFill>
+      </p:bgPr>
+    </p:bg>
+    <p:spTree>
+      <p:nvGrpSpPr>
+        <p:cNvPr id="1" name=""/>
+        <p:cNvGrpSpPr/>
+        <p:nvPr/>
+      </p:nvGrpSpPr>
+      <p:grpSpPr>
+        <a:xfrm>
+          <a:off x="0" y="0"/>
+          <a:ext cx="0" cy="0"/>
+          <a:chOff x="0" y="0"/>
+          <a:chExt cx="0" cy="0"/>
+        </a:xfrm>
+      </p:grpSpPr>
+      <p:pic>
+        <p:nvPicPr>
+          <p:cNvPr id="2" name="Image 0" descr="/home/user/ai/assets/gen/logo-red.png">    </p:cNvPr>
+          <p:cNvPicPr>
+            <a:picLocks noChangeAspect="1"/>
+          </p:cNvPicPr>
+          <p:nvPr/>
+        </p:nvPicPr>
+        <p:blipFill>
+          <a:blip r:embed="rId1"/>
+          <a:stretch>
+            <a:fillRect/>
+          </a:stretch>
+        </p:blipFill>
+        <p:spPr>
+          <a:xfrm>
+            <a:off x="9768535" y="457200"/>
+            <a:ext cx="1645920" cy="166053"/>
+          </a:xfrm>
+          <a:prstGeom prst="rect">
+            <a:avLst/>
+          </a:prstGeom>
+        </p:spPr>
+      </p:pic>
+      <p:sp>
+        <p:nvSpPr>
+          <p:cNvPr id="3" name="Text 0"/>
+          <p:cNvSpPr txBox="1"/>
+          <p:nvPr/>
+        </p:nvSpPr>
+        <p:spPr>
+          <a:xfrm>
+            <a:off x="777240" y="658368"/>
+            <a:ext cx="7315200" cy="219456"/>
+          </a:xfrm>
+          <a:prstGeom prst="rect">
+            <a:avLst/>
+          </a:prstGeom>
+          <a:noFill/>
+          <a:ln/>
+        </p:spPr>
+        <p:txBody>
+          <a:bodyPr wrap="square" lIns="0" tIns="0" rIns="0" bIns="0" rtlCol="0" anchor="t"/>
+          <a:lstStyle/>
+          <a:p>
+            <a:pPr indent="0" marL="0">
+              <a:buNone/>
+            </a:pPr>
+            <a:r>
+              <a:rPr lang="en-US" sz="1000" spc="220" kern="0" dirty="0">
+                <a:solidFill>
+                  <a:srgbClr val="942838"/>
+                </a:solidFill>
+                <a:latin typeface="Montserrat SemiBold" pitchFamily="34" charset="0"/>
+                <a:ea typeface="Montserrat SemiBold" pitchFamily="34" charset="-122"/>
+                <a:cs typeface="Montserrat SemiBold" pitchFamily="34" charset="-120"/>
+              </a:rPr>
+              <a:t>SUMMARY</a:t>
+            </a:r>
+            <a:endParaRPr lang="en-US" sz="1000" dirty="0"/>
+          </a:p>
+        </p:txBody>
+      </p:sp>
+      <p:sp>
+        <p:nvSpPr>
+          <p:cNvPr id="4" name="Text 1"/>
+          <p:cNvSpPr txBox="1"/>
+          <p:nvPr/>
+        </p:nvSpPr>
+        <p:spPr>
+          <a:xfrm>
+            <a:off x="777240" y="932688"/>
+            <a:ext cx="10515600" cy="868680"/>
+          </a:xfrm>
+          <a:prstGeom prst="rect">
+            <a:avLst/>
+          </a:prstGeom>
+          <a:noFill/>
+          <a:ln/>
+        </p:spPr>
+        <p:txBody>
+          <a:bodyPr wrap="square" lIns="0" tIns="0" rIns="0" bIns="0" rtlCol="0" anchor="t"/>
+          <a:lstStyle/>
+          <a:p>
+            <a:pPr indent="0" marL="0">
+              <a:lnSpc>
+                <a:spcPct val="98000"/>
+              </a:lnSpc>
+              <a:buNone/>
+            </a:pPr>
+            <a:r>
+              <a:rPr lang="en-US" sz="2900" spc="-50" kern="0" dirty="0">
+                <a:solidFill>
+                  <a:srgbClr val="2B2D30"/>
+                </a:solidFill>
+                <a:latin typeface="Montserrat ExtraBold" pitchFamily="34" charset="0"/>
+                <a:ea typeface="Montserrat ExtraBold" pitchFamily="34" charset="-122"/>
+                <a:cs typeface="Montserrat ExtraBold" pitchFamily="34" charset="-120"/>
+              </a:rPr>
+              <a:t>What this means for Stewart</a:t>
+            </a:r>
+            <a:endParaRPr lang="en-US" sz="2900" dirty="0"/>
+          </a:p>
+        </p:txBody>
+      </p:sp>
+      <p:sp>
+        <p:nvSpPr>
+          <p:cNvPr id="5" name="Shape 2"/>
+          <p:cNvSpPr/>
+          <p:nvPr/>
+        </p:nvSpPr>
+        <p:spPr>
+          <a:xfrm>
+            <a:off x="777240" y="1700784"/>
+            <a:ext cx="566928" cy="50292"/>
+          </a:xfrm>
+          <a:prstGeom prst="rect">
+            <a:avLst/>
+          </a:prstGeom>
+          <a:solidFill>
+            <a:srgbClr val="942838"/>
+          </a:solidFill>
+          <a:ln/>
+        </p:spPr>
+      </p:sp>
+      <p:sp>
+        <p:nvSpPr>
+          <p:cNvPr id="6" name="Shape 3"/>
+          <p:cNvSpPr/>
+          <p:nvPr/>
+        </p:nvSpPr>
+        <p:spPr>
+          <a:xfrm>
+            <a:off x="777240" y="6181344"/>
+            <a:ext cx="10637215" cy="10973"/>
+          </a:xfrm>
+          <a:prstGeom prst="rect">
+            <a:avLst/>
+          </a:prstGeom>
+          <a:solidFill>
+            <a:srgbClr val="E6E4E2"/>
+          </a:solidFill>
+          <a:ln/>
+        </p:spPr>
+      </p:sp>
+      <p:sp>
+        <p:nvSpPr>
+          <p:cNvPr id="7" name="Text 4"/>
+          <p:cNvSpPr txBox="1"/>
+          <p:nvPr/>
+        </p:nvSpPr>
+        <p:spPr>
+          <a:xfrm>
+            <a:off x="777240" y="6327648"/>
+            <a:ext cx="7315200" cy="201168"/>
+          </a:xfrm>
+          <a:prstGeom prst="rect">
+            <a:avLst/>
+          </a:prstGeom>
+          <a:noFill/>
+          <a:ln/>
+        </p:spPr>
+        <p:txBody>
+          <a:bodyPr wrap="square" lIns="0" tIns="0" rIns="0" bIns="0" rtlCol="0" anchor="t"/>
+          <a:lstStyle/>
+          <a:p>
+            <a:pPr indent="0" marL="0">
+              <a:buNone/>
+            </a:pPr>
+            <a:r>
+              <a:rPr lang="en-US" sz="850" spc="140" kern="0" dirty="0">
+                <a:solidFill>
+                  <a:srgbClr val="6E7175"/>
+                </a:solidFill>
+                <a:latin typeface="Montserrat SemiBold" pitchFamily="34" charset="0"/>
+                <a:ea typeface="Montserrat SemiBold" pitchFamily="34" charset="-122"/>
+                <a:cs typeface="Montserrat SemiBold" pitchFamily="34" charset="-120"/>
+              </a:rPr>
+              <a:t>SUMMARY</a:t>
+            </a:r>
+            <a:endParaRPr lang="en-US" sz="850" dirty="0"/>
+          </a:p>
+        </p:txBody>
+      </p:sp>
+      <p:sp>
+        <p:nvSpPr>
+          <p:cNvPr id="8" name="Text 5"/>
+          <p:cNvSpPr txBox="1"/>
+          <p:nvPr/>
+        </p:nvSpPr>
+        <p:spPr>
+          <a:xfrm>
+            <a:off x="10317175" y="6327648"/>
+            <a:ext cx="1097280" cy="201168"/>
+          </a:xfrm>
+          <a:prstGeom prst="rect">
+            <a:avLst/>
+          </a:prstGeom>
+          <a:noFill/>
+          <a:ln/>
+        </p:spPr>
+        <p:txBody>
+          <a:bodyPr wrap="square" lIns="0" tIns="0" rIns="0" bIns="0" rtlCol="0" anchor="t"/>
+          <a:lstStyle/>
+          <a:p>
+            <a:pPr algn="r" indent="0" marL="0">
+              <a:buNone/>
+            </a:pPr>
+            <a:r>
+              <a:rPr lang="en-US" sz="850" spc="140" kern="0" dirty="0">
+                <a:solidFill>
+                  <a:srgbClr val="6E7175"/>
+                </a:solidFill>
+                <a:latin typeface="Montserrat SemiBold" pitchFamily="34" charset="0"/>
+                <a:ea typeface="Montserrat SemiBold" pitchFamily="34" charset="-122"/>
+                <a:cs typeface="Montserrat SemiBold" pitchFamily="34" charset="-120"/>
+              </a:rPr>
+              <a:t>23</a:t>
+            </a:r>
+            <a:endParaRPr lang="en-US" sz="850" dirty="0"/>
+          </a:p>
+        </p:txBody>
+      </p:sp>
+      <p:sp>
+        <p:nvSpPr>
+          <p:cNvPr id="9" name="Text 6"/>
+          <p:cNvSpPr txBox="1"/>
+          <p:nvPr/>
+        </p:nvSpPr>
+        <p:spPr>
+          <a:xfrm>
+            <a:off x="777240" y="1956816"/>
+            <a:ext cx="10241280" cy="310896"/>
+          </a:xfrm>
+          <a:prstGeom prst="rect">
+            <a:avLst/>
+          </a:prstGeom>
+          <a:noFill/>
+          <a:ln/>
+        </p:spPr>
+        <p:txBody>
+          <a:bodyPr wrap="square" lIns="0" tIns="0" rIns="0" bIns="0" rtlCol="0" anchor="t"/>
+          <a:lstStyle/>
+          <a:p>
+            <a:pPr indent="0" marL="0">
+              <a:buNone/>
+            </a:pPr>
+            <a:r>
+              <a:rPr lang="en-US" sz="1400" dirty="0">
+                <a:solidFill>
+                  <a:srgbClr val="6E7175"/>
+                </a:solidFill>
+                <a:latin typeface="Montserrat Medium" pitchFamily="34" charset="0"/>
+                <a:ea typeface="Montserrat Medium" pitchFamily="34" charset="-122"/>
+                <a:cs typeface="Montserrat Medium" pitchFamily="34" charset="-120"/>
+              </a:rPr>
+              <a:t>Three gaps going in. Where each one stands now.</a:t>
+            </a:r>
+            <a:endParaRPr lang="en-US" sz="1400" dirty="0"/>
+          </a:p>
+        </p:txBody>
+      </p:sp>
+      <p:sp>
+        <p:nvSpPr>
+          <p:cNvPr id="10" name="Text 7"/>
+          <p:cNvSpPr txBox="1"/>
+          <p:nvPr/>
+        </p:nvSpPr>
+        <p:spPr>
+          <a:xfrm>
+            <a:off x="777240" y="2505456"/>
+            <a:ext cx="640080" cy="365760"/>
+          </a:xfrm>
+          <a:prstGeom prst="rect">
+            <a:avLst/>
+          </a:prstGeom>
+          <a:noFill/>
+          <a:ln/>
+        </p:spPr>
+        <p:txBody>
+          <a:bodyPr wrap="square" lIns="0" tIns="0" rIns="0" bIns="0" rtlCol="0" anchor="t"/>
+          <a:lstStyle/>
+          <a:p>
+            <a:pPr indent="0" marL="0">
+              <a:buNone/>
+            </a:pPr>
+            <a:r>
+              <a:rPr lang="en-US" sz="2400" spc="-40" kern="0" dirty="0">
+                <a:solidFill>
+                  <a:srgbClr val="DFBEC4"/>
+                </a:solidFill>
+                <a:latin typeface="Montserrat ExtraBold" pitchFamily="34" charset="0"/>
+                <a:ea typeface="Montserrat ExtraBold" pitchFamily="34" charset="-122"/>
+                <a:cs typeface="Montserrat ExtraBold" pitchFamily="34" charset="-120"/>
+              </a:rPr>
+              <a:t>01</a:t>
+            </a:r>
+            <a:endParaRPr lang="en-US" sz="2400" dirty="0"/>
+          </a:p>
+        </p:txBody>
+      </p:sp>
+      <p:sp>
+        <p:nvSpPr>
+          <p:cNvPr id="11" name="Text 8"/>
+          <p:cNvSpPr txBox="1"/>
+          <p:nvPr/>
+        </p:nvSpPr>
+        <p:spPr>
+          <a:xfrm>
+            <a:off x="1527048" y="2450592"/>
+            <a:ext cx="1828800" cy="182880"/>
+          </a:xfrm>
+          <a:prstGeom prst="rect">
+            <a:avLst/>
+          </a:prstGeom>
+          <a:noFill/>
+          <a:ln/>
+        </p:spPr>
+        <p:txBody>
+          <a:bodyPr wrap="square" lIns="0" tIns="0" rIns="0" bIns="0" rtlCol="0" anchor="t"/>
+          <a:lstStyle/>
+          <a:p>
+            <a:pPr indent="0" marL="0">
+              <a:buNone/>
+            </a:pPr>
+            <a:r>
+              <a:rPr lang="en-US" sz="850" spc="140" kern="0" dirty="0">
+                <a:solidFill>
+                  <a:srgbClr val="6E7175"/>
+                </a:solidFill>
+                <a:latin typeface="Montserrat SemiBold" pitchFamily="34" charset="0"/>
+                <a:ea typeface="Montserrat SemiBold" pitchFamily="34" charset="-122"/>
+                <a:cs typeface="Montserrat SemiBold" pitchFamily="34" charset="-120"/>
+              </a:rPr>
+              <a:t>WAS</a:t>
+            </a:r>
+            <a:endParaRPr lang="en-US" sz="850" dirty="0"/>
+          </a:p>
+        </p:txBody>
+      </p:sp>
+      <p:sp>
+        <p:nvSpPr>
+          <p:cNvPr id="12" name="Text 9"/>
+          <p:cNvSpPr txBox="1"/>
+          <p:nvPr/>
+        </p:nvSpPr>
+        <p:spPr>
+          <a:xfrm>
+            <a:off x="1527048" y="2670048"/>
+            <a:ext cx="3310128" cy="603504"/>
+          </a:xfrm>
+          <a:prstGeom prst="rect">
+            <a:avLst/>
+          </a:prstGeom>
+          <a:noFill/>
+          <a:ln/>
+        </p:spPr>
+        <p:txBody>
+          <a:bodyPr wrap="square" lIns="0" tIns="0" rIns="0" bIns="0" rtlCol="0" anchor="t"/>
+          <a:lstStyle/>
+          <a:p>
+            <a:pPr indent="0" marL="0">
+              <a:lnSpc>
+                <a:spcPct val="122000"/>
+              </a:lnSpc>
+              <a:buNone/>
+            </a:pPr>
+            <a:r>
+              <a:rPr lang="en-US" sz="1100" dirty="0">
+                <a:solidFill>
+                  <a:srgbClr val="43464A"/>
+                </a:solidFill>
+                <a:latin typeface="Montserrat" pitchFamily="34" charset="0"/>
+                <a:ea typeface="Montserrat" pitchFamily="34" charset="-122"/>
+                <a:cs typeface="Montserrat" pitchFamily="34" charset="-120"/>
+              </a:rPr>
+              <a:t>Machines could ship without their security baseline.</a:t>
+            </a:r>
+            <a:endParaRPr lang="en-US" sz="1100" dirty="0"/>
+          </a:p>
+        </p:txBody>
+      </p:sp>
+      <p:sp>
+        <p:nvSpPr>
+          <p:cNvPr id="13" name="Text 10"/>
+          <p:cNvSpPr txBox="1"/>
+          <p:nvPr/>
+        </p:nvSpPr>
+        <p:spPr>
+          <a:xfrm>
+            <a:off x="4882896" y="2615184"/>
+            <a:ext cx="365760" cy="420624"/>
+          </a:xfrm>
+          <a:prstGeom prst="rect">
+            <a:avLst/>
+          </a:prstGeom>
+          <a:noFill/>
+          <a:ln/>
+        </p:spPr>
+        <p:txBody>
+          <a:bodyPr wrap="square" lIns="0" tIns="0" rIns="0" bIns="0" rtlCol="0" anchor="ctr"/>
+          <a:lstStyle/>
+          <a:p>
+            <a:pPr algn="ctr" indent="0" marL="0">
+              <a:buNone/>
+            </a:pPr>
+            <a:r>
+              <a:rPr lang="en-US" sz="2600" b="1" dirty="0">
+                <a:solidFill>
+                  <a:srgbClr val="C9C6C4"/>
+                </a:solidFill>
+                <a:latin typeface="Montserrat" pitchFamily="34" charset="0"/>
+                <a:ea typeface="Montserrat" pitchFamily="34" charset="-122"/>
+                <a:cs typeface="Montserrat" pitchFamily="34" charset="-120"/>
+              </a:rPr>
+              <a:t>›</a:t>
+            </a:r>
+            <a:endParaRPr lang="en-US" sz="2600" dirty="0"/>
+          </a:p>
+        </p:txBody>
+      </p:sp>
+      <p:sp>
+        <p:nvSpPr>
+          <p:cNvPr id="14" name="Shape 11"/>
+          <p:cNvSpPr/>
+          <p:nvPr/>
+        </p:nvSpPr>
+        <p:spPr>
+          <a:xfrm>
+            <a:off x="5486400" y="2395728"/>
+            <a:ext cx="5928055" cy="914400"/>
+          </a:xfrm>
+          <a:prstGeom prst="roundRect">
+            <a:avLst>
+              <a:gd name="adj" fmla="val 5000"/>
+            </a:avLst>
+          </a:prstGeom>
+          <a:solidFill>
+            <a:srgbClr val="F6EEF0"/>
+          </a:solidFill>
+          <a:ln/>
+        </p:spPr>
+      </p:sp>
+      <p:sp>
+        <p:nvSpPr>
+          <p:cNvPr id="15" name="Shape 12"/>
+          <p:cNvSpPr/>
+          <p:nvPr/>
+        </p:nvSpPr>
+        <p:spPr>
+          <a:xfrm>
+            <a:off x="5486400" y="2395728"/>
+            <a:ext cx="45720" cy="914400"/>
+          </a:xfrm>
+          <a:prstGeom prst="rect">
+            <a:avLst/>
+          </a:prstGeom>
+          <a:solidFill>
+            <a:srgbClr val="942838"/>
+          </a:solidFill>
+          <a:ln/>
+        </p:spPr>
+      </p:sp>
+      <p:sp>
+        <p:nvSpPr>
+          <p:cNvPr id="16" name="Text 13"/>
+          <p:cNvSpPr txBox="1"/>
+          <p:nvPr/>
+        </p:nvSpPr>
+        <p:spPr>
+          <a:xfrm>
+            <a:off x="5724144" y="2523744"/>
+            <a:ext cx="1828800" cy="182880"/>
+          </a:xfrm>
+          <a:prstGeom prst="rect">
+            <a:avLst/>
+          </a:prstGeom>
+          <a:noFill/>
+          <a:ln/>
+        </p:spPr>
+        <p:txBody>
+          <a:bodyPr wrap="square" lIns="0" tIns="0" rIns="0" bIns="0" rtlCol="0" anchor="t"/>
+          <a:lstStyle/>
+          <a:p>
+            <a:pPr indent="0" marL="0">
+              <a:buNone/>
+            </a:pPr>
+            <a:r>
+              <a:rPr lang="en-US" sz="850" spc="140" kern="0" dirty="0">
+                <a:solidFill>
+                  <a:srgbClr val="942838"/>
+                </a:solidFill>
+                <a:latin typeface="Montserrat SemiBold" pitchFamily="34" charset="0"/>
+                <a:ea typeface="Montserrat SemiBold" pitchFamily="34" charset="-122"/>
+                <a:cs typeface="Montserrat SemiBold" pitchFamily="34" charset="-120"/>
+              </a:rPr>
+              <a:t>NOW</a:t>
+            </a:r>
+            <a:endParaRPr lang="en-US" sz="850" dirty="0"/>
+          </a:p>
+        </p:txBody>
+      </p:sp>
+      <p:sp>
+        <p:nvSpPr>
+          <p:cNvPr id="17" name="Text 14"/>
+          <p:cNvSpPr txBox="1"/>
+          <p:nvPr/>
+        </p:nvSpPr>
+        <p:spPr>
+          <a:xfrm>
+            <a:off x="5724144" y="2743200"/>
+            <a:ext cx="5452567" cy="548640"/>
+          </a:xfrm>
+          <a:prstGeom prst="rect">
+            <a:avLst/>
+          </a:prstGeom>
+          <a:noFill/>
+          <a:ln/>
+        </p:spPr>
+        <p:txBody>
+          <a:bodyPr wrap="square" lIns="0" tIns="0" rIns="0" bIns="0" rtlCol="0" anchor="t"/>
+          <a:lstStyle/>
+          <a:p>
+            <a:pPr indent="0" marL="0">
+              <a:lnSpc>
+                <a:spcPct val="122000"/>
+              </a:lnSpc>
+              <a:buNone/>
+            </a:pPr>
+            <a:r>
+              <a:rPr lang="en-US" sz="1150" dirty="0">
+                <a:solidFill>
+                  <a:srgbClr val="2B2D30"/>
+                </a:solidFill>
+                <a:latin typeface="Montserrat SemiBold" pitchFamily="34" charset="0"/>
+                <a:ea typeface="Montserrat SemiBold" pitchFamily="34" charset="-122"/>
+                <a:cs typeface="Montserrat SemiBold" pitchFamily="34" charset="-120"/>
+              </a:rPr>
+              <a:t>Nine required tools named, owners assigned, and a written framework staged for Q4 sign-off.</a:t>
+            </a:r>
+            <a:endParaRPr lang="en-US" sz="1150" dirty="0"/>
+          </a:p>
+        </p:txBody>
+      </p:sp>
+      <p:sp>
+        <p:nvSpPr>
+          <p:cNvPr id="18" name="Shape 15"/>
+          <p:cNvSpPr/>
+          <p:nvPr/>
+        </p:nvSpPr>
+        <p:spPr>
+          <a:xfrm>
+            <a:off x="777240" y="3419856"/>
+            <a:ext cx="10637215" cy="10973"/>
+          </a:xfrm>
+          <a:prstGeom prst="rect">
+            <a:avLst/>
+          </a:prstGeom>
+          <a:solidFill>
+            <a:srgbClr val="E6E4E2"/>
+          </a:solidFill>
+          <a:ln/>
+        </p:spPr>
+      </p:sp>
+      <p:sp>
+        <p:nvSpPr>
+          <p:cNvPr id="19" name="Text 16"/>
+          <p:cNvSpPr txBox="1"/>
+          <p:nvPr/>
+        </p:nvSpPr>
+        <p:spPr>
+          <a:xfrm>
+            <a:off x="777240" y="3602736"/>
+            <a:ext cx="640080" cy="365760"/>
+          </a:xfrm>
+          <a:prstGeom prst="rect">
+            <a:avLst/>
+          </a:prstGeom>
+          <a:noFill/>
+          <a:ln/>
+        </p:spPr>
+        <p:txBody>
+          <a:bodyPr wrap="square" lIns="0" tIns="0" rIns="0" bIns="0" rtlCol="0" anchor="t"/>
+          <a:lstStyle/>
+          <a:p>
+            <a:pPr indent="0" marL="0">
+              <a:buNone/>
+            </a:pPr>
+            <a:r>
+              <a:rPr lang="en-US" sz="2400" spc="-40" kern="0" dirty="0">
+                <a:solidFill>
+                  <a:srgbClr val="DFBEC4"/>
+                </a:solidFill>
+                <a:latin typeface="Montserrat ExtraBold" pitchFamily="34" charset="0"/>
+                <a:ea typeface="Montserrat ExtraBold" pitchFamily="34" charset="-122"/>
+                <a:cs typeface="Montserrat ExtraBold" pitchFamily="34" charset="-120"/>
+              </a:rPr>
+              <a:t>02</a:t>
+            </a:r>
+            <a:endParaRPr lang="en-US" sz="2400" dirty="0"/>
+          </a:p>
+        </p:txBody>
+      </p:sp>
+      <p:sp>
+        <p:nvSpPr>
+          <p:cNvPr id="20" name="Text 17"/>
+          <p:cNvSpPr txBox="1"/>
+          <p:nvPr/>
+        </p:nvSpPr>
+        <p:spPr>
+          <a:xfrm>
+            <a:off x="1527048" y="3547872"/>
+            <a:ext cx="1828800" cy="182880"/>
+          </a:xfrm>
+          <a:prstGeom prst="rect">
+            <a:avLst/>
+          </a:prstGeom>
+          <a:noFill/>
+          <a:ln/>
+        </p:spPr>
+        <p:txBody>
+          <a:bodyPr wrap="square" lIns="0" tIns="0" rIns="0" bIns="0" rtlCol="0" anchor="t"/>
+          <a:lstStyle/>
+          <a:p>
+            <a:pPr indent="0" marL="0">
+              <a:buNone/>
+            </a:pPr>
+            <a:r>
+              <a:rPr lang="en-US" sz="850" spc="140" kern="0" dirty="0">
+                <a:solidFill>
+                  <a:srgbClr val="6E7175"/>
+                </a:solidFill>
+                <a:latin typeface="Montserrat SemiBold" pitchFamily="34" charset="0"/>
+                <a:ea typeface="Montserrat SemiBold" pitchFamily="34" charset="-122"/>
+                <a:cs typeface="Montserrat SemiBold" pitchFamily="34" charset="-120"/>
+              </a:rPr>
+              <a:t>WAS</a:t>
+            </a:r>
+            <a:endParaRPr lang="en-US" sz="850" dirty="0"/>
+          </a:p>
+        </p:txBody>
+      </p:sp>
+      <p:sp>
+        <p:nvSpPr>
+          <p:cNvPr id="21" name="Text 18"/>
+          <p:cNvSpPr txBox="1"/>
+          <p:nvPr/>
+        </p:nvSpPr>
+        <p:spPr>
+          <a:xfrm>
+            <a:off x="1527048" y="3767328"/>
+            <a:ext cx="3310128" cy="603504"/>
+          </a:xfrm>
+          <a:prstGeom prst="rect">
+            <a:avLst/>
+          </a:prstGeom>
+          <a:noFill/>
+          <a:ln/>
+        </p:spPr>
+        <p:txBody>
+          <a:bodyPr wrap="square" lIns="0" tIns="0" rIns="0" bIns="0" rtlCol="0" anchor="t"/>
+          <a:lstStyle/>
+          <a:p>
+            <a:pPr indent="0" marL="0">
+              <a:lnSpc>
+                <a:spcPct val="122000"/>
+              </a:lnSpc>
+              <a:buNone/>
+            </a:pPr>
+            <a:r>
+              <a:rPr lang="en-US" sz="1100" dirty="0">
+                <a:solidFill>
+                  <a:srgbClr val="43464A"/>
+                </a:solidFill>
+                <a:latin typeface="Montserrat" pitchFamily="34" charset="0"/>
+                <a:ea typeface="Montserrat" pitchFamily="34" charset="-122"/>
+                <a:cs typeface="Montserrat" pitchFamily="34" charset="-120"/>
+              </a:rPr>
+              <a:t>Attackers hide malicious code inside the open-source packages we depend on.</a:t>
+            </a:r>
+            <a:endParaRPr lang="en-US" sz="1100" dirty="0"/>
+          </a:p>
+        </p:txBody>
+      </p:sp>
+      <p:sp>
+        <p:nvSpPr>
+          <p:cNvPr id="22" name="Text 19"/>
+          <p:cNvSpPr txBox="1"/>
+          <p:nvPr/>
+        </p:nvSpPr>
+        <p:spPr>
+          <a:xfrm>
+            <a:off x="4882896" y="3712464"/>
+            <a:ext cx="365760" cy="420624"/>
+          </a:xfrm>
+          <a:prstGeom prst="rect">
+            <a:avLst/>
+          </a:prstGeom>
+          <a:noFill/>
+          <a:ln/>
+        </p:spPr>
+        <p:txBody>
+          <a:bodyPr wrap="square" lIns="0" tIns="0" rIns="0" bIns="0" rtlCol="0" anchor="ctr"/>
+          <a:lstStyle/>
+          <a:p>
+            <a:pPr algn="ctr" indent="0" marL="0">
+              <a:buNone/>
+            </a:pPr>
+            <a:r>
+              <a:rPr lang="en-US" sz="2600" b="1" dirty="0">
+                <a:solidFill>
+                  <a:srgbClr val="C9C6C4"/>
+                </a:solidFill>
+                <a:latin typeface="Montserrat" pitchFamily="34" charset="0"/>
+                <a:ea typeface="Montserrat" pitchFamily="34" charset="-122"/>
+                <a:cs typeface="Montserrat" pitchFamily="34" charset="-120"/>
+              </a:rPr>
+              <a:t>›</a:t>
+            </a:r>
+            <a:endParaRPr lang="en-US" sz="2600" dirty="0"/>
+          </a:p>
+        </p:txBody>
+      </p:sp>
+      <p:sp>
+        <p:nvSpPr>
+          <p:cNvPr id="23" name="Shape 20"/>
+          <p:cNvSpPr/>
+          <p:nvPr/>
+        </p:nvSpPr>
+        <p:spPr>
+          <a:xfrm>
+            <a:off x="5486400" y="3493008"/>
+            <a:ext cx="5928055" cy="914400"/>
+          </a:xfrm>
+          <a:prstGeom prst="roundRect">
+            <a:avLst>
+              <a:gd name="adj" fmla="val 5000"/>
+            </a:avLst>
+          </a:prstGeom>
+          <a:solidFill>
+            <a:srgbClr val="F6EEF0"/>
+          </a:solidFill>
+          <a:ln/>
+        </p:spPr>
+      </p:sp>
+      <p:sp>
+        <p:nvSpPr>
+          <p:cNvPr id="24" name="Shape 21"/>
+          <p:cNvSpPr/>
+          <p:nvPr/>
+        </p:nvSpPr>
+        <p:spPr>
+          <a:xfrm>
+            <a:off x="5486400" y="3493008"/>
+            <a:ext cx="45720" cy="914400"/>
+          </a:xfrm>
+          <a:prstGeom prst="rect">
+            <a:avLst/>
+          </a:prstGeom>
+          <a:solidFill>
+            <a:srgbClr val="942838"/>
+          </a:solidFill>
+          <a:ln/>
+        </p:spPr>
+      </p:sp>
+      <p:sp>
+        <p:nvSpPr>
+          <p:cNvPr id="25" name="Text 22"/>
+          <p:cNvSpPr txBox="1"/>
+          <p:nvPr/>
+        </p:nvSpPr>
+        <p:spPr>
+          <a:xfrm>
+            <a:off x="5724144" y="3621024"/>
+            <a:ext cx="1828800" cy="182880"/>
+          </a:xfrm>
+          <a:prstGeom prst="rect">
+            <a:avLst/>
+          </a:prstGeom>
+          <a:noFill/>
+          <a:ln/>
+        </p:spPr>
+        <p:txBody>
+          <a:bodyPr wrap="square" lIns="0" tIns="0" rIns="0" bIns="0" rtlCol="0" anchor="t"/>
+          <a:lstStyle/>
+          <a:p>
+            <a:pPr indent="0" marL="0">
+              <a:buNone/>
+            </a:pPr>
+            <a:r>
+              <a:rPr lang="en-US" sz="850" spc="140" kern="0" dirty="0">
+                <a:solidFill>
+                  <a:srgbClr val="942838"/>
+                </a:solidFill>
+                <a:latin typeface="Montserrat SemiBold" pitchFamily="34" charset="0"/>
+                <a:ea typeface="Montserrat SemiBold" pitchFamily="34" charset="-122"/>
+                <a:cs typeface="Montserrat SemiBold" pitchFamily="34" charset="-120"/>
+              </a:rPr>
+              <a:t>NOW</a:t>
+            </a:r>
+            <a:endParaRPr lang="en-US" sz="850" dirty="0"/>
+          </a:p>
+        </p:txBody>
+      </p:sp>
+      <p:sp>
+        <p:nvSpPr>
+          <p:cNvPr id="26" name="Text 23"/>
+          <p:cNvSpPr txBox="1"/>
+          <p:nvPr/>
+        </p:nvSpPr>
+        <p:spPr>
+          <a:xfrm>
+            <a:off x="5724144" y="3840480"/>
+            <a:ext cx="5452567" cy="548640"/>
+          </a:xfrm>
+          <a:prstGeom prst="rect">
+            <a:avLst/>
+          </a:prstGeom>
+          <a:noFill/>
+          <a:ln/>
+        </p:spPr>
+        <p:txBody>
+          <a:bodyPr wrap="square" lIns="0" tIns="0" rIns="0" bIns="0" rtlCol="0" anchor="t"/>
+          <a:lstStyle/>
+          <a:p>
+            <a:pPr indent="0" marL="0">
+              <a:lnSpc>
+                <a:spcPct val="122000"/>
+              </a:lnSpc>
+              <a:buNone/>
+            </a:pPr>
+            <a:r>
+              <a:rPr lang="en-US" sz="1150" dirty="0">
+                <a:solidFill>
+                  <a:srgbClr val="2B2D30"/>
+                </a:solidFill>
+                <a:latin typeface="Montserrat SemiBold" pitchFamily="34" charset="0"/>
+                <a:ea typeface="Montserrat SemiBold" pitchFamily="34" charset="-122"/>
+                <a:cs typeface="Montserrat SemiBold" pitchFamily="34" charset="-120"/>
+              </a:rPr>
+              <a:t>AEGIS built and its safety rails tested — five stages, and 5,675 packages scanned in production by an earlier version.</a:t>
+            </a:r>
+            <a:endParaRPr lang="en-US" sz="1150" dirty="0"/>
+          </a:p>
+        </p:txBody>
+      </p:sp>
+      <p:sp>
+        <p:nvSpPr>
+          <p:cNvPr id="27" name="Shape 24"/>
+          <p:cNvSpPr/>
+          <p:nvPr/>
+        </p:nvSpPr>
+        <p:spPr>
+          <a:xfrm>
+            <a:off x="777240" y="4517136"/>
+            <a:ext cx="10637215" cy="10973"/>
+          </a:xfrm>
+          <a:prstGeom prst="rect">
+            <a:avLst/>
+          </a:prstGeom>
+          <a:solidFill>
+            <a:srgbClr val="E6E4E2"/>
+          </a:solidFill>
+          <a:ln/>
+        </p:spPr>
+      </p:sp>
+      <p:sp>
+        <p:nvSpPr>
+          <p:cNvPr id="28" name="Text 25"/>
+          <p:cNvSpPr txBox="1"/>
+          <p:nvPr/>
+        </p:nvSpPr>
+        <p:spPr>
+          <a:xfrm>
+            <a:off x="777240" y="4700016"/>
+            <a:ext cx="640080" cy="365760"/>
+          </a:xfrm>
+          <a:prstGeom prst="rect">
+            <a:avLst/>
+          </a:prstGeom>
+          <a:noFill/>
+          <a:ln/>
+        </p:spPr>
+        <p:txBody>
+          <a:bodyPr wrap="square" lIns="0" tIns="0" rIns="0" bIns="0" rtlCol="0" anchor="t"/>
+          <a:lstStyle/>
+          <a:p>
+            <a:pPr indent="0" marL="0">
+              <a:buNone/>
+            </a:pPr>
+            <a:r>
+              <a:rPr lang="en-US" sz="2400" spc="-40" kern="0" dirty="0">
+                <a:solidFill>
+                  <a:srgbClr val="DFBEC4"/>
+                </a:solidFill>
+                <a:latin typeface="Montserrat ExtraBold" pitchFamily="34" charset="0"/>
+                <a:ea typeface="Montserrat ExtraBold" pitchFamily="34" charset="-122"/>
+                <a:cs typeface="Montserrat ExtraBold" pitchFamily="34" charset="-120"/>
+              </a:rPr>
+              <a:t>03</a:t>
+            </a:r>
+            <a:endParaRPr lang="en-US" sz="2400" dirty="0"/>
+          </a:p>
+        </p:txBody>
+      </p:sp>
+      <p:sp>
+        <p:nvSpPr>
+          <p:cNvPr id="29" name="Text 26"/>
+          <p:cNvSpPr txBox="1"/>
+          <p:nvPr/>
+        </p:nvSpPr>
+        <p:spPr>
+          <a:xfrm>
+            <a:off x="1527048" y="4645152"/>
+            <a:ext cx="1828800" cy="182880"/>
+          </a:xfrm>
+          <a:prstGeom prst="rect">
+            <a:avLst/>
+          </a:prstGeom>
+          <a:noFill/>
+          <a:ln/>
+        </p:spPr>
+        <p:txBody>
+          <a:bodyPr wrap="square" lIns="0" tIns="0" rIns="0" bIns="0" rtlCol="0" anchor="t"/>
+          <a:lstStyle/>
+          <a:p>
+            <a:pPr indent="0" marL="0">
+              <a:buNone/>
+            </a:pPr>
+            <a:r>
+              <a:rPr lang="en-US" sz="850" spc="140" kern="0" dirty="0">
+                <a:solidFill>
+                  <a:srgbClr val="6E7175"/>
+                </a:solidFill>
+                <a:latin typeface="Montserrat SemiBold" pitchFamily="34" charset="0"/>
+                <a:ea typeface="Montserrat SemiBold" pitchFamily="34" charset="-122"/>
+                <a:cs typeface="Montserrat SemiBold" pitchFamily="34" charset="-120"/>
+              </a:rPr>
+              <a:t>WAS</a:t>
+            </a:r>
+            <a:endParaRPr lang="en-US" sz="850" dirty="0"/>
+          </a:p>
+        </p:txBody>
+      </p:sp>
+      <p:sp>
+        <p:nvSpPr>
+          <p:cNvPr id="30" name="Text 27"/>
+          <p:cNvSpPr txBox="1"/>
+          <p:nvPr/>
+        </p:nvSpPr>
+        <p:spPr>
+          <a:xfrm>
+            <a:off x="1527048" y="4864608"/>
+            <a:ext cx="3310128" cy="603504"/>
+          </a:xfrm>
+          <a:prstGeom prst="rect">
+            <a:avLst/>
+          </a:prstGeom>
+          <a:noFill/>
+          <a:ln/>
+        </p:spPr>
+        <p:txBody>
+          <a:bodyPr wrap="square" lIns="0" tIns="0" rIns="0" bIns="0" rtlCol="0" anchor="t"/>
+          <a:lstStyle/>
+          <a:p>
+            <a:pPr indent="0" marL="0">
+              <a:lnSpc>
+                <a:spcPct val="122000"/>
+              </a:lnSpc>
+              <a:buNone/>
+            </a:pPr>
+            <a:r>
+              <a:rPr lang="en-US" sz="1100" dirty="0">
+                <a:solidFill>
+                  <a:srgbClr val="43464A"/>
+                </a:solidFill>
+                <a:latin typeface="Montserrat" pitchFamily="34" charset="0"/>
+                <a:ea typeface="Montserrat" pitchFamily="34" charset="-122"/>
+                <a:cs typeface="Montserrat" pitchFamily="34" charset="-120"/>
+              </a:rPr>
+              <a:t>Matching every tracked flaw to its patch took about two days of analyst time.</a:t>
+            </a:r>
+            <a:endParaRPr lang="en-US" sz="1100" dirty="0"/>
+          </a:p>
+        </p:txBody>
+      </p:sp>
+      <p:sp>
+        <p:nvSpPr>
+          <p:cNvPr id="31" name="Text 28"/>
+          <p:cNvSpPr txBox="1"/>
+          <p:nvPr/>
+        </p:nvSpPr>
+        <p:spPr>
+          <a:xfrm>
+            <a:off x="4882896" y="4809744"/>
+            <a:ext cx="365760" cy="420624"/>
+          </a:xfrm>
+          <a:prstGeom prst="rect">
+            <a:avLst/>
+          </a:prstGeom>
+          <a:noFill/>
+          <a:ln/>
+        </p:spPr>
+        <p:txBody>
+          <a:bodyPr wrap="square" lIns="0" tIns="0" rIns="0" bIns="0" rtlCol="0" anchor="ctr"/>
+          <a:lstStyle/>
+          <a:p>
+            <a:pPr algn="ctr" indent="0" marL="0">
+              <a:buNone/>
+            </a:pPr>
+            <a:r>
+              <a:rPr lang="en-US" sz="2600" b="1" dirty="0">
+                <a:solidFill>
+                  <a:srgbClr val="C9C6C4"/>
+                </a:solidFill>
+                <a:latin typeface="Montserrat" pitchFamily="34" charset="0"/>
+                <a:ea typeface="Montserrat" pitchFamily="34" charset="-122"/>
+                <a:cs typeface="Montserrat" pitchFamily="34" charset="-120"/>
+              </a:rPr>
+              <a:t>›</a:t>
+            </a:r>
+            <a:endParaRPr lang="en-US" sz="2600" dirty="0"/>
+          </a:p>
+        </p:txBody>
+      </p:sp>
+      <p:sp>
+        <p:nvSpPr>
+          <p:cNvPr id="32" name="Shape 29"/>
+          <p:cNvSpPr/>
+          <p:nvPr/>
+        </p:nvSpPr>
+        <p:spPr>
+          <a:xfrm>
+            <a:off x="5486400" y="4590288"/>
+            <a:ext cx="5928055" cy="914400"/>
+          </a:xfrm>
+          <a:prstGeom prst="roundRect">
+            <a:avLst>
+              <a:gd name="adj" fmla="val 5000"/>
+            </a:avLst>
+          </a:prstGeom>
+          <a:solidFill>
+            <a:srgbClr val="F6EEF0"/>
+          </a:solidFill>
+          <a:ln/>
+        </p:spPr>
+      </p:sp>
+      <p:sp>
+        <p:nvSpPr>
+          <p:cNvPr id="33" name="Shape 30"/>
+          <p:cNvSpPr/>
+          <p:nvPr/>
+        </p:nvSpPr>
+        <p:spPr>
+          <a:xfrm>
+            <a:off x="5486400" y="4590288"/>
+            <a:ext cx="45720" cy="914400"/>
+          </a:xfrm>
+          <a:prstGeom prst="rect">
+            <a:avLst/>
+          </a:prstGeom>
+          <a:solidFill>
+            <a:srgbClr val="942838"/>
+          </a:solidFill>
+          <a:ln/>
+        </p:spPr>
+      </p:sp>
+      <p:sp>
+        <p:nvSpPr>
+          <p:cNvPr id="34" name="Text 31"/>
+          <p:cNvSpPr txBox="1"/>
+          <p:nvPr/>
+        </p:nvSpPr>
+        <p:spPr>
+          <a:xfrm>
+            <a:off x="5724144" y="4718304"/>
+            <a:ext cx="1828800" cy="182880"/>
+          </a:xfrm>
+          <a:prstGeom prst="rect">
+            <a:avLst/>
+          </a:prstGeom>
+          <a:noFill/>
+          <a:ln/>
+        </p:spPr>
+        <p:txBody>
+          <a:bodyPr wrap="square" lIns="0" tIns="0" rIns="0" bIns="0" rtlCol="0" anchor="t"/>
+          <a:lstStyle/>
+          <a:p>
+            <a:pPr indent="0" marL="0">
+              <a:buNone/>
+            </a:pPr>
+            <a:r>
+              <a:rPr lang="en-US" sz="850" spc="140" kern="0" dirty="0">
+                <a:solidFill>
+                  <a:srgbClr val="942838"/>
+                </a:solidFill>
+                <a:latin typeface="Montserrat SemiBold" pitchFamily="34" charset="0"/>
+                <a:ea typeface="Montserrat SemiBold" pitchFamily="34" charset="-122"/>
+                <a:cs typeface="Montserrat SemiBold" pitchFamily="34" charset="-120"/>
+              </a:rPr>
+              <a:t>NOW</a:t>
+            </a:r>
+            <a:endParaRPr lang="en-US" sz="850" dirty="0"/>
+          </a:p>
+        </p:txBody>
+      </p:sp>
+      <p:sp>
+        <p:nvSpPr>
+          <p:cNvPr id="35" name="Text 32"/>
+          <p:cNvSpPr txBox="1"/>
+          <p:nvPr/>
+        </p:nvSpPr>
+        <p:spPr>
+          <a:xfrm>
+            <a:off x="5724144" y="4937760"/>
+            <a:ext cx="5452567" cy="548640"/>
+          </a:xfrm>
+          <a:prstGeom prst="rect">
+            <a:avLst/>
+          </a:prstGeom>
+          <a:noFill/>
+          <a:ln/>
+        </p:spPr>
+        <p:txBody>
+          <a:bodyPr wrap="square" lIns="0" tIns="0" rIns="0" bIns="0" rtlCol="0" anchor="t"/>
+          <a:lstStyle/>
+          <a:p>
+            <a:pPr indent="0" marL="0">
+              <a:lnSpc>
+                <a:spcPct val="122000"/>
+              </a:lnSpc>
+              <a:buNone/>
+            </a:pPr>
+            <a:r>
+              <a:rPr lang="en-US" sz="1150" dirty="0">
+                <a:solidFill>
+                  <a:srgbClr val="2B2D30"/>
+                </a:solidFill>
+                <a:latin typeface="Montserrat SemiBold" pitchFamily="34" charset="0"/>
+                <a:ea typeface="Montserrat SemiBold" pitchFamily="34" charset="-122"/>
+                <a:cs typeface="Montserrat SemiBold" pitchFamily="34" charset="-120"/>
+              </a:rPr>
+              <a:t>117 matched in ~12 seconds, and 209 rows collapsed to 46 tickets with nothing skipped.</a:t>
+            </a:r>
+            <a:endParaRPr lang="en-US" sz="1150" dirty="0"/>
+          </a:p>
+        </p:txBody>
+      </p:sp>
+      <p:sp>
+        <p:nvSpPr>
+          <p:cNvPr id="36" name="Text 33"/>
+          <p:cNvSpPr txBox="1"/>
+          <p:nvPr/>
+        </p:nvSpPr>
+        <p:spPr>
+          <a:xfrm>
+            <a:off x="777240" y="5797296"/>
+            <a:ext cx="10637215" cy="310896"/>
+          </a:xfrm>
+          <a:prstGeom prst="rect">
+            <a:avLst/>
+          </a:prstGeom>
+          <a:noFill/>
+          <a:ln/>
+        </p:spPr>
+        <p:txBody>
+          <a:bodyPr wrap="square" lIns="0" tIns="0" rIns="0" bIns="0" rtlCol="0" anchor="t"/>
+          <a:lstStyle/>
+          <a:p>
+            <a:pPr indent="0" marL="0">
+              <a:buNone/>
+            </a:pPr>
+            <a:r>
+              <a:rPr lang="en-US" sz="1250" dirty="0">
+                <a:solidFill>
+                  <a:srgbClr val="942838"/>
+                </a:solidFill>
+                <a:latin typeface="Montserrat SemiBold" pitchFamily="34" charset="0"/>
+                <a:ea typeface="Montserrat SemiBold" pitchFamily="34" charset="-122"/>
+                <a:cs typeface="Montserrat SemiBold" pitchFamily="34" charset="-120"/>
+              </a:rPr>
+              <a:t>All three leave something behind: a written framework, a working scanner, and a script the team can run every cycle.</a:t>
+            </a:r>
+            <a:endParaRPr lang="en-US" sz="1250" dirty="0"/>
+          </a:p>
+        </p:txBody>
+      </p:sp>
+    </p:spTree>
+  </p:cSld>
+  <p:clrMapOvr>
+    <a:masterClrMapping/>
+  </p:clrMapOvr>
+</p:sld>
+</file>
+
+<file path=ppt/slides/slide24.xml><?xml version="1.0" encoding="utf-8"?>
+<p:sld xmlns:a="http://schemas.openxmlformats.org/drawingml/2006/main" xmlns:r="http://schemas.openxmlformats.org/officeDocument/2006/relationships" xmlns:p="http://schemas.openxmlformats.org/presentationml/2006/main">
+  <p:cSld name="Slide 24">
     <p:spTree>
       <p:nvGrpSpPr>
         <p:cNvPr id="1" name=""/>
@@ -16383,7 +17691,7 @@
                 <a:ea typeface="Montserrat SemiBold" pitchFamily="34" charset="-122"/>
                 <a:cs typeface="Montserrat SemiBold" pitchFamily="34" charset="-120"/>
               </a:rPr>
-              <a:t>23</a:t>
+              <a:t>24</a:t>
             </a:r>
             <a:endParaRPr lang="en-US" sz="850" dirty="0"/>
           </a:p>

</xml_diff>

<commit_message>
Put the summary slide on a red panel
It sat on white immediately before a full-red thank-you, so the deck ended on
a visual gear change rather than a build. Move it onto the same red panel and
invert the treatment used everywhere else: instead of red-tinted wells on
white, the 'now' column becomes solid white cards on red, making the outcome
the highest-contrast thing on the slide.

The two closing slides stay distinct — this one is a card grid, the thank-you
is an editorial list with no cards.
</commit_message>
<xml_diff>
--- a/out/Internship_Exit_Presentation_Stewart.pptx
+++ b/out/Internship_Exit_Presentation_Stewart.pptx
@@ -15753,13 +15753,6 @@
 <file path=ppt/slides/slide23.xml><?xml version="1.0" encoding="utf-8"?>
 <p:sld xmlns:a="http://schemas.openxmlformats.org/drawingml/2006/main" xmlns:r="http://schemas.openxmlformats.org/officeDocument/2006/relationships" xmlns:p="http://schemas.openxmlformats.org/presentationml/2006/main">
   <p:cSld name="Slide 23">
-    <p:bg>
-      <p:bgPr>
-        <a:solidFill>
-          <a:srgbClr val="FFFFFF"/>
-        </a:solidFill>
-      </p:bgPr>
-    </p:bg>
     <p:spTree>
       <p:nvGrpSpPr>
         <p:cNvPr id="1" name=""/>
@@ -15776,7 +15769,7 @@
       </p:grpSpPr>
       <p:pic>
         <p:nvPicPr>
-          <p:cNvPr id="2" name="Image 0" descr="/home/user/ai/assets/gen/logo-red.png">    </p:cNvPr>
+          <p:cNvPr id="2" name="Image 0" descr="/home/user/ai/assets/gen/panel-red.png">    </p:cNvPr>
           <p:cNvPicPr>
             <a:picLocks noChangeAspect="1"/>
           </p:cNvPicPr>
@@ -15790,6 +15783,54 @@
         </p:blipFill>
         <p:spPr>
           <a:xfrm>
+            <a:off x="0" y="0"/>
+            <a:ext cx="12191695" cy="6858000"/>
+          </a:xfrm>
+          <a:prstGeom prst="rect">
+            <a:avLst/>
+          </a:prstGeom>
+        </p:spPr>
+      </p:pic>
+      <p:pic>
+        <p:nvPicPr>
+          <p:cNvPr id="3" name="Image 1" descr="/home/user/ai/assets/gen/mark-slash-faint.png">    </p:cNvPr>
+          <p:cNvPicPr>
+            <a:picLocks noChangeAspect="1"/>
+          </p:cNvPicPr>
+          <p:nvPr/>
+        </p:nvPicPr>
+        <p:blipFill>
+          <a:blip r:embed="rId2"/>
+          <a:stretch>
+            <a:fillRect/>
+          </a:stretch>
+        </p:blipFill>
+        <p:spPr>
+          <a:xfrm>
+            <a:off x="8412480" y="-548640"/>
+            <a:ext cx="4937760" cy="4937760"/>
+          </a:xfrm>
+          <a:prstGeom prst="rect">
+            <a:avLst/>
+          </a:prstGeom>
+        </p:spPr>
+      </p:pic>
+      <p:pic>
+        <p:nvPicPr>
+          <p:cNvPr id="4" name="Image 2" descr="/home/user/ai/assets/gen/logo-white.png">    </p:cNvPr>
+          <p:cNvPicPr>
+            <a:picLocks noChangeAspect="1"/>
+          </p:cNvPicPr>
+          <p:nvPr/>
+        </p:nvPicPr>
+        <p:blipFill>
+          <a:blip r:embed="rId3"/>
+          <a:stretch>
+            <a:fillRect/>
+          </a:stretch>
+        </p:blipFill>
+        <p:spPr>
+          <a:xfrm>
             <a:off x="9768535" y="457200"/>
             <a:ext cx="1645920" cy="166053"/>
           </a:xfrm>
@@ -15800,14 +15841,14 @@
       </p:pic>
       <p:sp>
         <p:nvSpPr>
-          <p:cNvPr id="3" name="Text 0"/>
-          <p:cNvSpPr txBox="1"/>
-          <p:nvPr/>
-        </p:nvSpPr>
-        <p:spPr>
-          <a:xfrm>
-            <a:off x="777240" y="658368"/>
-            <a:ext cx="7315200" cy="219456"/>
+          <p:cNvPr id="5" name="Text 0"/>
+          <p:cNvSpPr txBox="1"/>
+          <p:nvPr/>
+        </p:nvSpPr>
+        <p:spPr>
+          <a:xfrm>
+            <a:off x="777240" y="676656"/>
+            <a:ext cx="5486400" cy="237744"/>
           </a:xfrm>
           <a:prstGeom prst="rect">
             <a:avLst/>
@@ -15825,7 +15866,7 @@
             <a:r>
               <a:rPr lang="en-US" sz="1000" spc="220" kern="0" dirty="0">
                 <a:solidFill>
-                  <a:srgbClr val="942838"/>
+                  <a:srgbClr val="E4C9CE"/>
                 </a:solidFill>
                 <a:latin typeface="Montserrat SemiBold" pitchFamily="34" charset="0"/>
                 <a:ea typeface="Montserrat SemiBold" pitchFamily="34" charset="-122"/>
@@ -15839,35 +15880,32 @@
       </p:sp>
       <p:sp>
         <p:nvSpPr>
-          <p:cNvPr id="4" name="Text 1"/>
-          <p:cNvSpPr txBox="1"/>
-          <p:nvPr/>
-        </p:nvSpPr>
-        <p:spPr>
-          <a:xfrm>
-            <a:off x="777240" y="932688"/>
-            <a:ext cx="10515600" cy="868680"/>
-          </a:xfrm>
-          <a:prstGeom prst="rect">
-            <a:avLst/>
-          </a:prstGeom>
-          <a:noFill/>
-          <a:ln/>
-        </p:spPr>
-        <p:txBody>
-          <a:bodyPr wrap="square" lIns="0" tIns="0" rIns="0" bIns="0" rtlCol="0" anchor="t"/>
-          <a:lstStyle/>
-          <a:p>
-            <a:pPr indent="0" marL="0">
-              <a:lnSpc>
-                <a:spcPct val="98000"/>
-              </a:lnSpc>
-              <a:buNone/>
-            </a:pPr>
-            <a:r>
-              <a:rPr lang="en-US" sz="2900" spc="-50" kern="0" dirty="0">
-                <a:solidFill>
-                  <a:srgbClr val="2B2D30"/>
+          <p:cNvPr id="6" name="Text 1"/>
+          <p:cNvSpPr txBox="1"/>
+          <p:nvPr/>
+        </p:nvSpPr>
+        <p:spPr>
+          <a:xfrm>
+            <a:off x="777240" y="969264"/>
+            <a:ext cx="9509760" cy="749808"/>
+          </a:xfrm>
+          <a:prstGeom prst="rect">
+            <a:avLst/>
+          </a:prstGeom>
+          <a:noFill/>
+          <a:ln/>
+        </p:spPr>
+        <p:txBody>
+          <a:bodyPr wrap="square" lIns="0" tIns="0" rIns="0" bIns="0" rtlCol="0" anchor="t"/>
+          <a:lstStyle/>
+          <a:p>
+            <a:pPr indent="0" marL="0">
+              <a:buNone/>
+            </a:pPr>
+            <a:r>
+              <a:rPr lang="en-US" sz="3600" spc="-90" kern="0" dirty="0">
+                <a:solidFill>
+                  <a:srgbClr val="FFFFFF"/>
                 </a:solidFill>
                 <a:latin typeface="Montserrat ExtraBold" pitchFamily="34" charset="0"/>
                 <a:ea typeface="Montserrat ExtraBold" pitchFamily="34" charset="-122"/>
@@ -15875,60 +15913,118 @@
               </a:rPr>
               <a:t>What this means for Stewart</a:t>
             </a:r>
-            <a:endParaRPr lang="en-US" sz="2900" dirty="0"/>
-          </a:p>
-        </p:txBody>
-      </p:sp>
-      <p:sp>
-        <p:nvSpPr>
-          <p:cNvPr id="5" name="Shape 2"/>
+            <a:endParaRPr lang="en-US" sz="3600" dirty="0"/>
+          </a:p>
+        </p:txBody>
+      </p:sp>
+      <p:sp>
+        <p:nvSpPr>
+          <p:cNvPr id="7" name="Shape 2"/>
           <p:cNvSpPr/>
           <p:nvPr/>
         </p:nvSpPr>
         <p:spPr>
           <a:xfrm>
-            <a:off x="777240" y="1700784"/>
-            <a:ext cx="566928" cy="50292"/>
+            <a:off x="777240" y="1810512"/>
+            <a:ext cx="640080" cy="50292"/>
           </a:xfrm>
           <a:prstGeom prst="rect">
             <a:avLst/>
           </a:prstGeom>
           <a:solidFill>
-            <a:srgbClr val="942838"/>
+            <a:srgbClr val="FFFFFF"/>
           </a:solidFill>
           <a:ln/>
         </p:spPr>
       </p:sp>
       <p:sp>
         <p:nvSpPr>
-          <p:cNvPr id="6" name="Shape 3"/>
-          <p:cNvSpPr/>
-          <p:nvPr/>
-        </p:nvSpPr>
-        <p:spPr>
-          <a:xfrm>
-            <a:off x="777240" y="6181344"/>
-            <a:ext cx="10637215" cy="10973"/>
-          </a:xfrm>
-          <a:prstGeom prst="rect">
-            <a:avLst/>
-          </a:prstGeom>
-          <a:solidFill>
-            <a:srgbClr val="E6E4E2"/>
-          </a:solidFill>
-          <a:ln/>
-        </p:spPr>
-      </p:sp>
-      <p:sp>
-        <p:nvSpPr>
-          <p:cNvPr id="7" name="Text 4"/>
-          <p:cNvSpPr txBox="1"/>
-          <p:nvPr/>
-        </p:nvSpPr>
-        <p:spPr>
-          <a:xfrm>
-            <a:off x="777240" y="6327648"/>
-            <a:ext cx="7315200" cy="201168"/>
+          <p:cNvPr id="8" name="Text 3"/>
+          <p:cNvSpPr txBox="1"/>
+          <p:nvPr/>
+        </p:nvSpPr>
+        <p:spPr>
+          <a:xfrm>
+            <a:off x="777240" y="2029968"/>
+            <a:ext cx="10241280" cy="310896"/>
+          </a:xfrm>
+          <a:prstGeom prst="rect">
+            <a:avLst/>
+          </a:prstGeom>
+          <a:noFill/>
+          <a:ln/>
+        </p:spPr>
+        <p:txBody>
+          <a:bodyPr wrap="square" lIns="0" tIns="0" rIns="0" bIns="0" rtlCol="0" anchor="t"/>
+          <a:lstStyle/>
+          <a:p>
+            <a:pPr indent="0" marL="0">
+              <a:buNone/>
+            </a:pPr>
+            <a:r>
+              <a:rPr lang="en-US" sz="1400" dirty="0">
+                <a:solidFill>
+                  <a:srgbClr val="DAB4BA"/>
+                </a:solidFill>
+                <a:latin typeface="Montserrat Medium" pitchFamily="34" charset="0"/>
+                <a:ea typeface="Montserrat Medium" pitchFamily="34" charset="-122"/>
+                <a:cs typeface="Montserrat Medium" pitchFamily="34" charset="-120"/>
+              </a:rPr>
+              <a:t>Three gaps going in. Where each one stands now.</a:t>
+            </a:r>
+            <a:endParaRPr lang="en-US" sz="1400" dirty="0"/>
+          </a:p>
+        </p:txBody>
+      </p:sp>
+      <p:sp>
+        <p:nvSpPr>
+          <p:cNvPr id="9" name="Text 4"/>
+          <p:cNvSpPr txBox="1"/>
+          <p:nvPr/>
+        </p:nvSpPr>
+        <p:spPr>
+          <a:xfrm>
+            <a:off x="777240" y="2542032"/>
+            <a:ext cx="640080" cy="365760"/>
+          </a:xfrm>
+          <a:prstGeom prst="rect">
+            <a:avLst/>
+          </a:prstGeom>
+          <a:noFill/>
+          <a:ln/>
+        </p:spPr>
+        <p:txBody>
+          <a:bodyPr wrap="square" lIns="0" tIns="0" rIns="0" bIns="0" rtlCol="0" anchor="t"/>
+          <a:lstStyle/>
+          <a:p>
+            <a:pPr indent="0" marL="0">
+              <a:buNone/>
+            </a:pPr>
+            <a:r>
+              <a:rPr lang="en-US" sz="2400" spc="-40" kern="0" dirty="0">
+                <a:solidFill>
+                  <a:srgbClr val="B9737E"/>
+                </a:solidFill>
+                <a:latin typeface="Montserrat ExtraBold" pitchFamily="34" charset="0"/>
+                <a:ea typeface="Montserrat ExtraBold" pitchFamily="34" charset="-122"/>
+                <a:cs typeface="Montserrat ExtraBold" pitchFamily="34" charset="-120"/>
+              </a:rPr>
+              <a:t>01</a:t>
+            </a:r>
+            <a:endParaRPr lang="en-US" sz="2400" dirty="0"/>
+          </a:p>
+        </p:txBody>
+      </p:sp>
+      <p:sp>
+        <p:nvSpPr>
+          <p:cNvPr id="10" name="Text 5"/>
+          <p:cNvSpPr txBox="1"/>
+          <p:nvPr/>
+        </p:nvSpPr>
+        <p:spPr>
+          <a:xfrm>
+            <a:off x="1527048" y="2487168"/>
+            <a:ext cx="1828800" cy="182880"/>
           </a:xfrm>
           <a:prstGeom prst="rect">
             <a:avLst/>
@@ -15946,13 +16042,13 @@
             <a:r>
               <a:rPr lang="en-US" sz="850" spc="140" kern="0" dirty="0">
                 <a:solidFill>
-                  <a:srgbClr val="6E7175"/>
+                  <a:srgbClr val="CA949C"/>
                 </a:solidFill>
                 <a:latin typeface="Montserrat SemiBold" pitchFamily="34" charset="0"/>
                 <a:ea typeface="Montserrat SemiBold" pitchFamily="34" charset="-122"/>
                 <a:cs typeface="Montserrat SemiBold" pitchFamily="34" charset="-120"/>
               </a:rPr>
-              <a:t>SUMMARY</a:t>
+              <a:t>WAS</a:t>
             </a:r>
             <a:endParaRPr lang="en-US" sz="850" dirty="0"/>
           </a:p>
@@ -15960,169 +16056,13 @@
       </p:sp>
       <p:sp>
         <p:nvSpPr>
-          <p:cNvPr id="8" name="Text 5"/>
-          <p:cNvSpPr txBox="1"/>
-          <p:nvPr/>
-        </p:nvSpPr>
-        <p:spPr>
-          <a:xfrm>
-            <a:off x="10317175" y="6327648"/>
-            <a:ext cx="1097280" cy="201168"/>
-          </a:xfrm>
-          <a:prstGeom prst="rect">
-            <a:avLst/>
-          </a:prstGeom>
-          <a:noFill/>
-          <a:ln/>
-        </p:spPr>
-        <p:txBody>
-          <a:bodyPr wrap="square" lIns="0" tIns="0" rIns="0" bIns="0" rtlCol="0" anchor="t"/>
-          <a:lstStyle/>
-          <a:p>
-            <a:pPr algn="r" indent="0" marL="0">
-              <a:buNone/>
-            </a:pPr>
-            <a:r>
-              <a:rPr lang="en-US" sz="850" spc="140" kern="0" dirty="0">
-                <a:solidFill>
-                  <a:srgbClr val="6E7175"/>
-                </a:solidFill>
-                <a:latin typeface="Montserrat SemiBold" pitchFamily="34" charset="0"/>
-                <a:ea typeface="Montserrat SemiBold" pitchFamily="34" charset="-122"/>
-                <a:cs typeface="Montserrat SemiBold" pitchFamily="34" charset="-120"/>
-              </a:rPr>
-              <a:t>23</a:t>
-            </a:r>
-            <a:endParaRPr lang="en-US" sz="850" dirty="0"/>
-          </a:p>
-        </p:txBody>
-      </p:sp>
-      <p:sp>
-        <p:nvSpPr>
-          <p:cNvPr id="9" name="Text 6"/>
-          <p:cNvSpPr txBox="1"/>
-          <p:nvPr/>
-        </p:nvSpPr>
-        <p:spPr>
-          <a:xfrm>
-            <a:off x="777240" y="1956816"/>
-            <a:ext cx="10241280" cy="310896"/>
-          </a:xfrm>
-          <a:prstGeom prst="rect">
-            <a:avLst/>
-          </a:prstGeom>
-          <a:noFill/>
-          <a:ln/>
-        </p:spPr>
-        <p:txBody>
-          <a:bodyPr wrap="square" lIns="0" tIns="0" rIns="0" bIns="0" rtlCol="0" anchor="t"/>
-          <a:lstStyle/>
-          <a:p>
-            <a:pPr indent="0" marL="0">
-              <a:buNone/>
-            </a:pPr>
-            <a:r>
-              <a:rPr lang="en-US" sz="1400" dirty="0">
-                <a:solidFill>
-                  <a:srgbClr val="6E7175"/>
-                </a:solidFill>
-                <a:latin typeface="Montserrat Medium" pitchFamily="34" charset="0"/>
-                <a:ea typeface="Montserrat Medium" pitchFamily="34" charset="-122"/>
-                <a:cs typeface="Montserrat Medium" pitchFamily="34" charset="-120"/>
-              </a:rPr>
-              <a:t>Three gaps going in. Where each one stands now.</a:t>
-            </a:r>
-            <a:endParaRPr lang="en-US" sz="1400" dirty="0"/>
-          </a:p>
-        </p:txBody>
-      </p:sp>
-      <p:sp>
-        <p:nvSpPr>
-          <p:cNvPr id="10" name="Text 7"/>
-          <p:cNvSpPr txBox="1"/>
-          <p:nvPr/>
-        </p:nvSpPr>
-        <p:spPr>
-          <a:xfrm>
-            <a:off x="777240" y="2505456"/>
-            <a:ext cx="640080" cy="365760"/>
-          </a:xfrm>
-          <a:prstGeom prst="rect">
-            <a:avLst/>
-          </a:prstGeom>
-          <a:noFill/>
-          <a:ln/>
-        </p:spPr>
-        <p:txBody>
-          <a:bodyPr wrap="square" lIns="0" tIns="0" rIns="0" bIns="0" rtlCol="0" anchor="t"/>
-          <a:lstStyle/>
-          <a:p>
-            <a:pPr indent="0" marL="0">
-              <a:buNone/>
-            </a:pPr>
-            <a:r>
-              <a:rPr lang="en-US" sz="2400" spc="-40" kern="0" dirty="0">
-                <a:solidFill>
-                  <a:srgbClr val="DFBEC4"/>
-                </a:solidFill>
-                <a:latin typeface="Montserrat ExtraBold" pitchFamily="34" charset="0"/>
-                <a:ea typeface="Montserrat ExtraBold" pitchFamily="34" charset="-122"/>
-                <a:cs typeface="Montserrat ExtraBold" pitchFamily="34" charset="-120"/>
-              </a:rPr>
-              <a:t>01</a:t>
-            </a:r>
-            <a:endParaRPr lang="en-US" sz="2400" dirty="0"/>
-          </a:p>
-        </p:txBody>
-      </p:sp>
-      <p:sp>
-        <p:nvSpPr>
-          <p:cNvPr id="11" name="Text 8"/>
-          <p:cNvSpPr txBox="1"/>
-          <p:nvPr/>
-        </p:nvSpPr>
-        <p:spPr>
-          <a:xfrm>
-            <a:off x="1527048" y="2450592"/>
-            <a:ext cx="1828800" cy="182880"/>
-          </a:xfrm>
-          <a:prstGeom prst="rect">
-            <a:avLst/>
-          </a:prstGeom>
-          <a:noFill/>
-          <a:ln/>
-        </p:spPr>
-        <p:txBody>
-          <a:bodyPr wrap="square" lIns="0" tIns="0" rIns="0" bIns="0" rtlCol="0" anchor="t"/>
-          <a:lstStyle/>
-          <a:p>
-            <a:pPr indent="0" marL="0">
-              <a:buNone/>
-            </a:pPr>
-            <a:r>
-              <a:rPr lang="en-US" sz="850" spc="140" kern="0" dirty="0">
-                <a:solidFill>
-                  <a:srgbClr val="6E7175"/>
-                </a:solidFill>
-                <a:latin typeface="Montserrat SemiBold" pitchFamily="34" charset="0"/>
-                <a:ea typeface="Montserrat SemiBold" pitchFamily="34" charset="-122"/>
-                <a:cs typeface="Montserrat SemiBold" pitchFamily="34" charset="-120"/>
-              </a:rPr>
-              <a:t>WAS</a:t>
-            </a:r>
-            <a:endParaRPr lang="en-US" sz="850" dirty="0"/>
-          </a:p>
-        </p:txBody>
-      </p:sp>
-      <p:sp>
-        <p:nvSpPr>
-          <p:cNvPr id="12" name="Text 9"/>
-          <p:cNvSpPr txBox="1"/>
-          <p:nvPr/>
-        </p:nvSpPr>
-        <p:spPr>
-          <a:xfrm>
-            <a:off x="1527048" y="2670048"/>
+          <p:cNvPr id="11" name="Text 6"/>
+          <p:cNvSpPr txBox="1"/>
+          <p:nvPr/>
+        </p:nvSpPr>
+        <p:spPr>
+          <a:xfrm>
+            <a:off x="1527048" y="2706624"/>
             <a:ext cx="3310128" cy="603504"/>
           </a:xfrm>
           <a:prstGeom prst="rect">
@@ -16144,7 +16084,7 @@
             <a:r>
               <a:rPr lang="en-US" sz="1100" dirty="0">
                 <a:solidFill>
-                  <a:srgbClr val="43464A"/>
+                  <a:srgbClr val="DAB4BA"/>
                 </a:solidFill>
                 <a:latin typeface="Montserrat" pitchFamily="34" charset="0"/>
                 <a:ea typeface="Montserrat" pitchFamily="34" charset="-122"/>
@@ -16158,13 +16098,13 @@
       </p:sp>
       <p:sp>
         <p:nvSpPr>
-          <p:cNvPr id="13" name="Text 10"/>
-          <p:cNvSpPr txBox="1"/>
-          <p:nvPr/>
-        </p:nvSpPr>
-        <p:spPr>
-          <a:xfrm>
-            <a:off x="4882896" y="2615184"/>
+          <p:cNvPr id="12" name="Text 7"/>
+          <p:cNvSpPr txBox="1"/>
+          <p:nvPr/>
+        </p:nvSpPr>
+        <p:spPr>
+          <a:xfrm>
+            <a:off x="4882896" y="2651760"/>
             <a:ext cx="365760" cy="420624"/>
           </a:xfrm>
           <a:prstGeom prst="rect">
@@ -16183,7 +16123,7 @@
             <a:r>
               <a:rPr lang="en-US" sz="2600" b="1" dirty="0">
                 <a:solidFill>
-                  <a:srgbClr val="C9C6C4"/>
+                  <a:srgbClr val="CA949C"/>
                 </a:solidFill>
                 <a:latin typeface="Montserrat" pitchFamily="34" charset="0"/>
                 <a:ea typeface="Montserrat" pitchFamily="34" charset="-122"/>
@@ -16197,13 +16137,13 @@
       </p:sp>
       <p:sp>
         <p:nvSpPr>
-          <p:cNvPr id="14" name="Shape 11"/>
+          <p:cNvPr id="13" name="Shape 8"/>
           <p:cNvSpPr/>
           <p:nvPr/>
         </p:nvSpPr>
         <p:spPr>
           <a:xfrm>
-            <a:off x="5486400" y="2395728"/>
+            <a:off x="5486400" y="2432304"/>
             <a:ext cx="5928055" cy="914400"/>
           </a:xfrm>
           <a:prstGeom prst="roundRect">
@@ -16212,20 +16152,27 @@
             </a:avLst>
           </a:prstGeom>
           <a:solidFill>
-            <a:srgbClr val="F6EEF0"/>
+            <a:srgbClr val="FFFFFF"/>
           </a:solidFill>
           <a:ln/>
-        </p:spPr>
-      </p:sp>
-      <p:sp>
-        <p:nvSpPr>
-          <p:cNvPr id="15" name="Shape 12"/>
+          <a:effectLst>
+            <a:outerShdw sx="100000" sy="100000" kx="0" ky="0" algn="bl" rotWithShape="0" blurRad="2580640000" dist="645160000" dir="324000000000">
+              <a:srgbClr val="5D1923">
+                <a:alpha val="3400000000"/>
+              </a:srgbClr>
+            </a:outerShdw>
+          </a:effectLst>
+        </p:spPr>
+      </p:sp>
+      <p:sp>
+        <p:nvSpPr>
+          <p:cNvPr id="14" name="Shape 9"/>
           <p:cNvSpPr/>
           <p:nvPr/>
         </p:nvSpPr>
         <p:spPr>
           <a:xfrm>
-            <a:off x="5486400" y="2395728"/>
+            <a:off x="5486400" y="2432304"/>
             <a:ext cx="45720" cy="914400"/>
           </a:xfrm>
           <a:prstGeom prst="rect">
@@ -16239,13 +16186,13 @@
       </p:sp>
       <p:sp>
         <p:nvSpPr>
-          <p:cNvPr id="16" name="Text 13"/>
-          <p:cNvSpPr txBox="1"/>
-          <p:nvPr/>
-        </p:nvSpPr>
-        <p:spPr>
-          <a:xfrm>
-            <a:off x="5724144" y="2523744"/>
+          <p:cNvPr id="15" name="Text 10"/>
+          <p:cNvSpPr txBox="1"/>
+          <p:nvPr/>
+        </p:nvSpPr>
+        <p:spPr>
+          <a:xfrm>
+            <a:off x="5724144" y="2560320"/>
             <a:ext cx="1828800" cy="182880"/>
           </a:xfrm>
           <a:prstGeom prst="rect">
@@ -16278,13 +16225,13 @@
       </p:sp>
       <p:sp>
         <p:nvSpPr>
-          <p:cNvPr id="17" name="Text 14"/>
-          <p:cNvSpPr txBox="1"/>
-          <p:nvPr/>
-        </p:nvSpPr>
-        <p:spPr>
-          <a:xfrm>
-            <a:off x="5724144" y="2743200"/>
+          <p:cNvPr id="16" name="Text 11"/>
+          <p:cNvSpPr txBox="1"/>
+          <p:nvPr/>
+        </p:nvSpPr>
+        <p:spPr>
+          <a:xfrm>
+            <a:off x="5724144" y="2779776"/>
             <a:ext cx="5452567" cy="548640"/>
           </a:xfrm>
           <a:prstGeom prst="rect">
@@ -16320,33 +16267,13 @@
       </p:sp>
       <p:sp>
         <p:nvSpPr>
-          <p:cNvPr id="18" name="Shape 15"/>
-          <p:cNvSpPr/>
-          <p:nvPr/>
-        </p:nvSpPr>
-        <p:spPr>
-          <a:xfrm>
-            <a:off x="777240" y="3419856"/>
-            <a:ext cx="10637215" cy="10973"/>
-          </a:xfrm>
-          <a:prstGeom prst="rect">
-            <a:avLst/>
-          </a:prstGeom>
-          <a:solidFill>
-            <a:srgbClr val="E6E4E2"/>
-          </a:solidFill>
-          <a:ln/>
-        </p:spPr>
-      </p:sp>
-      <p:sp>
-        <p:nvSpPr>
-          <p:cNvPr id="19" name="Text 16"/>
-          <p:cNvSpPr txBox="1"/>
-          <p:nvPr/>
-        </p:nvSpPr>
-        <p:spPr>
-          <a:xfrm>
-            <a:off x="777240" y="3602736"/>
+          <p:cNvPr id="17" name="Text 12"/>
+          <p:cNvSpPr txBox="1"/>
+          <p:nvPr/>
+        </p:nvSpPr>
+        <p:spPr>
+          <a:xfrm>
+            <a:off x="777240" y="3621024"/>
             <a:ext cx="640080" cy="365760"/>
           </a:xfrm>
           <a:prstGeom prst="rect">
@@ -16365,7 +16292,7 @@
             <a:r>
               <a:rPr lang="en-US" sz="2400" spc="-40" kern="0" dirty="0">
                 <a:solidFill>
-                  <a:srgbClr val="DFBEC4"/>
+                  <a:srgbClr val="B9737E"/>
                 </a:solidFill>
                 <a:latin typeface="Montserrat ExtraBold" pitchFamily="34" charset="0"/>
                 <a:ea typeface="Montserrat ExtraBold" pitchFamily="34" charset="-122"/>
@@ -16379,13 +16306,13 @@
       </p:sp>
       <p:sp>
         <p:nvSpPr>
-          <p:cNvPr id="20" name="Text 17"/>
-          <p:cNvSpPr txBox="1"/>
-          <p:nvPr/>
-        </p:nvSpPr>
-        <p:spPr>
-          <a:xfrm>
-            <a:off x="1527048" y="3547872"/>
+          <p:cNvPr id="18" name="Text 13"/>
+          <p:cNvSpPr txBox="1"/>
+          <p:nvPr/>
+        </p:nvSpPr>
+        <p:spPr>
+          <a:xfrm>
+            <a:off x="1527048" y="3566160"/>
             <a:ext cx="1828800" cy="182880"/>
           </a:xfrm>
           <a:prstGeom prst="rect">
@@ -16404,7 +16331,7 @@
             <a:r>
               <a:rPr lang="en-US" sz="850" spc="140" kern="0" dirty="0">
                 <a:solidFill>
-                  <a:srgbClr val="6E7175"/>
+                  <a:srgbClr val="CA949C"/>
                 </a:solidFill>
                 <a:latin typeface="Montserrat SemiBold" pitchFamily="34" charset="0"/>
                 <a:ea typeface="Montserrat SemiBold" pitchFamily="34" charset="-122"/>
@@ -16418,13 +16345,13 @@
       </p:sp>
       <p:sp>
         <p:nvSpPr>
-          <p:cNvPr id="21" name="Text 18"/>
-          <p:cNvSpPr txBox="1"/>
-          <p:nvPr/>
-        </p:nvSpPr>
-        <p:spPr>
-          <a:xfrm>
-            <a:off x="1527048" y="3767328"/>
+          <p:cNvPr id="19" name="Text 14"/>
+          <p:cNvSpPr txBox="1"/>
+          <p:nvPr/>
+        </p:nvSpPr>
+        <p:spPr>
+          <a:xfrm>
+            <a:off x="1527048" y="3785616"/>
             <a:ext cx="3310128" cy="603504"/>
           </a:xfrm>
           <a:prstGeom prst="rect">
@@ -16446,7 +16373,7 @@
             <a:r>
               <a:rPr lang="en-US" sz="1100" dirty="0">
                 <a:solidFill>
-                  <a:srgbClr val="43464A"/>
+                  <a:srgbClr val="DAB4BA"/>
                 </a:solidFill>
                 <a:latin typeface="Montserrat" pitchFamily="34" charset="0"/>
                 <a:ea typeface="Montserrat" pitchFamily="34" charset="-122"/>
@@ -16460,13 +16387,13 @@
       </p:sp>
       <p:sp>
         <p:nvSpPr>
-          <p:cNvPr id="22" name="Text 19"/>
-          <p:cNvSpPr txBox="1"/>
-          <p:nvPr/>
-        </p:nvSpPr>
-        <p:spPr>
-          <a:xfrm>
-            <a:off x="4882896" y="3712464"/>
+          <p:cNvPr id="20" name="Text 15"/>
+          <p:cNvSpPr txBox="1"/>
+          <p:nvPr/>
+        </p:nvSpPr>
+        <p:spPr>
+          <a:xfrm>
+            <a:off x="4882896" y="3730752"/>
             <a:ext cx="365760" cy="420624"/>
           </a:xfrm>
           <a:prstGeom prst="rect">
@@ -16485,7 +16412,7 @@
             <a:r>
               <a:rPr lang="en-US" sz="2600" b="1" dirty="0">
                 <a:solidFill>
-                  <a:srgbClr val="C9C6C4"/>
+                  <a:srgbClr val="CA949C"/>
                 </a:solidFill>
                 <a:latin typeface="Montserrat" pitchFamily="34" charset="0"/>
                 <a:ea typeface="Montserrat" pitchFamily="34" charset="-122"/>
@@ -16499,13 +16426,13 @@
       </p:sp>
       <p:sp>
         <p:nvSpPr>
-          <p:cNvPr id="23" name="Shape 20"/>
+          <p:cNvPr id="21" name="Shape 16"/>
           <p:cNvSpPr/>
           <p:nvPr/>
         </p:nvSpPr>
         <p:spPr>
           <a:xfrm>
-            <a:off x="5486400" y="3493008"/>
+            <a:off x="5486400" y="3511296"/>
             <a:ext cx="5928055" cy="914400"/>
           </a:xfrm>
           <a:prstGeom prst="roundRect">
@@ -16514,20 +16441,27 @@
             </a:avLst>
           </a:prstGeom>
           <a:solidFill>
-            <a:srgbClr val="F6EEF0"/>
+            <a:srgbClr val="FFFFFF"/>
           </a:solidFill>
           <a:ln/>
-        </p:spPr>
-      </p:sp>
-      <p:sp>
-        <p:nvSpPr>
-          <p:cNvPr id="24" name="Shape 21"/>
+          <a:effectLst>
+            <a:outerShdw sx="100000" sy="100000" kx="0" ky="0" algn="bl" rotWithShape="0" blurRad="32774128000000" dist="8193532000000" dir="19440000000000000">
+              <a:srgbClr val="5D1923">
+                <a:alpha val="340000000000000"/>
+              </a:srgbClr>
+            </a:outerShdw>
+          </a:effectLst>
+        </p:spPr>
+      </p:sp>
+      <p:sp>
+        <p:nvSpPr>
+          <p:cNvPr id="22" name="Shape 17"/>
           <p:cNvSpPr/>
           <p:nvPr/>
         </p:nvSpPr>
         <p:spPr>
           <a:xfrm>
-            <a:off x="5486400" y="3493008"/>
+            <a:off x="5486400" y="3511296"/>
             <a:ext cx="45720" cy="914400"/>
           </a:xfrm>
           <a:prstGeom prst="rect">
@@ -16541,13 +16475,13 @@
       </p:sp>
       <p:sp>
         <p:nvSpPr>
-          <p:cNvPr id="25" name="Text 22"/>
-          <p:cNvSpPr txBox="1"/>
-          <p:nvPr/>
-        </p:nvSpPr>
-        <p:spPr>
-          <a:xfrm>
-            <a:off x="5724144" y="3621024"/>
+          <p:cNvPr id="23" name="Text 18"/>
+          <p:cNvSpPr txBox="1"/>
+          <p:nvPr/>
+        </p:nvSpPr>
+        <p:spPr>
+          <a:xfrm>
+            <a:off x="5724144" y="3639312"/>
             <a:ext cx="1828800" cy="182880"/>
           </a:xfrm>
           <a:prstGeom prst="rect">
@@ -16580,13 +16514,13 @@
       </p:sp>
       <p:sp>
         <p:nvSpPr>
-          <p:cNvPr id="26" name="Text 23"/>
-          <p:cNvSpPr txBox="1"/>
-          <p:nvPr/>
-        </p:nvSpPr>
-        <p:spPr>
-          <a:xfrm>
-            <a:off x="5724144" y="3840480"/>
+          <p:cNvPr id="24" name="Text 19"/>
+          <p:cNvSpPr txBox="1"/>
+          <p:nvPr/>
+        </p:nvSpPr>
+        <p:spPr>
+          <a:xfrm>
+            <a:off x="5724144" y="3858768"/>
             <a:ext cx="5452567" cy="548640"/>
           </a:xfrm>
           <a:prstGeom prst="rect">
@@ -16622,27 +16556,7 @@
       </p:sp>
       <p:sp>
         <p:nvSpPr>
-          <p:cNvPr id="27" name="Shape 24"/>
-          <p:cNvSpPr/>
-          <p:nvPr/>
-        </p:nvSpPr>
-        <p:spPr>
-          <a:xfrm>
-            <a:off x="777240" y="4517136"/>
-            <a:ext cx="10637215" cy="10973"/>
-          </a:xfrm>
-          <a:prstGeom prst="rect">
-            <a:avLst/>
-          </a:prstGeom>
-          <a:solidFill>
-            <a:srgbClr val="E6E4E2"/>
-          </a:solidFill>
-          <a:ln/>
-        </p:spPr>
-      </p:sp>
-      <p:sp>
-        <p:nvSpPr>
-          <p:cNvPr id="28" name="Text 25"/>
+          <p:cNvPr id="25" name="Text 20"/>
           <p:cNvSpPr txBox="1"/>
           <p:nvPr/>
         </p:nvSpPr>
@@ -16667,7 +16581,7 @@
             <a:r>
               <a:rPr lang="en-US" sz="2400" spc="-40" kern="0" dirty="0">
                 <a:solidFill>
-                  <a:srgbClr val="DFBEC4"/>
+                  <a:srgbClr val="B9737E"/>
                 </a:solidFill>
                 <a:latin typeface="Montserrat ExtraBold" pitchFamily="34" charset="0"/>
                 <a:ea typeface="Montserrat ExtraBold" pitchFamily="34" charset="-122"/>
@@ -16681,7 +16595,7 @@
       </p:sp>
       <p:sp>
         <p:nvSpPr>
-          <p:cNvPr id="29" name="Text 26"/>
+          <p:cNvPr id="26" name="Text 21"/>
           <p:cNvSpPr txBox="1"/>
           <p:nvPr/>
         </p:nvSpPr>
@@ -16706,7 +16620,7 @@
             <a:r>
               <a:rPr lang="en-US" sz="850" spc="140" kern="0" dirty="0">
                 <a:solidFill>
-                  <a:srgbClr val="6E7175"/>
+                  <a:srgbClr val="CA949C"/>
                 </a:solidFill>
                 <a:latin typeface="Montserrat SemiBold" pitchFamily="34" charset="0"/>
                 <a:ea typeface="Montserrat SemiBold" pitchFamily="34" charset="-122"/>
@@ -16720,7 +16634,7 @@
       </p:sp>
       <p:sp>
         <p:nvSpPr>
-          <p:cNvPr id="30" name="Text 27"/>
+          <p:cNvPr id="27" name="Text 22"/>
           <p:cNvSpPr txBox="1"/>
           <p:nvPr/>
         </p:nvSpPr>
@@ -16748,7 +16662,7 @@
             <a:r>
               <a:rPr lang="en-US" sz="1100" dirty="0">
                 <a:solidFill>
-                  <a:srgbClr val="43464A"/>
+                  <a:srgbClr val="DAB4BA"/>
                 </a:solidFill>
                 <a:latin typeface="Montserrat" pitchFamily="34" charset="0"/>
                 <a:ea typeface="Montserrat" pitchFamily="34" charset="-122"/>
@@ -16762,7 +16676,7 @@
       </p:sp>
       <p:sp>
         <p:nvSpPr>
-          <p:cNvPr id="31" name="Text 28"/>
+          <p:cNvPr id="28" name="Text 23"/>
           <p:cNvSpPr txBox="1"/>
           <p:nvPr/>
         </p:nvSpPr>
@@ -16787,7 +16701,7 @@
             <a:r>
               <a:rPr lang="en-US" sz="2600" b="1" dirty="0">
                 <a:solidFill>
-                  <a:srgbClr val="C9C6C4"/>
+                  <a:srgbClr val="CA949C"/>
                 </a:solidFill>
                 <a:latin typeface="Montserrat" pitchFamily="34" charset="0"/>
                 <a:ea typeface="Montserrat" pitchFamily="34" charset="-122"/>
@@ -16801,7 +16715,7 @@
       </p:sp>
       <p:sp>
         <p:nvSpPr>
-          <p:cNvPr id="32" name="Shape 29"/>
+          <p:cNvPr id="29" name="Shape 24"/>
           <p:cNvSpPr/>
           <p:nvPr/>
         </p:nvSpPr>
@@ -16816,14 +16730,21 @@
             </a:avLst>
           </a:prstGeom>
           <a:solidFill>
-            <a:srgbClr val="F6EEF0"/>
+            <a:srgbClr val="FFFFFF"/>
           </a:solidFill>
           <a:ln/>
-        </p:spPr>
-      </p:sp>
-      <p:sp>
-        <p:nvSpPr>
-          <p:cNvPr id="33" name="Shape 30"/>
+          <a:effectLst>
+            <a:outerShdw sx="100000" sy="100000" kx="0" ky="0" algn="bl" rotWithShape="0" blurRad="416231425600000000" dist="104057856400000000" dir="1.1664e+21">
+              <a:srgbClr val="5D1923">
+                <a:alpha val="34000000000000000000"/>
+              </a:srgbClr>
+            </a:outerShdw>
+          </a:effectLst>
+        </p:spPr>
+      </p:sp>
+      <p:sp>
+        <p:nvSpPr>
+          <p:cNvPr id="30" name="Shape 25"/>
           <p:cNvSpPr/>
           <p:nvPr/>
         </p:nvSpPr>
@@ -16843,7 +16764,7 @@
       </p:sp>
       <p:sp>
         <p:nvSpPr>
-          <p:cNvPr id="34" name="Text 31"/>
+          <p:cNvPr id="31" name="Text 26"/>
           <p:cNvSpPr txBox="1"/>
           <p:nvPr/>
         </p:nvSpPr>
@@ -16882,7 +16803,7 @@
       </p:sp>
       <p:sp>
         <p:nvSpPr>
-          <p:cNvPr id="35" name="Text 32"/>
+          <p:cNvPr id="32" name="Text 27"/>
           <p:cNvSpPr txBox="1"/>
           <p:nvPr/>
         </p:nvSpPr>
@@ -16924,13 +16845,13 @@
       </p:sp>
       <p:sp>
         <p:nvSpPr>
-          <p:cNvPr id="36" name="Text 33"/>
-          <p:cNvSpPr txBox="1"/>
-          <p:nvPr/>
-        </p:nvSpPr>
-        <p:spPr>
-          <a:xfrm>
-            <a:off x="777240" y="5797296"/>
+          <p:cNvPr id="33" name="Text 28"/>
+          <p:cNvSpPr txBox="1"/>
+          <p:nvPr/>
+        </p:nvSpPr>
+        <p:spPr>
+          <a:xfrm>
+            <a:off x="777240" y="5833872"/>
             <a:ext cx="10637215" cy="310896"/>
           </a:xfrm>
           <a:prstGeom prst="rect">
@@ -16947,9 +16868,9 @@
               <a:buNone/>
             </a:pPr>
             <a:r>
-              <a:rPr lang="en-US" sz="1250" dirty="0">
-                <a:solidFill>
-                  <a:srgbClr val="942838"/>
+              <a:rPr lang="en-US" sz="1300" dirty="0">
+                <a:solidFill>
+                  <a:srgbClr val="FFFFFF"/>
                 </a:solidFill>
                 <a:latin typeface="Montserrat SemiBold" pitchFamily="34" charset="0"/>
                 <a:ea typeface="Montserrat SemiBold" pitchFamily="34" charset="-122"/>
@@ -16957,7 +16878,85 @@
               </a:rPr>
               <a:t>All three leave something behind: a written framework, a working scanner, and a script the team can run every cycle.</a:t>
             </a:r>
-            <a:endParaRPr lang="en-US" sz="1250" dirty="0"/>
+            <a:endParaRPr lang="en-US" sz="1300" dirty="0"/>
+          </a:p>
+        </p:txBody>
+      </p:sp>
+      <p:sp>
+        <p:nvSpPr>
+          <p:cNvPr id="34" name="Text 29"/>
+          <p:cNvSpPr txBox="1"/>
+          <p:nvPr/>
+        </p:nvSpPr>
+        <p:spPr>
+          <a:xfrm>
+            <a:off x="777240" y="6327648"/>
+            <a:ext cx="7315200" cy="201168"/>
+          </a:xfrm>
+          <a:prstGeom prst="rect">
+            <a:avLst/>
+          </a:prstGeom>
+          <a:noFill/>
+          <a:ln/>
+        </p:spPr>
+        <p:txBody>
+          <a:bodyPr wrap="square" lIns="0" tIns="0" rIns="0" bIns="0" rtlCol="0" anchor="t"/>
+          <a:lstStyle/>
+          <a:p>
+            <a:pPr indent="0" marL="0">
+              <a:buNone/>
+            </a:pPr>
+            <a:r>
+              <a:rPr lang="en-US" sz="850" spc="140" kern="0" dirty="0">
+                <a:solidFill>
+                  <a:srgbClr val="E4C9CE"/>
+                </a:solidFill>
+                <a:latin typeface="Montserrat SemiBold" pitchFamily="34" charset="0"/>
+                <a:ea typeface="Montserrat SemiBold" pitchFamily="34" charset="-122"/>
+                <a:cs typeface="Montserrat SemiBold" pitchFamily="34" charset="-120"/>
+              </a:rPr>
+              <a:t>SUMMARY</a:t>
+            </a:r>
+            <a:endParaRPr lang="en-US" sz="850" dirty="0"/>
+          </a:p>
+        </p:txBody>
+      </p:sp>
+      <p:sp>
+        <p:nvSpPr>
+          <p:cNvPr id="35" name="Text 30"/>
+          <p:cNvSpPr txBox="1"/>
+          <p:nvPr/>
+        </p:nvSpPr>
+        <p:spPr>
+          <a:xfrm>
+            <a:off x="10317175" y="6327648"/>
+            <a:ext cx="1097280" cy="201168"/>
+          </a:xfrm>
+          <a:prstGeom prst="rect">
+            <a:avLst/>
+          </a:prstGeom>
+          <a:noFill/>
+          <a:ln/>
+        </p:spPr>
+        <p:txBody>
+          <a:bodyPr wrap="square" lIns="0" tIns="0" rIns="0" bIns="0" rtlCol="0" anchor="t"/>
+          <a:lstStyle/>
+          <a:p>
+            <a:pPr algn="r" indent="0" marL="0">
+              <a:buNone/>
+            </a:pPr>
+            <a:r>
+              <a:rPr lang="en-US" sz="850" spc="140" kern="0" dirty="0">
+                <a:solidFill>
+                  <a:srgbClr val="E4C9CE"/>
+                </a:solidFill>
+                <a:latin typeface="Montserrat SemiBold" pitchFamily="34" charset="0"/>
+                <a:ea typeface="Montserrat SemiBold" pitchFamily="34" charset="-122"/>
+                <a:cs typeface="Montserrat SemiBold" pitchFamily="34" charset="-120"/>
+              </a:rPr>
+              <a:t>23</a:t>
+            </a:r>
+            <a:endParaRPr lang="en-US" sz="850" dirty="0"/>
           </a:p>
         </p:txBody>
       </p:sp>

</xml_diff>